<commit_message>
Add Network monitor and migrate sampler implement in support.py
</commit_message>
<xml_diff>
--- a/Presentation/IoMT_IDS_Presentation.pptx
+++ b/Presentation/IoMT_IDS_Presentation.pptx
@@ -5,7 +5,7 @@
     <p:sldMasterId id="2147483648" r:id="rId1"/>
   </p:sldMasterIdLst>
   <p:notesMasterIdLst>
-    <p:notesMasterId r:id="rId14"/>
+    <p:notesMasterId r:id="rId13"/>
   </p:notesMasterIdLst>
   <p:sldIdLst>
     <p:sldId id="256" r:id="rId2"/>
@@ -15,11 +15,10 @@
     <p:sldId id="271" r:id="rId6"/>
     <p:sldId id="268" r:id="rId7"/>
     <p:sldId id="261" r:id="rId8"/>
-    <p:sldId id="262" r:id="rId9"/>
-    <p:sldId id="263" r:id="rId10"/>
-    <p:sldId id="264" r:id="rId11"/>
-    <p:sldId id="265" r:id="rId12"/>
-    <p:sldId id="266" r:id="rId13"/>
+    <p:sldId id="263" r:id="rId9"/>
+    <p:sldId id="264" r:id="rId10"/>
+    <p:sldId id="265" r:id="rId11"/>
+    <p:sldId id="266" r:id="rId12"/>
   </p:sldIdLst>
   <p:sldSz cx="9144000" cy="6858000" type="screen4x3"/>
   <p:notesSz cx="6858000" cy="9144000"/>
@@ -140,7 +139,7 @@
 <file path=ppt/revisionInfo.xml><?xml version="1.0" encoding="utf-8"?>
 <p1510:revInfo xmlns:a="http://schemas.openxmlformats.org/drawingml/2006/main" xmlns:r="http://schemas.openxmlformats.org/officeDocument/2006/relationships" xmlns:p1510="http://schemas.microsoft.com/office/powerpoint/2015/10/main">
   <p1510:revLst>
-    <p1510:client id="{7BF04AB4-6846-4849-A1B8-6A167A3B7532}" v="271" dt="2026-03-18T22:08:55.508"/>
+    <p1510:client id="{7BF04AB4-6846-4849-A1B8-6A167A3B7532}" v="395" dt="2026-03-19T15:25:41.810"/>
   </p1510:revLst>
 </p1510:revInfo>
 </file>
@@ -150,7 +149,7 @@
   <pc:docChgLst>
     <pc:chgData name="耀泉 马" userId="19e30af8d5659de2" providerId="LiveId" clId="{C3594856-CEDA-5129-B2AF-7962E3CA4CA3}"/>
     <pc:docChg chg="undo custSel addSld delSld modSld sldOrd">
-      <pc:chgData name="耀泉 马" userId="19e30af8d5659de2" providerId="LiveId" clId="{C3594856-CEDA-5129-B2AF-7962E3CA4CA3}" dt="2026-03-18T22:09:36.506" v="2891" actId="2696"/>
+      <pc:chgData name="耀泉 马" userId="19e30af8d5659de2" providerId="LiveId" clId="{C3594856-CEDA-5129-B2AF-7962E3CA4CA3}" dt="2026-03-19T15:43:19.766" v="3032" actId="20577"/>
       <pc:docMkLst>
         <pc:docMk/>
       </pc:docMkLst>
@@ -231,22 +230,6 @@
           <pc:docMk/>
           <pc:sldMk cId="0" sldId="257"/>
         </pc:sldMkLst>
-        <pc:spChg chg="mod">
-          <ac:chgData name="耀泉 马" userId="19e30af8d5659de2" providerId="LiveId" clId="{C3594856-CEDA-5129-B2AF-7962E3CA4CA3}" dt="2026-03-17T20:49:03.171" v="54" actId="26606"/>
-          <ac:spMkLst>
-            <pc:docMk/>
-            <pc:sldMk cId="0" sldId="257"/>
-            <ac:spMk id="2" creationId="{00000000-0000-0000-0000-000000000000}"/>
-          </ac:spMkLst>
-        </pc:spChg>
-        <pc:spChg chg="del">
-          <ac:chgData name="耀泉 马" userId="19e30af8d5659de2" providerId="LiveId" clId="{C3594856-CEDA-5129-B2AF-7962E3CA4CA3}" dt="2026-03-17T20:49:03.171" v="54" actId="26606"/>
-          <ac:spMkLst>
-            <pc:docMk/>
-            <pc:sldMk cId="0" sldId="257"/>
-            <ac:spMk id="3" creationId="{00000000-0000-0000-0000-000000000000}"/>
-          </ac:spMkLst>
-        </pc:spChg>
         <pc:spChg chg="add del mod">
           <ac:chgData name="耀泉 马" userId="19e30af8d5659de2" providerId="LiveId" clId="{C3594856-CEDA-5129-B2AF-7962E3CA4CA3}" dt="2026-03-18T19:28:19.056" v="1599" actId="478"/>
           <ac:spMkLst>
@@ -261,38 +244,6 @@
             <pc:docMk/>
             <pc:sldMk cId="0" sldId="257"/>
             <ac:spMk id="6" creationId="{624F9F52-2DCC-4B10-9313-D03274AF554E}"/>
-          </ac:spMkLst>
-        </pc:spChg>
-        <pc:spChg chg="add">
-          <ac:chgData name="耀泉 马" userId="19e30af8d5659de2" providerId="LiveId" clId="{C3594856-CEDA-5129-B2AF-7962E3CA4CA3}" dt="2026-03-17T20:49:03.171" v="54" actId="26606"/>
-          <ac:spMkLst>
-            <pc:docMk/>
-            <pc:sldMk cId="0" sldId="257"/>
-            <ac:spMk id="9" creationId="{BACC6370-2D7E-4714-9D71-7542949D7D5D}"/>
-          </ac:spMkLst>
-        </pc:spChg>
-        <pc:spChg chg="add">
-          <ac:chgData name="耀泉 马" userId="19e30af8d5659de2" providerId="LiveId" clId="{C3594856-CEDA-5129-B2AF-7962E3CA4CA3}" dt="2026-03-17T20:49:03.171" v="54" actId="26606"/>
-          <ac:spMkLst>
-            <pc:docMk/>
-            <pc:sldMk cId="0" sldId="257"/>
-            <ac:spMk id="11" creationId="{F68B3F68-107C-434F-AA38-110D5EA91B85}"/>
-          </ac:spMkLst>
-        </pc:spChg>
-        <pc:spChg chg="add">
-          <ac:chgData name="耀泉 马" userId="19e30af8d5659de2" providerId="LiveId" clId="{C3594856-CEDA-5129-B2AF-7962E3CA4CA3}" dt="2026-03-17T20:49:03.171" v="54" actId="26606"/>
-          <ac:spMkLst>
-            <pc:docMk/>
-            <pc:sldMk cId="0" sldId="257"/>
-            <ac:spMk id="13" creationId="{AAD0DBB9-1A4B-4391-81D4-CB19F9AB918A}"/>
-          </ac:spMkLst>
-        </pc:spChg>
-        <pc:spChg chg="add">
-          <ac:chgData name="耀泉 马" userId="19e30af8d5659de2" providerId="LiveId" clId="{C3594856-CEDA-5129-B2AF-7962E3CA4CA3}" dt="2026-03-17T20:49:03.171" v="54" actId="26606"/>
-          <ac:spMkLst>
-            <pc:docMk/>
-            <pc:sldMk cId="0" sldId="257"/>
-            <ac:spMk id="15" creationId="{063BBA22-50EA-4C4D-BE05-F1CE4E63AA56}"/>
           </ac:spMkLst>
         </pc:spChg>
         <pc:spChg chg="add mod">
@@ -406,14 +357,6 @@
             <ac:spMk id="2" creationId="{00000000-0000-0000-0000-000000000000}"/>
           </ac:spMkLst>
         </pc:spChg>
-        <pc:spChg chg="del">
-          <ac:chgData name="耀泉 马" userId="19e30af8d5659de2" providerId="LiveId" clId="{C3594856-CEDA-5129-B2AF-7962E3CA4CA3}" dt="2026-03-17T20:49:47.708" v="55" actId="26606"/>
-          <ac:spMkLst>
-            <pc:docMk/>
-            <pc:sldMk cId="0" sldId="258"/>
-            <ac:spMk id="3" creationId="{00000000-0000-0000-0000-000000000000}"/>
-          </ac:spMkLst>
-        </pc:spChg>
         <pc:spChg chg="add">
           <ac:chgData name="耀泉 马" userId="19e30af8d5659de2" providerId="LiveId" clId="{C3594856-CEDA-5129-B2AF-7962E3CA4CA3}" dt="2026-03-17T20:49:47.708" v="55" actId="26606"/>
           <ac:spMkLst>
@@ -472,7 +415,7 @@
         </pc:graphicFrameChg>
       </pc:sldChg>
       <pc:sldChg chg="addSp delSp modSp mod setBg">
-        <pc:chgData name="耀泉 马" userId="19e30af8d5659de2" providerId="LiveId" clId="{C3594856-CEDA-5129-B2AF-7962E3CA4CA3}" dt="2026-03-18T09:45:43.142" v="256" actId="20577"/>
+        <pc:chgData name="耀泉 马" userId="19e30af8d5659de2" providerId="LiveId" clId="{C3594856-CEDA-5129-B2AF-7962E3CA4CA3}" dt="2026-03-19T15:14:05.952" v="3011" actId="20577"/>
         <pc:sldMkLst>
           <pc:docMk/>
           <pc:sldMk cId="0" sldId="259"/>
@@ -485,14 +428,6 @@
             <ac:spMk id="2" creationId="{00000000-0000-0000-0000-000000000000}"/>
           </ac:spMkLst>
         </pc:spChg>
-        <pc:spChg chg="del">
-          <ac:chgData name="耀泉 马" userId="19e30af8d5659de2" providerId="LiveId" clId="{C3594856-CEDA-5129-B2AF-7962E3CA4CA3}" dt="2026-03-17T20:49:58.716" v="56" actId="26606"/>
-          <ac:spMkLst>
-            <pc:docMk/>
-            <pc:sldMk cId="0" sldId="259"/>
-            <ac:spMk id="3" creationId="{00000000-0000-0000-0000-000000000000}"/>
-          </ac:spMkLst>
-        </pc:spChg>
         <pc:spChg chg="add">
           <ac:chgData name="耀泉 马" userId="19e30af8d5659de2" providerId="LiveId" clId="{C3594856-CEDA-5129-B2AF-7962E3CA4CA3}" dt="2026-03-17T20:49:58.716" v="56" actId="26606"/>
           <ac:spMkLst>
@@ -542,7 +477,7 @@
           </ac:spMkLst>
         </pc:spChg>
         <pc:graphicFrameChg chg="add mod">
-          <ac:chgData name="耀泉 马" userId="19e30af8d5659de2" providerId="LiveId" clId="{C3594856-CEDA-5129-B2AF-7962E3CA4CA3}" dt="2026-03-18T09:45:43.142" v="256" actId="20577"/>
+          <ac:chgData name="耀泉 马" userId="19e30af8d5659de2" providerId="LiveId" clId="{C3594856-CEDA-5129-B2AF-7962E3CA4CA3}" dt="2026-03-19T15:14:05.952" v="3011" actId="20577"/>
           <ac:graphicFrameMkLst>
             <pc:docMk/>
             <pc:sldMk cId="0" sldId="259"/>
@@ -734,13 +669,13 @@
         </pc:picChg>
       </pc:sldChg>
       <pc:sldChg chg="addSp delSp modSp mod ord">
-        <pc:chgData name="耀泉 马" userId="19e30af8d5659de2" providerId="LiveId" clId="{C3594856-CEDA-5129-B2AF-7962E3CA4CA3}" dt="2026-03-18T22:09:26.524" v="2890" actId="1076"/>
+        <pc:chgData name="耀泉 马" userId="19e30af8d5659de2" providerId="LiveId" clId="{C3594856-CEDA-5129-B2AF-7962E3CA4CA3}" dt="2026-03-19T15:43:19.766" v="3032" actId="20577"/>
         <pc:sldMkLst>
           <pc:docMk/>
           <pc:sldMk cId="0" sldId="261"/>
         </pc:sldMkLst>
         <pc:spChg chg="mod">
-          <ac:chgData name="耀泉 马" userId="19e30af8d5659de2" providerId="LiveId" clId="{C3594856-CEDA-5129-B2AF-7962E3CA4CA3}" dt="2026-03-18T22:09:26.524" v="2890" actId="1076"/>
+          <ac:chgData name="耀泉 马" userId="19e30af8d5659de2" providerId="LiveId" clId="{C3594856-CEDA-5129-B2AF-7962E3CA4CA3}" dt="2026-03-19T15:43:19.766" v="3032" actId="20577"/>
           <ac:spMkLst>
             <pc:docMk/>
             <pc:sldMk cId="0" sldId="261"/>
@@ -780,17 +715,39 @@
           </ac:picMkLst>
         </pc:picChg>
       </pc:sldChg>
-      <pc:sldChg chg="modSp mod">
-        <pc:chgData name="耀泉 马" userId="19e30af8d5659de2" providerId="LiveId" clId="{C3594856-CEDA-5129-B2AF-7962E3CA4CA3}" dt="2026-03-17T20:52:22.569" v="130" actId="20577"/>
+      <pc:sldChg chg="modSp del mod">
+        <pc:chgData name="耀泉 马" userId="19e30af8d5659de2" providerId="LiveId" clId="{C3594856-CEDA-5129-B2AF-7962E3CA4CA3}" dt="2026-03-19T15:19:45.238" v="3014" actId="2696"/>
         <pc:sldMkLst>
           <pc:docMk/>
           <pc:sldMk cId="0" sldId="262"/>
         </pc:sldMkLst>
+      </pc:sldChg>
+      <pc:sldChg chg="modSp mod">
+        <pc:chgData name="耀泉 马" userId="19e30af8d5659de2" providerId="LiveId" clId="{C3594856-CEDA-5129-B2AF-7962E3CA4CA3}" dt="2026-03-19T15:16:36.398" v="3013" actId="20577"/>
+        <pc:sldMkLst>
+          <pc:docMk/>
+          <pc:sldMk cId="0" sldId="263"/>
+        </pc:sldMkLst>
         <pc:spChg chg="mod">
-          <ac:chgData name="耀泉 马" userId="19e30af8d5659de2" providerId="LiveId" clId="{C3594856-CEDA-5129-B2AF-7962E3CA4CA3}" dt="2026-03-17T20:52:22.569" v="130" actId="20577"/>
+          <ac:chgData name="耀泉 马" userId="19e30af8d5659de2" providerId="LiveId" clId="{C3594856-CEDA-5129-B2AF-7962E3CA4CA3}" dt="2026-03-19T15:16:36.398" v="3013" actId="20577"/>
           <ac:spMkLst>
             <pc:docMk/>
-            <pc:sldMk cId="0" sldId="262"/>
+            <pc:sldMk cId="0" sldId="263"/>
+            <ac:spMk id="3" creationId="{00000000-0000-0000-0000-000000000000}"/>
+          </ac:spMkLst>
+        </pc:spChg>
+      </pc:sldChg>
+      <pc:sldChg chg="modSp mod">
+        <pc:chgData name="耀泉 马" userId="19e30af8d5659de2" providerId="LiveId" clId="{C3594856-CEDA-5129-B2AF-7962E3CA4CA3}" dt="2026-03-19T15:25:41.900" v="3029" actId="27636"/>
+        <pc:sldMkLst>
+          <pc:docMk/>
+          <pc:sldMk cId="0" sldId="265"/>
+        </pc:sldMkLst>
+        <pc:spChg chg="mod">
+          <ac:chgData name="耀泉 马" userId="19e30af8d5659de2" providerId="LiveId" clId="{C3594856-CEDA-5129-B2AF-7962E3CA4CA3}" dt="2026-03-19T15:25:41.900" v="3029" actId="27636"/>
+          <ac:spMkLst>
+            <pc:docMk/>
+            <pc:sldMk cId="0" sldId="265"/>
             <ac:spMk id="3" creationId="{00000000-0000-0000-0000-000000000000}"/>
           </ac:spMkLst>
         </pc:spChg>
@@ -7090,7 +7047,7 @@
         <a:lstStyle/>
         <a:p>
           <a:r>
-            <a:rPr lang="en-US"/>
+            <a:rPr lang="en-US" dirty="0"/>
             <a:t>IDS types: Signature-based, ML/DL-based</a:t>
           </a:r>
         </a:p>
@@ -7126,7 +7083,7 @@
         <a:lstStyle/>
         <a:p>
           <a:r>
-            <a:rPr lang="en-US"/>
+            <a:rPr lang="en-US" dirty="0"/>
             <a:t>Deployment: Edge-based, Cloud-based, Hybrid</a:t>
           </a:r>
         </a:p>
@@ -7162,7 +7119,7 @@
         <a:lstStyle/>
         <a:p>
           <a:r>
-            <a:rPr lang="en-US"/>
+            <a:rPr lang="en-US" dirty="0"/>
             <a:t>Existing methods: Lightweight ML, Federated Learning, Split Learning</a:t>
           </a:r>
         </a:p>
@@ -7198,8 +7155,16 @@
         <a:lstStyle/>
         <a:p>
           <a:r>
-            <a:rPr lang="en-US"/>
-            <a:t>Limitations: Accuracy vs Deployability trade-off</a:t>
+            <a:rPr lang="en-US" dirty="0"/>
+            <a:t>Limitations: Accuracy vs </a:t>
+          </a:r>
+          <a:r>
+            <a:rPr lang="en-US" dirty="0" err="1"/>
+            <a:t>Deployability</a:t>
+          </a:r>
+          <a:r>
+            <a:rPr lang="en-US" dirty="0"/>
+            <a:t> trade-off</a:t>
           </a:r>
         </a:p>
       </dgm:t>
@@ -7370,9 +7335,14 @@
         <a:lstStyle/>
         <a:p>
           <a:r>
-            <a:rPr lang="en-US" dirty="0"/>
-            <a:t>Existing IDS: too simple or too complex</a:t>
+            <a:rPr lang="en-GB" dirty="0"/>
+            <a:t>Edge IDS: </a:t>
           </a:r>
+          <a:r>
+            <a:rPr lang="en-GB" b="1" dirty="0"/>
+            <a:t>simple ML and Federated Learning</a:t>
+          </a:r>
+          <a:endParaRPr lang="en-US" dirty="0"/>
         </a:p>
       </dgm:t>
     </dgm:pt>
@@ -7445,6 +7415,19 @@
             <a:rPr lang="en-US" dirty="0"/>
             <a:t>Evaluate Feature Selection, PCA, Autoencoder</a:t>
           </a:r>
+          <a:r>
+            <a:rPr lang="en-US" altLang="zh-CN" dirty="0"/>
+            <a:t>,</a:t>
+          </a:r>
+          <a:r>
+            <a:rPr lang="zh-CN" altLang="en-US" dirty="0"/>
+            <a:t> </a:t>
+          </a:r>
+          <a:r>
+            <a:rPr lang="en-US" altLang="zh-CN" dirty="0" err="1"/>
+            <a:t>ResNext</a:t>
+          </a:r>
+          <a:endParaRPr lang="en-US" dirty="0"/>
         </a:p>
       </dgm:t>
     </dgm:pt>
@@ -8455,7 +8438,7 @@
             <a:buNone/>
           </a:pPr>
           <a:r>
-            <a:rPr lang="en-US" sz="2600" kern="1200"/>
+            <a:rPr lang="en-US" sz="2600" kern="1200" dirty="0"/>
             <a:t>IDS types: Signature-based, ML/DL-based</a:t>
           </a:r>
         </a:p>
@@ -8549,7 +8532,7 @@
             <a:buNone/>
           </a:pPr>
           <a:r>
-            <a:rPr lang="en-US" sz="2600" kern="1200"/>
+            <a:rPr lang="en-US" sz="2600" kern="1200" dirty="0"/>
             <a:t>Deployment: Edge-based, Cloud-based, Hybrid</a:t>
           </a:r>
         </a:p>
@@ -8643,7 +8626,7 @@
             <a:buNone/>
           </a:pPr>
           <a:r>
-            <a:rPr lang="en-US" sz="2600" kern="1200"/>
+            <a:rPr lang="en-US" sz="2600" kern="1200" dirty="0"/>
             <a:t>Existing methods: Lightweight ML, Federated Learning, Split Learning</a:t>
           </a:r>
         </a:p>
@@ -8737,8 +8720,16 @@
             <a:buNone/>
           </a:pPr>
           <a:r>
-            <a:rPr lang="en-US" sz="2600" kern="1200"/>
-            <a:t>Limitations: Accuracy vs Deployability trade-off</a:t>
+            <a:rPr lang="en-US" sz="2600" kern="1200" dirty="0"/>
+            <a:t>Limitations: Accuracy vs </a:t>
+          </a:r>
+          <a:r>
+            <a:rPr lang="en-US" sz="2600" kern="1200" dirty="0" err="1"/>
+            <a:t>Deployability</a:t>
+          </a:r>
+          <a:r>
+            <a:rPr lang="en-US" sz="2600" kern="1200" dirty="0"/>
+            <a:t> trade-off</a:t>
           </a:r>
         </a:p>
       </dsp:txBody>
@@ -9017,9 +9008,14 @@
             <a:buNone/>
           </a:pPr>
           <a:r>
-            <a:rPr lang="en-US" sz="3000" kern="1200" dirty="0"/>
-            <a:t>Existing IDS: too simple or too complex</a:t>
+            <a:rPr lang="en-GB" sz="3000" kern="1200" dirty="0"/>
+            <a:t>Edge IDS: </a:t>
           </a:r>
+          <a:r>
+            <a:rPr lang="en-GB" sz="3000" b="1" kern="1200" dirty="0"/>
+            <a:t>simple ML and Federated Learning</a:t>
+          </a:r>
+          <a:endParaRPr lang="en-US" sz="3000" kern="1200" dirty="0"/>
         </a:p>
       </dsp:txBody>
       <dsp:txXfrm>
@@ -9288,6 +9284,19 @@
             <a:rPr lang="en-US" sz="3000" kern="1200" dirty="0"/>
             <a:t>Evaluate Feature Selection, PCA, Autoencoder</a:t>
           </a:r>
+          <a:r>
+            <a:rPr lang="en-US" altLang="zh-CN" sz="3000" kern="1200" dirty="0"/>
+            <a:t>,</a:t>
+          </a:r>
+          <a:r>
+            <a:rPr lang="zh-CN" altLang="en-US" sz="3000" kern="1200" dirty="0"/>
+            <a:t> </a:t>
+          </a:r>
+          <a:r>
+            <a:rPr lang="en-US" altLang="zh-CN" sz="3000" kern="1200" dirty="0" err="1"/>
+            <a:t>ResNext</a:t>
+          </a:r>
+          <a:endParaRPr lang="en-US" sz="3000" kern="1200" dirty="0"/>
         </a:p>
       </dsp:txBody>
       <dsp:txXfrm>
@@ -13442,7 +13451,7 @@
           <a:p>
             <a:fld id="{26149304-4996-5048-AF8D-AE7FCF302DAE}" type="datetimeFigureOut">
               <a:rPr lang="en-US" smtClean="0"/>
-              <a:t>3/18/26</a:t>
+              <a:t>3/19/26</a:t>
             </a:fld>
             <a:endParaRPr lang="en-US"/>
           </a:p>
@@ -14057,7 +14066,7 @@
           <a:p>
             <a:fld id="{5BCAD085-E8A6-8845-BD4E-CB4CCA059FC4}" type="datetimeFigureOut">
               <a:rPr lang="en-US" smtClean="0"/>
-              <a:t>3/18/26</a:t>
+              <a:t>3/19/26</a:t>
             </a:fld>
             <a:endParaRPr lang="en-US"/>
           </a:p>
@@ -14225,7 +14234,7 @@
           <a:p>
             <a:fld id="{5BCAD085-E8A6-8845-BD4E-CB4CCA059FC4}" type="datetimeFigureOut">
               <a:rPr lang="en-US" smtClean="0"/>
-              <a:t>3/18/26</a:t>
+              <a:t>3/19/26</a:t>
             </a:fld>
             <a:endParaRPr lang="en-US"/>
           </a:p>
@@ -14403,7 +14412,7 @@
           <a:p>
             <a:fld id="{5BCAD085-E8A6-8845-BD4E-CB4CCA059FC4}" type="datetimeFigureOut">
               <a:rPr lang="en-US" smtClean="0"/>
-              <a:t>3/18/26</a:t>
+              <a:t>3/19/26</a:t>
             </a:fld>
             <a:endParaRPr lang="en-US"/>
           </a:p>
@@ -14571,7 +14580,7 @@
           <a:p>
             <a:fld id="{5BCAD085-E8A6-8845-BD4E-CB4CCA059FC4}" type="datetimeFigureOut">
               <a:rPr lang="en-US" smtClean="0"/>
-              <a:t>3/18/26</a:t>
+              <a:t>3/19/26</a:t>
             </a:fld>
             <a:endParaRPr lang="en-US"/>
           </a:p>
@@ -14816,7 +14825,7 @@
           <a:p>
             <a:fld id="{5BCAD085-E8A6-8845-BD4E-CB4CCA059FC4}" type="datetimeFigureOut">
               <a:rPr lang="en-US" smtClean="0"/>
-              <a:t>3/18/26</a:t>
+              <a:t>3/19/26</a:t>
             </a:fld>
             <a:endParaRPr lang="en-US"/>
           </a:p>
@@ -15101,7 +15110,7 @@
           <a:p>
             <a:fld id="{5BCAD085-E8A6-8845-BD4E-CB4CCA059FC4}" type="datetimeFigureOut">
               <a:rPr lang="en-US" smtClean="0"/>
-              <a:t>3/18/26</a:t>
+              <a:t>3/19/26</a:t>
             </a:fld>
             <a:endParaRPr lang="en-US"/>
           </a:p>
@@ -15520,7 +15529,7 @@
           <a:p>
             <a:fld id="{5BCAD085-E8A6-8845-BD4E-CB4CCA059FC4}" type="datetimeFigureOut">
               <a:rPr lang="en-US" smtClean="0"/>
-              <a:t>3/18/26</a:t>
+              <a:t>3/19/26</a:t>
             </a:fld>
             <a:endParaRPr lang="en-US"/>
           </a:p>
@@ -15637,7 +15646,7 @@
           <a:p>
             <a:fld id="{5BCAD085-E8A6-8845-BD4E-CB4CCA059FC4}" type="datetimeFigureOut">
               <a:rPr lang="en-US" smtClean="0"/>
-              <a:t>3/18/26</a:t>
+              <a:t>3/19/26</a:t>
             </a:fld>
             <a:endParaRPr lang="en-US"/>
           </a:p>
@@ -15732,7 +15741,7 @@
           <a:p>
             <a:fld id="{5BCAD085-E8A6-8845-BD4E-CB4CCA059FC4}" type="datetimeFigureOut">
               <a:rPr lang="en-US" smtClean="0"/>
-              <a:t>3/18/26</a:t>
+              <a:t>3/19/26</a:t>
             </a:fld>
             <a:endParaRPr lang="en-US"/>
           </a:p>
@@ -16007,7 +16016,7 @@
           <a:p>
             <a:fld id="{5BCAD085-E8A6-8845-BD4E-CB4CCA059FC4}" type="datetimeFigureOut">
               <a:rPr lang="en-US" smtClean="0"/>
-              <a:t>3/18/26</a:t>
+              <a:t>3/19/26</a:t>
             </a:fld>
             <a:endParaRPr lang="en-US"/>
           </a:p>
@@ -16259,7 +16268,7 @@
           <a:p>
             <a:fld id="{5BCAD085-E8A6-8845-BD4E-CB4CCA059FC4}" type="datetimeFigureOut">
               <a:rPr lang="en-US" smtClean="0"/>
-              <a:t>3/18/26</a:t>
+              <a:t>3/19/26</a:t>
             </a:fld>
             <a:endParaRPr lang="en-US"/>
           </a:p>
@@ -16470,7 +16479,7 @@
           <a:p>
             <a:fld id="{5BCAD085-E8A6-8845-BD4E-CB4CCA059FC4}" type="datetimeFigureOut">
               <a:rPr lang="en-US" smtClean="0"/>
-              <a:t>3/18/26</a:t>
+              <a:t>3/19/26</a:t>
             </a:fld>
             <a:endParaRPr lang="en-US"/>
           </a:p>
@@ -17511,83 +17520,6 @@
           <a:lstStyle/>
           <a:p>
             <a:r>
-              <a:t>Results: Resource &amp; Efficiency</a:t>
-            </a:r>
-          </a:p>
-        </p:txBody>
-      </p:sp>
-      <p:sp>
-        <p:nvSpPr>
-          <p:cNvPr id="3" name="Content Placeholder 2"/>
-          <p:cNvSpPr>
-            <a:spLocks noGrp="1"/>
-          </p:cNvSpPr>
-          <p:nvPr>
-            <p:ph idx="1"/>
-          </p:nvPr>
-        </p:nvSpPr>
-        <p:spPr/>
-        <p:txBody>
-          <a:bodyPr/>
-          <a:lstStyle/>
-          <a:p>
-            <a:r>
-              <a:t>CPU and memory usage comparison</a:t>
-            </a:r>
-          </a:p>
-          <a:p>
-            <a:r>
-              <a:t>Processing time analysis</a:t>
-            </a:r>
-          </a:p>
-          <a:p>
-            <a:r>
-              <a:t>Identify most efficient method for edge</a:t>
-            </a:r>
-          </a:p>
-        </p:txBody>
-      </p:sp>
-    </p:spTree>
-  </p:cSld>
-  <p:clrMapOvr>
-    <a:masterClrMapping/>
-  </p:clrMapOvr>
-</p:sld>
-</file>
-
-<file path=ppt/slides/slide11.xml><?xml version="1.0" encoding="utf-8"?>
-<p:sld xmlns:a="http://schemas.openxmlformats.org/drawingml/2006/main" xmlns:r="http://schemas.openxmlformats.org/officeDocument/2006/relationships" xmlns:p="http://schemas.openxmlformats.org/presentationml/2006/main">
-  <p:cSld>
-    <p:spTree>
-      <p:nvGrpSpPr>
-        <p:cNvPr id="1" name=""/>
-        <p:cNvGrpSpPr/>
-        <p:nvPr/>
-      </p:nvGrpSpPr>
-      <p:grpSpPr>
-        <a:xfrm>
-          <a:off x="0" y="0"/>
-          <a:ext cx="0" cy="0"/>
-          <a:chOff x="0" y="0"/>
-          <a:chExt cx="0" cy="0"/>
-        </a:xfrm>
-      </p:grpSpPr>
-      <p:sp>
-        <p:nvSpPr>
-          <p:cNvPr id="2" name="Title 1"/>
-          <p:cNvSpPr>
-            <a:spLocks noGrp="1"/>
-          </p:cNvSpPr>
-          <p:nvPr>
-            <p:ph type="title"/>
-          </p:nvPr>
-        </p:nvSpPr>
-        <p:spPr/>
-        <p:txBody>
-          <a:bodyPr/>
-          <a:lstStyle/>
-          <a:p>
-            <a:r>
               <a:t>Conclusion</a:t>
             </a:r>
           </a:p>
@@ -17605,31 +17537,91 @@
         </p:nvSpPr>
         <p:spPr/>
         <p:txBody>
-          <a:bodyPr/>
+          <a:bodyPr>
+            <a:normAutofit fontScale="70000" lnSpcReduction="20000"/>
+          </a:bodyPr>
           <a:lstStyle/>
           <a:p>
             <a:r>
-              <a:rPr dirty="0"/>
-              <a:t>IDS is essential for IoMT edge security</a:t>
+              <a:rPr lang="en-GB" dirty="0"/>
+              <a:t>Feature reduction techniques, including PCA, </a:t>
+            </a:r>
+            <a:r>
+              <a:rPr lang="en-GB" dirty="0" err="1"/>
+              <a:t>AutoEncoder</a:t>
+            </a:r>
+            <a:r>
+              <a:rPr lang="en-GB" dirty="0"/>
+              <a:t>, and </a:t>
+            </a:r>
+            <a:r>
+              <a:rPr lang="en-GB" dirty="0" err="1"/>
+              <a:t>ResNeXt</a:t>
+            </a:r>
+            <a:r>
+              <a:rPr lang="en-GB" dirty="0"/>
+              <a:t>, generally lead to a decrease in model performance, particularly in terms of accuracy and F1 score.</a:t>
             </a:r>
           </a:p>
           <a:p>
             <a:r>
-              <a:rPr dirty="0"/>
-              <a:t>Resource constraints impact deployment</a:t>
+              <a:rPr lang="en-GB" dirty="0"/>
+              <a:t>If</a:t>
+            </a:r>
+            <a:r>
+              <a:rPr lang="zh-CN" altLang="en-US" dirty="0"/>
+              <a:t> </a:t>
+            </a:r>
+            <a:r>
+              <a:rPr lang="en-GB" dirty="0"/>
+              <a:t>a certain degree of performance degradation is acceptable, more aggressive dimensionality reduction can be applied to significantly reduce feature size and computational cost.</a:t>
             </a:r>
           </a:p>
           <a:p>
             <a:r>
-              <a:rPr dirty="0"/>
-              <a:t>Trade-off between accuracy and efficiency</a:t>
+              <a:rPr lang="en-GB" dirty="0" err="1"/>
+              <a:t>ResNeXt</a:t>
+            </a:r>
+            <a:r>
+              <a:rPr lang="en-GB" dirty="0"/>
+              <a:t> introduces high CPU overhead when applied to low-dimensional flow-level data, without improving accuracy or F1 score, making it unsuitable for deployment on edge devices. In contrast, PCA and </a:t>
+            </a:r>
+            <a:r>
+              <a:rPr lang="en-GB" dirty="0" err="1"/>
+              <a:t>AutoEncoder</a:t>
+            </a:r>
+            <a:r>
+              <a:rPr lang="en-GB" dirty="0"/>
+              <a:t> show no significant resource bottlenecks and are more suitable for edge-based IDS.</a:t>
             </a:r>
           </a:p>
           <a:p>
             <a:r>
-              <a:rPr dirty="0"/>
-              <a:t>Efficient feature reduction is critical</a:t>
+              <a:rPr lang="en-GB" dirty="0"/>
+              <a:t>Feature reduction reduces performance but improves efficiency; PCA and </a:t>
             </a:r>
+            <a:r>
+              <a:rPr lang="en-GB" dirty="0" err="1"/>
+              <a:t>AutoEncoder</a:t>
+            </a:r>
+            <a:r>
+              <a:rPr lang="en-GB" dirty="0"/>
+              <a:t> are edge-friendly, while </a:t>
+            </a:r>
+            <a:r>
+              <a:rPr lang="en-GB" dirty="0" err="1"/>
+              <a:t>ResNeXt</a:t>
+            </a:r>
+            <a:r>
+              <a:rPr lang="en-GB" dirty="0"/>
+              <a:t> is computationally expensive and ineffective for low-dimensional data.</a:t>
+            </a:r>
+          </a:p>
+          <a:p>
+            <a:endParaRPr lang="en-GB" dirty="0"/>
+          </a:p>
+          <a:p>
+            <a:endParaRPr lang="en-GB" dirty="0"/>
           </a:p>
         </p:txBody>
       </p:sp>
@@ -17641,7 +17633,7 @@
 </p:sld>
 </file>
 
-<file path=ppt/slides/slide12.xml><?xml version="1.0" encoding="utf-8"?>
+<file path=ppt/slides/slide11.xml><?xml version="1.0" encoding="utf-8"?>
 <p:sld xmlns:a="http://schemas.openxmlformats.org/drawingml/2006/main" xmlns:r="http://schemas.openxmlformats.org/officeDocument/2006/relationships" xmlns:p="http://schemas.openxmlformats.org/presentationml/2006/main">
   <p:cSld>
     <p:spTree>
@@ -19408,7 +19400,7 @@
             <p:ph idx="1"/>
             <p:extLst>
               <p:ext uri="{D42A27DB-BD31-4B8C-83A1-F6EECF244321}">
-                <p14:modId xmlns:p14="http://schemas.microsoft.com/office/powerpoint/2010/main" val="3654781277"/>
+                <p14:modId xmlns:p14="http://schemas.microsoft.com/office/powerpoint/2010/main" val="3681699800"/>
               </p:ext>
             </p:extLst>
           </p:nvPr>
@@ -33747,8 +33739,16 @@
               <a:t>Methodology: </a:t>
             </a:r>
             <a:r>
-              <a:rPr lang="en-GB" sz="2800" dirty="0" err="1"/>
-              <a:t>DataSet</a:t>
+              <a:rPr lang="en-GB" sz="2800" dirty="0"/>
+              <a:t>Data</a:t>
+            </a:r>
+            <a:r>
+              <a:rPr lang="en-US" altLang="zh-CN" sz="2800" dirty="0"/>
+              <a:t>s</a:t>
+            </a:r>
+            <a:r>
+              <a:rPr lang="en-GB" sz="2800" dirty="0"/>
+              <a:t>et</a:t>
             </a:r>
             <a:r>
               <a:rPr lang="zh-CN" altLang="en-US" sz="2800" dirty="0"/>
@@ -34061,7 +34061,7 @@
           <a:lstStyle/>
           <a:p>
             <a:r>
-              <a:t>Methodology: Evaluation Design</a:t>
+              <a:t>Results: Detection Performance</a:t>
             </a:r>
           </a:p>
         </p:txBody>
@@ -34082,36 +34082,20 @@
           <a:lstStyle/>
           <a:p>
             <a:r>
-              <a:rPr dirty="0"/>
-              <a:t>Detection: Accuracy, </a:t>
-            </a:r>
-            <a:r>
-              <a:rPr lang="en-US" dirty="0"/>
-              <a:t>F1 score</a:t>
-            </a:r>
-            <a:endParaRPr dirty="0"/>
-          </a:p>
-          <a:p>
-            <a:r>
-              <a:rPr dirty="0"/>
-              <a:t>Resource usage: CPU, Memory</a:t>
-            </a:r>
-            <a:r>
-              <a:rPr lang="en-US" dirty="0"/>
-              <a:t>, Network Traffic</a:t>
-            </a:r>
-            <a:endParaRPr dirty="0"/>
-          </a:p>
-          <a:p>
-            <a:r>
-              <a:rPr dirty="0"/>
-              <a:t>Efficiency: Processing time, Throughput</a:t>
+              <a:rPr lang="en-GB" dirty="0"/>
+              <a:t>Compare FS, PCA, Autoencoder</a:t>
             </a:r>
           </a:p>
           <a:p>
             <a:r>
-              <a:rPr dirty="0"/>
-              <a:t>Test under edge-like constraints</a:t>
+              <a:rPr lang="en-GB" dirty="0"/>
+              <a:t>Accuracy / Precision / Recall results</a:t>
+            </a:r>
+          </a:p>
+          <a:p>
+            <a:r>
+              <a:rPr lang="en-GB" dirty="0"/>
+              <a:t>Performance differences observed</a:t>
             </a:r>
           </a:p>
         </p:txBody>
@@ -34157,7 +34141,7 @@
           <a:lstStyle/>
           <a:p>
             <a:r>
-              <a:t>Results: Detection Performance</a:t>
+              <a:t>Results: Resource &amp; Efficiency</a:t>
             </a:r>
           </a:p>
         </p:txBody>
@@ -34178,17 +34162,17 @@
           <a:lstStyle/>
           <a:p>
             <a:r>
-              <a:t>Compare FS, PCA, Autoencoder</a:t>
+              <a:t>CPU and memory usage comparison</a:t>
             </a:r>
           </a:p>
           <a:p>
             <a:r>
-              <a:t>Accuracy / Precision / Recall results</a:t>
+              <a:t>Processing time analysis</a:t>
             </a:r>
           </a:p>
           <a:p>
             <a:r>
-              <a:t>Performance differences observed</a:t>
+              <a:t>Identify most efficient method for edge</a:t>
             </a:r>
           </a:p>
         </p:txBody>

</xml_diff>

<commit_message>
Add network, CPU and memory
</commit_message>
<xml_diff>
--- a/Presentation/IoMT_IDS_Presentation.pptx
+++ b/Presentation/IoMT_IDS_Presentation.pptx
@@ -5,7 +5,7 @@
     <p:sldMasterId id="2147483648" r:id="rId1"/>
   </p:sldMasterIdLst>
   <p:notesMasterIdLst>
-    <p:notesMasterId r:id="rId13"/>
+    <p:notesMasterId r:id="rId15"/>
   </p:notesMasterIdLst>
   <p:sldIdLst>
     <p:sldId id="256" r:id="rId2"/>
@@ -17,8 +17,10 @@
     <p:sldId id="261" r:id="rId8"/>
     <p:sldId id="272" r:id="rId9"/>
     <p:sldId id="263" r:id="rId10"/>
-    <p:sldId id="265" r:id="rId11"/>
-    <p:sldId id="266" r:id="rId12"/>
+    <p:sldId id="273" r:id="rId11"/>
+    <p:sldId id="274" r:id="rId12"/>
+    <p:sldId id="265" r:id="rId13"/>
+    <p:sldId id="266" r:id="rId14"/>
   </p:sldIdLst>
   <p:sldSz cx="9144000" cy="6858000" type="screen4x3"/>
   <p:notesSz cx="6858000" cy="9144000"/>
@@ -139,7 +141,7 @@
 <file path=ppt/revisionInfo.xml><?xml version="1.0" encoding="utf-8"?>
 <p1510:revInfo xmlns:a="http://schemas.openxmlformats.org/drawingml/2006/main" xmlns:r="http://schemas.openxmlformats.org/officeDocument/2006/relationships" xmlns:p1510="http://schemas.microsoft.com/office/powerpoint/2015/10/main">
   <p1510:revLst>
-    <p1510:client id="{7BF04AB4-6846-4849-A1B8-6A167A3B7532}" v="439" dt="2026-03-21T18:34:36.950"/>
+    <p1510:client id="{7BF04AB4-6846-4849-A1B8-6A167A3B7532}" v="450" dt="2026-03-21T20:43:58.717"/>
   </p1510:revLst>
 </p1510:revInfo>
 </file>
@@ -149,7 +151,7 @@
   <pc:docChgLst>
     <pc:chgData name="耀泉 马" userId="19e30af8d5659de2" providerId="LiveId" clId="{C3594856-CEDA-5129-B2AF-7962E3CA4CA3}"/>
     <pc:docChg chg="undo custSel addSld delSld modSld sldOrd">
-      <pc:chgData name="耀泉 马" userId="19e30af8d5659de2" providerId="LiveId" clId="{C3594856-CEDA-5129-B2AF-7962E3CA4CA3}" dt="2026-03-21T18:35:33.059" v="3525" actId="1037"/>
+      <pc:chgData name="耀泉 马" userId="19e30af8d5659de2" providerId="LiveId" clId="{C3594856-CEDA-5129-B2AF-7962E3CA4CA3}" dt="2026-03-21T20:43:58.717" v="3569" actId="20577"/>
       <pc:docMkLst>
         <pc:docMk/>
       </pc:docMkLst>
@@ -367,7 +369,7 @@
         </pc:graphicFrameChg>
       </pc:sldChg>
       <pc:sldChg chg="addSp delSp modSp mod ord modNotesTx">
-        <pc:chgData name="耀泉 马" userId="19e30af8d5659de2" providerId="LiveId" clId="{C3594856-CEDA-5129-B2AF-7962E3CA4CA3}" dt="2026-03-21T18:23:43.642" v="3382" actId="313"/>
+        <pc:chgData name="耀泉 马" userId="19e30af8d5659de2" providerId="LiveId" clId="{C3594856-CEDA-5129-B2AF-7962E3CA4CA3}" dt="2026-03-21T20:36:25.152" v="3542" actId="20577"/>
         <pc:sldMkLst>
           <pc:docMk/>
           <pc:sldMk cId="0" sldId="261"/>
@@ -389,7 +391,7 @@
           </ac:spMkLst>
         </pc:spChg>
         <pc:spChg chg="add mod">
-          <ac:chgData name="耀泉 马" userId="19e30af8d5659de2" providerId="LiveId" clId="{C3594856-CEDA-5129-B2AF-7962E3CA4CA3}" dt="2026-03-21T17:29:09.431" v="3262" actId="20577"/>
+          <ac:chgData name="耀泉 马" userId="19e30af8d5659de2" providerId="LiveId" clId="{C3594856-CEDA-5129-B2AF-7962E3CA4CA3}" dt="2026-03-21T20:36:25.152" v="3542" actId="20577"/>
           <ac:spMkLst>
             <pc:docMk/>
             <pc:sldMk cId="0" sldId="261"/>
@@ -413,20 +415,44 @@
           </ac:picMkLst>
         </pc:picChg>
       </pc:sldChg>
-      <pc:sldChg chg="modSp mod">
-        <pc:chgData name="耀泉 马" userId="19e30af8d5659de2" providerId="LiveId" clId="{C3594856-CEDA-5129-B2AF-7962E3CA4CA3}" dt="2026-03-19T15:16:36.398" v="3013" actId="20577"/>
+      <pc:sldChg chg="addSp delSp modSp mod setBg">
+        <pc:chgData name="耀泉 马" userId="19e30af8d5659de2" providerId="LiveId" clId="{C3594856-CEDA-5129-B2AF-7962E3CA4CA3}" dt="2026-03-21T20:43:40.961" v="3562" actId="1076"/>
         <pc:sldMkLst>
           <pc:docMk/>
           <pc:sldMk cId="0" sldId="263"/>
         </pc:sldMkLst>
         <pc:spChg chg="mod">
-          <ac:chgData name="耀泉 马" userId="19e30af8d5659de2" providerId="LiveId" clId="{C3594856-CEDA-5129-B2AF-7962E3CA4CA3}" dt="2026-03-19T15:16:36.398" v="3013" actId="20577"/>
+          <ac:chgData name="耀泉 马" userId="19e30af8d5659de2" providerId="LiveId" clId="{C3594856-CEDA-5129-B2AF-7962E3CA4CA3}" dt="2026-03-21T20:36:00.261" v="3532" actId="26606"/>
+          <ac:spMkLst>
+            <pc:docMk/>
+            <pc:sldMk cId="0" sldId="263"/>
+            <ac:spMk id="2" creationId="{00000000-0000-0000-0000-000000000000}"/>
+          </ac:spMkLst>
+        </pc:spChg>
+        <pc:spChg chg="del mod">
+          <ac:chgData name="耀泉 马" userId="19e30af8d5659de2" providerId="LiveId" clId="{C3594856-CEDA-5129-B2AF-7962E3CA4CA3}" dt="2026-03-21T20:35:51.651" v="3528" actId="478"/>
           <ac:spMkLst>
             <pc:docMk/>
             <pc:sldMk cId="0" sldId="263"/>
             <ac:spMk id="3" creationId="{00000000-0000-0000-0000-000000000000}"/>
           </ac:spMkLst>
         </pc:spChg>
+        <pc:spChg chg="add">
+          <ac:chgData name="耀泉 马" userId="19e30af8d5659de2" providerId="LiveId" clId="{C3594856-CEDA-5129-B2AF-7962E3CA4CA3}" dt="2026-03-21T20:36:00.261" v="3532" actId="26606"/>
+          <ac:spMkLst>
+            <pc:docMk/>
+            <pc:sldMk cId="0" sldId="263"/>
+            <ac:spMk id="9" creationId="{A4AC5506-6312-4701-8D3C-40187889A947}"/>
+          </ac:spMkLst>
+        </pc:spChg>
+        <pc:picChg chg="add mod">
+          <ac:chgData name="耀泉 马" userId="19e30af8d5659de2" providerId="LiveId" clId="{C3594856-CEDA-5129-B2AF-7962E3CA4CA3}" dt="2026-03-21T20:43:40.961" v="3562" actId="1076"/>
+          <ac:picMkLst>
+            <pc:docMk/>
+            <pc:sldMk cId="0" sldId="263"/>
+            <ac:picMk id="4" creationId="{DAA2CFB1-11FC-6602-E404-BCF9B9E77477}"/>
+          </ac:picMkLst>
+        </pc:picChg>
       </pc:sldChg>
       <pc:sldChg chg="modSp del mod">
         <pc:chgData name="耀泉 马" userId="19e30af8d5659de2" providerId="LiveId" clId="{C3594856-CEDA-5129-B2AF-7962E3CA4CA3}" dt="2026-03-21T16:21:59.799" v="3128" actId="2696"/>
@@ -443,20 +469,60 @@
           </ac:spMkLst>
         </pc:spChg>
       </pc:sldChg>
-      <pc:sldChg chg="modSp mod">
-        <pc:chgData name="耀泉 马" userId="19e30af8d5659de2" providerId="LiveId" clId="{C3594856-CEDA-5129-B2AF-7962E3CA4CA3}" dt="2026-03-19T15:25:41.900" v="3029" actId="27636"/>
+      <pc:sldChg chg="addSp delSp modSp mod setBg">
+        <pc:chgData name="耀泉 马" userId="19e30af8d5659de2" providerId="LiveId" clId="{C3594856-CEDA-5129-B2AF-7962E3CA4CA3}" dt="2026-03-21T20:43:58.717" v="3569" actId="20577"/>
         <pc:sldMkLst>
           <pc:docMk/>
           <pc:sldMk cId="0" sldId="265"/>
         </pc:sldMkLst>
         <pc:spChg chg="mod">
-          <ac:chgData name="耀泉 马" userId="19e30af8d5659de2" providerId="LiveId" clId="{C3594856-CEDA-5129-B2AF-7962E3CA4CA3}" dt="2026-03-19T15:25:41.900" v="3029" actId="27636"/>
+          <ac:chgData name="耀泉 马" userId="19e30af8d5659de2" providerId="LiveId" clId="{C3594856-CEDA-5129-B2AF-7962E3CA4CA3}" dt="2026-03-21T20:43:51.197" v="3563" actId="26606"/>
+          <ac:spMkLst>
+            <pc:docMk/>
+            <pc:sldMk cId="0" sldId="265"/>
+            <ac:spMk id="2" creationId="{00000000-0000-0000-0000-000000000000}"/>
+          </ac:spMkLst>
+        </pc:spChg>
+        <pc:spChg chg="del mod">
+          <ac:chgData name="耀泉 马" userId="19e30af8d5659de2" providerId="LiveId" clId="{C3594856-CEDA-5129-B2AF-7962E3CA4CA3}" dt="2026-03-21T20:43:51.197" v="3563" actId="26606"/>
           <ac:spMkLst>
             <pc:docMk/>
             <pc:sldMk cId="0" sldId="265"/>
             <ac:spMk id="3" creationId="{00000000-0000-0000-0000-000000000000}"/>
           </ac:spMkLst>
         </pc:spChg>
+        <pc:spChg chg="add">
+          <ac:chgData name="耀泉 马" userId="19e30af8d5659de2" providerId="LiveId" clId="{C3594856-CEDA-5129-B2AF-7962E3CA4CA3}" dt="2026-03-21T20:43:51.197" v="3563" actId="26606"/>
+          <ac:spMkLst>
+            <pc:docMk/>
+            <pc:sldMk cId="0" sldId="265"/>
+            <ac:spMk id="9" creationId="{53B021B3-DE93-4AB7-8A18-CF5F1CED88B8}"/>
+          </ac:spMkLst>
+        </pc:spChg>
+        <pc:spChg chg="add">
+          <ac:chgData name="耀泉 马" userId="19e30af8d5659de2" providerId="LiveId" clId="{C3594856-CEDA-5129-B2AF-7962E3CA4CA3}" dt="2026-03-21T20:43:51.197" v="3563" actId="26606"/>
+          <ac:spMkLst>
+            <pc:docMk/>
+            <pc:sldMk cId="0" sldId="265"/>
+            <ac:spMk id="11" creationId="{52D502E5-F6B4-4D58-B4AE-FC466FF15EE8}"/>
+          </ac:spMkLst>
+        </pc:spChg>
+        <pc:spChg chg="add">
+          <ac:chgData name="耀泉 马" userId="19e30af8d5659de2" providerId="LiveId" clId="{C3594856-CEDA-5129-B2AF-7962E3CA4CA3}" dt="2026-03-21T20:43:51.197" v="3563" actId="26606"/>
+          <ac:spMkLst>
+            <pc:docMk/>
+            <pc:sldMk cId="0" sldId="265"/>
+            <ac:spMk id="13" creationId="{9DECDBF4-02B6-4BB4-B65B-B8107AD6A9E8}"/>
+          </ac:spMkLst>
+        </pc:spChg>
+        <pc:graphicFrameChg chg="add mod">
+          <ac:chgData name="耀泉 马" userId="19e30af8d5659de2" providerId="LiveId" clId="{C3594856-CEDA-5129-B2AF-7962E3CA4CA3}" dt="2026-03-21T20:43:58.717" v="3569" actId="20577"/>
+          <ac:graphicFrameMkLst>
+            <pc:docMk/>
+            <pc:sldMk cId="0" sldId="265"/>
+            <ac:graphicFrameMk id="5" creationId="{8229F03F-070E-65BB-A314-B6D801640DE9}"/>
+          </ac:graphicFrameMkLst>
+        </pc:graphicFrameChg>
       </pc:sldChg>
       <pc:sldChg chg="addSp delSp modSp add mod modAnim">
         <pc:chgData name="耀泉 马" userId="19e30af8d5659de2" providerId="LiveId" clId="{C3594856-CEDA-5129-B2AF-7962E3CA4CA3}" dt="2026-03-21T17:49:38.641" v="3335" actId="692"/>
@@ -2174,6 +2240,84 @@
           </ac:cxnSpMkLst>
         </pc:cxnChg>
       </pc:sldChg>
+      <pc:sldChg chg="addSp delSp modSp add mod setBg delDesignElem">
+        <pc:chgData name="耀泉 马" userId="19e30af8d5659de2" providerId="LiveId" clId="{C3594856-CEDA-5129-B2AF-7962E3CA4CA3}" dt="2026-03-21T20:42:45.077" v="3550" actId="1076"/>
+        <pc:sldMkLst>
+          <pc:docMk/>
+          <pc:sldMk cId="350239924" sldId="273"/>
+        </pc:sldMkLst>
+        <pc:spChg chg="add">
+          <ac:chgData name="耀泉 马" userId="19e30af8d5659de2" providerId="LiveId" clId="{C3594856-CEDA-5129-B2AF-7962E3CA4CA3}" dt="2026-03-21T20:42:05.475" v="3545" actId="26606"/>
+          <ac:spMkLst>
+            <pc:docMk/>
+            <pc:sldMk cId="350239924" sldId="273"/>
+            <ac:spMk id="6" creationId="{A4AC5506-6312-4701-8D3C-40187889A947}"/>
+          </ac:spMkLst>
+        </pc:spChg>
+        <pc:spChg chg="del">
+          <ac:chgData name="耀泉 马" userId="19e30af8d5659de2" providerId="LiveId" clId="{C3594856-CEDA-5129-B2AF-7962E3CA4CA3}" dt="2026-03-21T20:41:55.322" v="3544"/>
+          <ac:spMkLst>
+            <pc:docMk/>
+            <pc:sldMk cId="350239924" sldId="273"/>
+            <ac:spMk id="9" creationId="{47B08BE7-4113-CFD4-6149-0F7CD87686DB}"/>
+          </ac:spMkLst>
+        </pc:spChg>
+        <pc:picChg chg="add mod">
+          <ac:chgData name="耀泉 马" userId="19e30af8d5659de2" providerId="LiveId" clId="{C3594856-CEDA-5129-B2AF-7962E3CA4CA3}" dt="2026-03-21T20:42:45.077" v="3550" actId="1076"/>
+          <ac:picMkLst>
+            <pc:docMk/>
+            <pc:sldMk cId="350239924" sldId="273"/>
+            <ac:picMk id="3" creationId="{25BE9F14-AAAC-F3B5-9722-4E0629D91F9E}"/>
+          </ac:picMkLst>
+        </pc:picChg>
+        <pc:picChg chg="del">
+          <ac:chgData name="耀泉 马" userId="19e30af8d5659de2" providerId="LiveId" clId="{C3594856-CEDA-5129-B2AF-7962E3CA4CA3}" dt="2026-03-21T20:42:39.087" v="3546" actId="478"/>
+          <ac:picMkLst>
+            <pc:docMk/>
+            <pc:sldMk cId="350239924" sldId="273"/>
+            <ac:picMk id="4" creationId="{9CD23B94-81C0-D80E-DD4A-CE2F3487F73A}"/>
+          </ac:picMkLst>
+        </pc:picChg>
+      </pc:sldChg>
+      <pc:sldChg chg="addSp delSp modSp add mod setBg delDesignElem">
+        <pc:chgData name="耀泉 马" userId="19e30af8d5659de2" providerId="LiveId" clId="{C3594856-CEDA-5129-B2AF-7962E3CA4CA3}" dt="2026-03-21T20:43:30.782" v="3557" actId="1076"/>
+        <pc:sldMkLst>
+          <pc:docMk/>
+          <pc:sldMk cId="2818536614" sldId="274"/>
+        </pc:sldMkLst>
+        <pc:spChg chg="del">
+          <ac:chgData name="耀泉 马" userId="19e30af8d5659de2" providerId="LiveId" clId="{C3594856-CEDA-5129-B2AF-7962E3CA4CA3}" dt="2026-03-21T20:42:51.165" v="3552"/>
+          <ac:spMkLst>
+            <pc:docMk/>
+            <pc:sldMk cId="2818536614" sldId="274"/>
+            <ac:spMk id="6" creationId="{4D2B9041-1F8D-23EC-0579-37950B9604E9}"/>
+          </ac:spMkLst>
+        </pc:spChg>
+        <pc:spChg chg="add">
+          <ac:chgData name="耀泉 马" userId="19e30af8d5659de2" providerId="LiveId" clId="{C3594856-CEDA-5129-B2AF-7962E3CA4CA3}" dt="2026-03-21T20:42:59.449" v="3553" actId="26606"/>
+          <ac:spMkLst>
+            <pc:docMk/>
+            <pc:sldMk cId="2818536614" sldId="274"/>
+            <ac:spMk id="8" creationId="{A4AC5506-6312-4701-8D3C-40187889A947}"/>
+          </ac:spMkLst>
+        </pc:spChg>
+        <pc:picChg chg="del mod">
+          <ac:chgData name="耀泉 马" userId="19e30af8d5659de2" providerId="LiveId" clId="{C3594856-CEDA-5129-B2AF-7962E3CA4CA3}" dt="2026-03-21T20:43:26.586" v="3554" actId="478"/>
+          <ac:picMkLst>
+            <pc:docMk/>
+            <pc:sldMk cId="2818536614" sldId="274"/>
+            <ac:picMk id="3" creationId="{7F668C18-4893-9C0F-92E9-9372E309CEED}"/>
+          </ac:picMkLst>
+        </pc:picChg>
+        <pc:picChg chg="add mod">
+          <ac:chgData name="耀泉 马" userId="19e30af8d5659de2" providerId="LiveId" clId="{C3594856-CEDA-5129-B2AF-7962E3CA4CA3}" dt="2026-03-21T20:43:30.782" v="3557" actId="1076"/>
+          <ac:picMkLst>
+            <pc:docMk/>
+            <pc:sldMk cId="2818536614" sldId="274"/>
+            <ac:picMk id="4" creationId="{32C908D8-FD4A-23AD-FF3A-C520FE2AF206}"/>
+          </ac:picMkLst>
+        </pc:picChg>
+      </pc:sldChg>
     </pc:docChg>
   </pc:docChgLst>
 </pc:chgInfo>
@@ -4656,6 +4800,927 @@
     <dgm:txLinClrLst/>
     <dgm:txFillClrLst meth="repeat">
       <a:schemeClr val="tx1"/>
+    </dgm:txFillClrLst>
+    <dgm:txEffectClrLst/>
+  </dgm:styleLbl>
+</dgm:colorsDef>
+</file>
+
+<file path=ppt/diagrams/colors4.xml><?xml version="1.0" encoding="utf-8"?>
+<dgm:colorsDef xmlns:dgm="http://schemas.openxmlformats.org/drawingml/2006/diagram" xmlns:a="http://schemas.openxmlformats.org/drawingml/2006/main" uniqueId="urn:microsoft.com/office/officeart/2018/5/colors/Iconchunking_neutralicontext_colorful1">
+  <dgm:title val=""/>
+  <dgm:desc val=""/>
+  <dgm:catLst>
+    <dgm:cat type="colorful" pri="10100"/>
+  </dgm:catLst>
+  <dgm:styleLbl name="node0">
+    <dgm:fillClrLst meth="repeat">
+      <a:schemeClr val="accent1"/>
+    </dgm:fillClrLst>
+    <dgm:linClrLst meth="repeat">
+      <a:schemeClr val="lt1"/>
+    </dgm:linClrLst>
+    <dgm:effectClrLst/>
+    <dgm:txLinClrLst/>
+    <dgm:txFillClrLst/>
+    <dgm:txEffectClrLst/>
+  </dgm:styleLbl>
+  <dgm:styleLbl name="node1">
+    <dgm:fillClrLst meth="repeat">
+      <a:schemeClr val="bg1"/>
+    </dgm:fillClrLst>
+    <dgm:linClrLst meth="repeat">
+      <a:schemeClr val="lt1">
+        <a:alpha val="0"/>
+      </a:schemeClr>
+    </dgm:linClrLst>
+    <dgm:effectClrLst/>
+    <dgm:txLinClrLst/>
+    <dgm:txFillClrLst meth="repeat">
+      <a:schemeClr val="dk1"/>
+    </dgm:txFillClrLst>
+    <dgm:txEffectClrLst/>
+  </dgm:styleLbl>
+  <dgm:styleLbl name="alignNode1">
+    <dgm:fillClrLst meth="repeat">
+      <a:schemeClr val="accent2"/>
+      <a:schemeClr val="accent3"/>
+      <a:schemeClr val="accent4"/>
+      <a:schemeClr val="accent5"/>
+      <a:schemeClr val="accent6"/>
+    </dgm:fillClrLst>
+    <dgm:linClrLst meth="repeat">
+      <a:schemeClr val="accent2"/>
+      <a:schemeClr val="accent3"/>
+      <a:schemeClr val="accent4"/>
+      <a:schemeClr val="accent5"/>
+      <a:schemeClr val="accent6"/>
+    </dgm:linClrLst>
+    <dgm:effectClrLst/>
+    <dgm:txLinClrLst/>
+    <dgm:txFillClrLst/>
+    <dgm:txEffectClrLst/>
+  </dgm:styleLbl>
+  <dgm:styleLbl name="lnNode1">
+    <dgm:fillClrLst meth="repeat">
+      <a:schemeClr val="accent2"/>
+      <a:schemeClr val="accent3"/>
+      <a:schemeClr val="accent4"/>
+      <a:schemeClr val="accent5"/>
+      <a:schemeClr val="accent6"/>
+    </dgm:fillClrLst>
+    <dgm:linClrLst meth="repeat">
+      <a:schemeClr val="lt1"/>
+    </dgm:linClrLst>
+    <dgm:effectClrLst/>
+    <dgm:txLinClrLst/>
+    <dgm:txFillClrLst/>
+    <dgm:txEffectClrLst/>
+  </dgm:styleLbl>
+  <dgm:styleLbl name="vennNode1">
+    <dgm:fillClrLst meth="repeat">
+      <a:schemeClr val="accent2">
+        <a:alpha val="50000"/>
+      </a:schemeClr>
+      <a:schemeClr val="accent3">
+        <a:alpha val="50000"/>
+      </a:schemeClr>
+      <a:schemeClr val="accent4">
+        <a:alpha val="50000"/>
+      </a:schemeClr>
+      <a:schemeClr val="accent5">
+        <a:alpha val="50000"/>
+      </a:schemeClr>
+      <a:schemeClr val="accent6">
+        <a:alpha val="50000"/>
+      </a:schemeClr>
+    </dgm:fillClrLst>
+    <dgm:linClrLst meth="repeat">
+      <a:schemeClr val="lt1"/>
+    </dgm:linClrLst>
+    <dgm:effectClrLst/>
+    <dgm:txLinClrLst/>
+    <dgm:txFillClrLst/>
+    <dgm:txEffectClrLst/>
+  </dgm:styleLbl>
+  <dgm:styleLbl name="node2">
+    <dgm:fillClrLst>
+      <a:schemeClr val="accent2"/>
+    </dgm:fillClrLst>
+    <dgm:linClrLst meth="repeat">
+      <a:schemeClr val="lt1"/>
+    </dgm:linClrLst>
+    <dgm:effectClrLst/>
+    <dgm:txLinClrLst/>
+    <dgm:txFillClrLst/>
+    <dgm:txEffectClrLst/>
+  </dgm:styleLbl>
+  <dgm:styleLbl name="node3">
+    <dgm:fillClrLst>
+      <a:schemeClr val="accent3"/>
+    </dgm:fillClrLst>
+    <dgm:linClrLst meth="repeat">
+      <a:schemeClr val="lt1"/>
+    </dgm:linClrLst>
+    <dgm:effectClrLst/>
+    <dgm:txLinClrLst/>
+    <dgm:txFillClrLst/>
+    <dgm:txEffectClrLst/>
+  </dgm:styleLbl>
+  <dgm:styleLbl name="node4">
+    <dgm:fillClrLst>
+      <a:schemeClr val="accent4"/>
+    </dgm:fillClrLst>
+    <dgm:linClrLst meth="repeat">
+      <a:schemeClr val="lt1"/>
+    </dgm:linClrLst>
+    <dgm:effectClrLst/>
+    <dgm:txLinClrLst/>
+    <dgm:txFillClrLst/>
+    <dgm:txEffectClrLst/>
+  </dgm:styleLbl>
+  <dgm:styleLbl name="fgImgPlace1">
+    <dgm:fillClrLst meth="repeat">
+      <a:schemeClr val="accent2">
+        <a:tint val="50000"/>
+      </a:schemeClr>
+      <a:schemeClr val="accent3">
+        <a:tint val="50000"/>
+      </a:schemeClr>
+      <a:schemeClr val="accent4">
+        <a:tint val="50000"/>
+      </a:schemeClr>
+      <a:schemeClr val="accent5">
+        <a:tint val="50000"/>
+      </a:schemeClr>
+      <a:schemeClr val="accent6">
+        <a:tint val="50000"/>
+      </a:schemeClr>
+    </dgm:fillClrLst>
+    <dgm:linClrLst meth="repeat">
+      <a:schemeClr val="lt1"/>
+    </dgm:linClrLst>
+    <dgm:effectClrLst/>
+    <dgm:txLinClrLst/>
+    <dgm:txFillClrLst meth="repeat">
+      <a:schemeClr val="lt1"/>
+    </dgm:txFillClrLst>
+    <dgm:txEffectClrLst/>
+  </dgm:styleLbl>
+  <dgm:styleLbl name="alignImgPlace1">
+    <dgm:fillClrLst>
+      <a:schemeClr val="accent1">
+        <a:tint val="50000"/>
+      </a:schemeClr>
+      <a:schemeClr val="accent2">
+        <a:tint val="20000"/>
+      </a:schemeClr>
+    </dgm:fillClrLst>
+    <dgm:linClrLst meth="repeat">
+      <a:schemeClr val="lt1"/>
+    </dgm:linClrLst>
+    <dgm:effectClrLst/>
+    <dgm:txLinClrLst/>
+    <dgm:txFillClrLst meth="repeat">
+      <a:schemeClr val="lt1"/>
+    </dgm:txFillClrLst>
+    <dgm:txEffectClrLst/>
+  </dgm:styleLbl>
+  <dgm:styleLbl name="bgImgPlace1">
+    <dgm:fillClrLst>
+      <a:schemeClr val="accent1">
+        <a:tint val="50000"/>
+      </a:schemeClr>
+      <a:schemeClr val="accent2">
+        <a:tint val="20000"/>
+      </a:schemeClr>
+    </dgm:fillClrLst>
+    <dgm:linClrLst meth="repeat">
+      <a:schemeClr val="lt1"/>
+    </dgm:linClrLst>
+    <dgm:effectClrLst/>
+    <dgm:txLinClrLst/>
+    <dgm:txFillClrLst meth="repeat">
+      <a:schemeClr val="lt1"/>
+    </dgm:txFillClrLst>
+    <dgm:txEffectClrLst/>
+  </dgm:styleLbl>
+  <dgm:styleLbl name="sibTrans2D1">
+    <dgm:fillClrLst meth="repeat">
+      <a:schemeClr val="accent2"/>
+      <a:schemeClr val="accent3"/>
+      <a:schemeClr val="accent4"/>
+      <a:schemeClr val="accent5"/>
+      <a:schemeClr val="accent6"/>
+    </dgm:fillClrLst>
+    <dgm:linClrLst meth="cycle">
+      <a:schemeClr val="lt1"/>
+    </dgm:linClrLst>
+    <dgm:effectClrLst/>
+    <dgm:txLinClrLst/>
+    <dgm:txFillClrLst/>
+    <dgm:txEffectClrLst/>
+  </dgm:styleLbl>
+  <dgm:styleLbl name="fgSibTrans2D1">
+    <dgm:fillClrLst meth="repeat">
+      <a:schemeClr val="accent2"/>
+      <a:schemeClr val="accent3"/>
+      <a:schemeClr val="accent4"/>
+      <a:schemeClr val="accent5"/>
+      <a:schemeClr val="accent6"/>
+    </dgm:fillClrLst>
+    <dgm:linClrLst meth="cycle">
+      <a:schemeClr val="lt1"/>
+    </dgm:linClrLst>
+    <dgm:effectClrLst/>
+    <dgm:txLinClrLst/>
+    <dgm:txFillClrLst meth="repeat">
+      <a:schemeClr val="lt1"/>
+    </dgm:txFillClrLst>
+    <dgm:txEffectClrLst/>
+  </dgm:styleLbl>
+  <dgm:styleLbl name="bgSibTrans2D1">
+    <dgm:fillClrLst meth="repeat">
+      <a:schemeClr val="accent2"/>
+      <a:schemeClr val="accent3"/>
+      <a:schemeClr val="accent4"/>
+      <a:schemeClr val="accent5"/>
+      <a:schemeClr val="accent6"/>
+    </dgm:fillClrLst>
+    <dgm:linClrLst meth="cycle">
+      <a:schemeClr val="lt1"/>
+    </dgm:linClrLst>
+    <dgm:effectClrLst/>
+    <dgm:txLinClrLst/>
+    <dgm:txFillClrLst meth="repeat">
+      <a:schemeClr val="lt1"/>
+    </dgm:txFillClrLst>
+    <dgm:txEffectClrLst/>
+  </dgm:styleLbl>
+  <dgm:styleLbl name="sibTrans1D1">
+    <dgm:fillClrLst meth="repeat">
+      <a:schemeClr val="accent2"/>
+      <a:schemeClr val="accent3"/>
+      <a:schemeClr val="accent4"/>
+      <a:schemeClr val="accent5"/>
+      <a:schemeClr val="accent6"/>
+    </dgm:fillClrLst>
+    <dgm:linClrLst meth="repeat">
+      <a:schemeClr val="accent2"/>
+      <a:schemeClr val="accent3"/>
+      <a:schemeClr val="accent4"/>
+      <a:schemeClr val="accent5"/>
+      <a:schemeClr val="accent6"/>
+    </dgm:linClrLst>
+    <dgm:effectClrLst/>
+    <dgm:txLinClrLst/>
+    <dgm:txFillClrLst meth="repeat">
+      <a:schemeClr val="tx1"/>
+    </dgm:txFillClrLst>
+    <dgm:txEffectClrLst/>
+  </dgm:styleLbl>
+  <dgm:styleLbl name="callout">
+    <dgm:fillClrLst meth="repeat">
+      <a:schemeClr val="accent2"/>
+    </dgm:fillClrLst>
+    <dgm:linClrLst meth="repeat">
+      <a:schemeClr val="accent2">
+        <a:tint val="50000"/>
+      </a:schemeClr>
+    </dgm:linClrLst>
+    <dgm:effectClrLst/>
+    <dgm:txLinClrLst/>
+    <dgm:txFillClrLst meth="repeat">
+      <a:schemeClr val="tx1"/>
+    </dgm:txFillClrLst>
+    <dgm:txEffectClrLst/>
+  </dgm:styleLbl>
+  <dgm:styleLbl name="asst0">
+    <dgm:fillClrLst meth="repeat">
+      <a:schemeClr val="accent1"/>
+    </dgm:fillClrLst>
+    <dgm:linClrLst meth="repeat">
+      <a:schemeClr val="lt1"/>
+    </dgm:linClrLst>
+    <dgm:effectClrLst/>
+    <dgm:txLinClrLst/>
+    <dgm:txFillClrLst/>
+    <dgm:txEffectClrLst/>
+  </dgm:styleLbl>
+  <dgm:styleLbl name="asst1">
+    <dgm:fillClrLst meth="repeat">
+      <a:schemeClr val="accent2"/>
+    </dgm:fillClrLst>
+    <dgm:linClrLst meth="repeat">
+      <a:schemeClr val="lt1"/>
+    </dgm:linClrLst>
+    <dgm:effectClrLst/>
+    <dgm:txLinClrLst/>
+    <dgm:txFillClrLst/>
+    <dgm:txEffectClrLst/>
+  </dgm:styleLbl>
+  <dgm:styleLbl name="asst2">
+    <dgm:fillClrLst>
+      <a:schemeClr val="accent3"/>
+    </dgm:fillClrLst>
+    <dgm:linClrLst meth="repeat">
+      <a:schemeClr val="lt1"/>
+    </dgm:linClrLst>
+    <dgm:effectClrLst/>
+    <dgm:txLinClrLst/>
+    <dgm:txFillClrLst/>
+    <dgm:txEffectClrLst/>
+  </dgm:styleLbl>
+  <dgm:styleLbl name="asst3">
+    <dgm:fillClrLst>
+      <a:schemeClr val="accent4"/>
+    </dgm:fillClrLst>
+    <dgm:linClrLst meth="repeat">
+      <a:schemeClr val="lt1"/>
+    </dgm:linClrLst>
+    <dgm:effectClrLst/>
+    <dgm:txLinClrLst/>
+    <dgm:txFillClrLst/>
+    <dgm:txEffectClrLst/>
+  </dgm:styleLbl>
+  <dgm:styleLbl name="asst4">
+    <dgm:fillClrLst>
+      <a:schemeClr val="accent5"/>
+    </dgm:fillClrLst>
+    <dgm:linClrLst meth="repeat">
+      <a:schemeClr val="lt1"/>
+    </dgm:linClrLst>
+    <dgm:effectClrLst/>
+    <dgm:txLinClrLst/>
+    <dgm:txFillClrLst/>
+    <dgm:txEffectClrLst/>
+  </dgm:styleLbl>
+  <dgm:styleLbl name="parChTrans2D1">
+    <dgm:fillClrLst meth="repeat">
+      <a:schemeClr val="accent2"/>
+    </dgm:fillClrLst>
+    <dgm:linClrLst meth="repeat">
+      <a:schemeClr val="lt1"/>
+    </dgm:linClrLst>
+    <dgm:effectClrLst/>
+    <dgm:txLinClrLst/>
+    <dgm:txFillClrLst meth="repeat">
+      <a:schemeClr val="lt1"/>
+    </dgm:txFillClrLst>
+    <dgm:txEffectClrLst/>
+  </dgm:styleLbl>
+  <dgm:styleLbl name="parChTrans2D2">
+    <dgm:fillClrLst meth="repeat">
+      <a:schemeClr val="accent3"/>
+    </dgm:fillClrLst>
+    <dgm:linClrLst meth="repeat">
+      <a:schemeClr val="lt1"/>
+    </dgm:linClrLst>
+    <dgm:effectClrLst/>
+    <dgm:txLinClrLst/>
+    <dgm:txFillClrLst/>
+    <dgm:txEffectClrLst/>
+  </dgm:styleLbl>
+  <dgm:styleLbl name="parChTrans2D3">
+    <dgm:fillClrLst meth="repeat">
+      <a:schemeClr val="accent4"/>
+    </dgm:fillClrLst>
+    <dgm:linClrLst meth="repeat">
+      <a:schemeClr val="lt1"/>
+    </dgm:linClrLst>
+    <dgm:effectClrLst/>
+    <dgm:txLinClrLst/>
+    <dgm:txFillClrLst/>
+    <dgm:txEffectClrLst/>
+  </dgm:styleLbl>
+  <dgm:styleLbl name="parChTrans2D4">
+    <dgm:fillClrLst meth="repeat">
+      <a:schemeClr val="accent5"/>
+    </dgm:fillClrLst>
+    <dgm:linClrLst meth="repeat">
+      <a:schemeClr val="lt1"/>
+    </dgm:linClrLst>
+    <dgm:effectClrLst/>
+    <dgm:txLinClrLst/>
+    <dgm:txFillClrLst meth="repeat">
+      <a:schemeClr val="lt1"/>
+    </dgm:txFillClrLst>
+    <dgm:txEffectClrLst/>
+  </dgm:styleLbl>
+  <dgm:styleLbl name="parChTrans1D1">
+    <dgm:fillClrLst meth="repeat">
+      <a:schemeClr val="accent2"/>
+    </dgm:fillClrLst>
+    <dgm:linClrLst meth="repeat">
+      <a:schemeClr val="accent1"/>
+    </dgm:linClrLst>
+    <dgm:effectClrLst/>
+    <dgm:txLinClrLst/>
+    <dgm:txFillClrLst meth="repeat">
+      <a:schemeClr val="tx1"/>
+    </dgm:txFillClrLst>
+    <dgm:txEffectClrLst/>
+  </dgm:styleLbl>
+  <dgm:styleLbl name="parChTrans1D2">
+    <dgm:fillClrLst meth="repeat">
+      <a:schemeClr val="accent3">
+        <a:tint val="90000"/>
+      </a:schemeClr>
+    </dgm:fillClrLst>
+    <dgm:linClrLst meth="repeat">
+      <a:schemeClr val="accent2"/>
+    </dgm:linClrLst>
+    <dgm:effectClrLst/>
+    <dgm:txLinClrLst/>
+    <dgm:txFillClrLst meth="repeat">
+      <a:schemeClr val="tx1"/>
+    </dgm:txFillClrLst>
+    <dgm:txEffectClrLst/>
+  </dgm:styleLbl>
+  <dgm:styleLbl name="parChTrans1D3">
+    <dgm:fillClrLst meth="repeat">
+      <a:schemeClr val="accent4">
+        <a:tint val="70000"/>
+      </a:schemeClr>
+    </dgm:fillClrLst>
+    <dgm:linClrLst meth="repeat">
+      <a:schemeClr val="accent3"/>
+    </dgm:linClrLst>
+    <dgm:effectClrLst/>
+    <dgm:txLinClrLst/>
+    <dgm:txFillClrLst meth="repeat">
+      <a:schemeClr val="tx1"/>
+    </dgm:txFillClrLst>
+    <dgm:txEffectClrLst/>
+  </dgm:styleLbl>
+  <dgm:styleLbl name="parChTrans1D4">
+    <dgm:fillClrLst meth="repeat">
+      <a:schemeClr val="accent5">
+        <a:tint val="50000"/>
+      </a:schemeClr>
+    </dgm:fillClrLst>
+    <dgm:linClrLst meth="repeat">
+      <a:schemeClr val="accent4"/>
+    </dgm:linClrLst>
+    <dgm:effectClrLst/>
+    <dgm:txLinClrLst/>
+    <dgm:txFillClrLst meth="repeat">
+      <a:schemeClr val="tx1"/>
+    </dgm:txFillClrLst>
+    <dgm:txEffectClrLst/>
+  </dgm:styleLbl>
+  <dgm:styleLbl name="fgAcc1">
+    <dgm:fillClrLst meth="repeat">
+      <a:schemeClr val="lt1">
+        <a:alpha val="90000"/>
+      </a:schemeClr>
+    </dgm:fillClrLst>
+    <dgm:linClrLst meth="repeat">
+      <a:schemeClr val="accent2"/>
+      <a:schemeClr val="accent3"/>
+      <a:schemeClr val="accent4"/>
+      <a:schemeClr val="accent5"/>
+      <a:schemeClr val="accent6"/>
+    </dgm:linClrLst>
+    <dgm:effectClrLst/>
+    <dgm:txLinClrLst/>
+    <dgm:txFillClrLst meth="repeat">
+      <a:schemeClr val="dk1"/>
+    </dgm:txFillClrLst>
+    <dgm:txEffectClrLst/>
+  </dgm:styleLbl>
+  <dgm:styleLbl name="conFgAcc1">
+    <dgm:fillClrLst meth="repeat">
+      <a:schemeClr val="lt1">
+        <a:alpha val="90000"/>
+      </a:schemeClr>
+    </dgm:fillClrLst>
+    <dgm:linClrLst meth="repeat">
+      <a:schemeClr val="accent2"/>
+      <a:schemeClr val="accent3"/>
+      <a:schemeClr val="accent4"/>
+      <a:schemeClr val="accent5"/>
+      <a:schemeClr val="accent6"/>
+    </dgm:linClrLst>
+    <dgm:effectClrLst/>
+    <dgm:txLinClrLst/>
+    <dgm:txFillClrLst meth="repeat">
+      <a:schemeClr val="dk1"/>
+    </dgm:txFillClrLst>
+    <dgm:txEffectClrLst/>
+  </dgm:styleLbl>
+  <dgm:styleLbl name="alignAcc1">
+    <dgm:fillClrLst meth="repeat">
+      <a:schemeClr val="lt1">
+        <a:alpha val="90000"/>
+      </a:schemeClr>
+    </dgm:fillClrLst>
+    <dgm:linClrLst meth="repeat">
+      <a:schemeClr val="accent2"/>
+      <a:schemeClr val="accent3"/>
+      <a:schemeClr val="accent4"/>
+      <a:schemeClr val="accent5"/>
+      <a:schemeClr val="accent6"/>
+    </dgm:linClrLst>
+    <dgm:effectClrLst/>
+    <dgm:txLinClrLst/>
+    <dgm:txFillClrLst meth="repeat">
+      <a:schemeClr val="dk1"/>
+    </dgm:txFillClrLst>
+    <dgm:txEffectClrLst/>
+  </dgm:styleLbl>
+  <dgm:styleLbl name="trAlignAcc1">
+    <dgm:fillClrLst meth="repeat">
+      <a:schemeClr val="lt1">
+        <a:alpha val="40000"/>
+      </a:schemeClr>
+    </dgm:fillClrLst>
+    <dgm:linClrLst meth="repeat">
+      <a:schemeClr val="accent1"/>
+    </dgm:linClrLst>
+    <dgm:effectClrLst/>
+    <dgm:txLinClrLst/>
+    <dgm:txFillClrLst meth="repeat">
+      <a:schemeClr val="dk1"/>
+    </dgm:txFillClrLst>
+    <dgm:txEffectClrLst/>
+  </dgm:styleLbl>
+  <dgm:styleLbl name="bgAcc1">
+    <dgm:fillClrLst meth="repeat">
+      <a:schemeClr val="lt1">
+        <a:alpha val="90000"/>
+      </a:schemeClr>
+    </dgm:fillClrLst>
+    <dgm:linClrLst meth="repeat">
+      <a:schemeClr val="accent2"/>
+      <a:schemeClr val="accent3"/>
+      <a:schemeClr val="accent4"/>
+      <a:schemeClr val="accent5"/>
+      <a:schemeClr val="accent6"/>
+    </dgm:linClrLst>
+    <dgm:effectClrLst/>
+    <dgm:txLinClrLst/>
+    <dgm:txFillClrLst meth="repeat">
+      <a:schemeClr val="dk1"/>
+    </dgm:txFillClrLst>
+    <dgm:txEffectClrLst/>
+  </dgm:styleLbl>
+  <dgm:styleLbl name="solidFgAcc1">
+    <dgm:fillClrLst meth="repeat">
+      <a:schemeClr val="lt1"/>
+    </dgm:fillClrLst>
+    <dgm:linClrLst meth="repeat">
+      <a:schemeClr val="accent2"/>
+      <a:schemeClr val="accent3"/>
+      <a:schemeClr val="accent4"/>
+      <a:schemeClr val="accent5"/>
+      <a:schemeClr val="accent6"/>
+    </dgm:linClrLst>
+    <dgm:effectClrLst/>
+    <dgm:txLinClrLst/>
+    <dgm:txFillClrLst meth="repeat">
+      <a:schemeClr val="dk1"/>
+    </dgm:txFillClrLst>
+    <dgm:txEffectClrLst/>
+  </dgm:styleLbl>
+  <dgm:styleLbl name="solidAlignAcc1">
+    <dgm:fillClrLst meth="repeat">
+      <a:schemeClr val="lt1"/>
+    </dgm:fillClrLst>
+    <dgm:linClrLst meth="repeat">
+      <a:schemeClr val="accent2"/>
+      <a:schemeClr val="accent3"/>
+      <a:schemeClr val="accent4"/>
+      <a:schemeClr val="accent5"/>
+      <a:schemeClr val="accent6"/>
+    </dgm:linClrLst>
+    <dgm:effectClrLst/>
+    <dgm:txLinClrLst/>
+    <dgm:txFillClrLst meth="repeat">
+      <a:schemeClr val="dk1"/>
+    </dgm:txFillClrLst>
+    <dgm:txEffectClrLst/>
+  </dgm:styleLbl>
+  <dgm:styleLbl name="solidBgAcc1">
+    <dgm:fillClrLst meth="repeat">
+      <a:schemeClr val="lt1"/>
+    </dgm:fillClrLst>
+    <dgm:linClrLst meth="repeat">
+      <a:schemeClr val="accent2"/>
+      <a:schemeClr val="accent3"/>
+      <a:schemeClr val="accent4"/>
+      <a:schemeClr val="accent5"/>
+      <a:schemeClr val="accent6"/>
+    </dgm:linClrLst>
+    <dgm:effectClrLst/>
+    <dgm:txLinClrLst/>
+    <dgm:txFillClrLst meth="repeat">
+      <a:schemeClr val="dk1"/>
+    </dgm:txFillClrLst>
+    <dgm:txEffectClrLst/>
+  </dgm:styleLbl>
+  <dgm:styleLbl name="fgAccFollowNode1">
+    <dgm:fillClrLst meth="repeat">
+      <a:schemeClr val="accent2">
+        <a:tint val="40000"/>
+        <a:alpha val="90000"/>
+      </a:schemeClr>
+      <a:schemeClr val="accent3">
+        <a:tint val="40000"/>
+        <a:alpha val="90000"/>
+      </a:schemeClr>
+      <a:schemeClr val="accent4">
+        <a:tint val="40000"/>
+        <a:alpha val="90000"/>
+      </a:schemeClr>
+      <a:schemeClr val="accent5">
+        <a:tint val="40000"/>
+        <a:alpha val="90000"/>
+      </a:schemeClr>
+      <a:schemeClr val="accent6">
+        <a:tint val="40000"/>
+        <a:alpha val="90000"/>
+      </a:schemeClr>
+    </dgm:fillClrLst>
+    <dgm:linClrLst meth="repeat">
+      <a:schemeClr val="accent2">
+        <a:tint val="40000"/>
+        <a:alpha val="90000"/>
+      </a:schemeClr>
+      <a:schemeClr val="accent3">
+        <a:tint val="40000"/>
+        <a:alpha val="90000"/>
+      </a:schemeClr>
+      <a:schemeClr val="accent4">
+        <a:tint val="40000"/>
+        <a:alpha val="90000"/>
+      </a:schemeClr>
+      <a:schemeClr val="accent5">
+        <a:tint val="40000"/>
+        <a:alpha val="90000"/>
+      </a:schemeClr>
+      <a:schemeClr val="accent6">
+        <a:tint val="40000"/>
+        <a:alpha val="90000"/>
+      </a:schemeClr>
+    </dgm:linClrLst>
+    <dgm:effectClrLst/>
+    <dgm:txLinClrLst/>
+    <dgm:txFillClrLst meth="repeat">
+      <a:schemeClr val="dk1"/>
+    </dgm:txFillClrLst>
+    <dgm:txEffectClrLst/>
+  </dgm:styleLbl>
+  <dgm:styleLbl name="alignAccFollowNode1">
+    <dgm:fillClrLst meth="repeat">
+      <a:schemeClr val="accent2">
+        <a:tint val="40000"/>
+        <a:alpha val="90000"/>
+      </a:schemeClr>
+      <a:schemeClr val="accent3">
+        <a:tint val="40000"/>
+        <a:alpha val="90000"/>
+      </a:schemeClr>
+      <a:schemeClr val="accent4">
+        <a:tint val="40000"/>
+        <a:alpha val="90000"/>
+      </a:schemeClr>
+      <a:schemeClr val="accent5">
+        <a:tint val="40000"/>
+        <a:alpha val="90000"/>
+      </a:schemeClr>
+      <a:schemeClr val="accent6">
+        <a:tint val="40000"/>
+        <a:alpha val="90000"/>
+      </a:schemeClr>
+    </dgm:fillClrLst>
+    <dgm:linClrLst meth="repeat">
+      <a:schemeClr val="accent2">
+        <a:tint val="40000"/>
+        <a:alpha val="90000"/>
+      </a:schemeClr>
+      <a:schemeClr val="accent3">
+        <a:tint val="40000"/>
+        <a:alpha val="90000"/>
+      </a:schemeClr>
+      <a:schemeClr val="accent4">
+        <a:tint val="40000"/>
+        <a:alpha val="90000"/>
+      </a:schemeClr>
+      <a:schemeClr val="accent5">
+        <a:tint val="40000"/>
+        <a:alpha val="90000"/>
+      </a:schemeClr>
+      <a:schemeClr val="accent6">
+        <a:tint val="40000"/>
+        <a:alpha val="90000"/>
+      </a:schemeClr>
+    </dgm:linClrLst>
+    <dgm:effectClrLst/>
+    <dgm:txLinClrLst/>
+    <dgm:txFillClrLst meth="repeat">
+      <a:schemeClr val="dk1"/>
+    </dgm:txFillClrLst>
+    <dgm:txEffectClrLst/>
+  </dgm:styleLbl>
+  <dgm:styleLbl name="bgAccFollowNode1">
+    <dgm:fillClrLst meth="repeat">
+      <a:schemeClr val="accent2">
+        <a:tint val="40000"/>
+        <a:alpha val="90000"/>
+      </a:schemeClr>
+      <a:schemeClr val="accent3">
+        <a:tint val="40000"/>
+        <a:alpha val="90000"/>
+      </a:schemeClr>
+      <a:schemeClr val="accent4">
+        <a:tint val="40000"/>
+        <a:alpha val="90000"/>
+      </a:schemeClr>
+      <a:schemeClr val="accent5">
+        <a:tint val="40000"/>
+        <a:alpha val="90000"/>
+      </a:schemeClr>
+      <a:schemeClr val="accent6">
+        <a:tint val="40000"/>
+        <a:alpha val="90000"/>
+      </a:schemeClr>
+    </dgm:fillClrLst>
+    <dgm:linClrLst meth="repeat">
+      <a:schemeClr val="accent2">
+        <a:tint val="40000"/>
+        <a:alpha val="90000"/>
+      </a:schemeClr>
+      <a:schemeClr val="accent3">
+        <a:tint val="40000"/>
+        <a:alpha val="90000"/>
+      </a:schemeClr>
+      <a:schemeClr val="accent4">
+        <a:tint val="40000"/>
+        <a:alpha val="90000"/>
+      </a:schemeClr>
+      <a:schemeClr val="accent5">
+        <a:tint val="40000"/>
+        <a:alpha val="90000"/>
+      </a:schemeClr>
+      <a:schemeClr val="accent6">
+        <a:tint val="40000"/>
+        <a:alpha val="90000"/>
+      </a:schemeClr>
+    </dgm:linClrLst>
+    <dgm:effectClrLst/>
+    <dgm:txLinClrLst/>
+    <dgm:txFillClrLst meth="repeat">
+      <a:schemeClr val="dk1"/>
+    </dgm:txFillClrLst>
+    <dgm:txEffectClrLst/>
+  </dgm:styleLbl>
+  <dgm:styleLbl name="fgAcc0">
+    <dgm:fillClrLst meth="repeat">
+      <a:schemeClr val="lt1">
+        <a:alpha val="90000"/>
+      </a:schemeClr>
+    </dgm:fillClrLst>
+    <dgm:linClrLst>
+      <a:schemeClr val="accent1"/>
+    </dgm:linClrLst>
+    <dgm:effectClrLst/>
+    <dgm:txLinClrLst/>
+    <dgm:txFillClrLst meth="repeat">
+      <a:schemeClr val="dk1"/>
+    </dgm:txFillClrLst>
+    <dgm:txEffectClrLst/>
+  </dgm:styleLbl>
+  <dgm:styleLbl name="fgAcc2">
+    <dgm:fillClrLst meth="repeat">
+      <a:schemeClr val="lt1">
+        <a:alpha val="90000"/>
+      </a:schemeClr>
+    </dgm:fillClrLst>
+    <dgm:linClrLst>
+      <a:schemeClr val="accent2"/>
+    </dgm:linClrLst>
+    <dgm:effectClrLst/>
+    <dgm:txLinClrLst/>
+    <dgm:txFillClrLst meth="repeat">
+      <a:schemeClr val="dk1"/>
+    </dgm:txFillClrLst>
+    <dgm:txEffectClrLst/>
+  </dgm:styleLbl>
+  <dgm:styleLbl name="fgAcc3">
+    <dgm:fillClrLst meth="repeat">
+      <a:schemeClr val="lt1">
+        <a:alpha val="90000"/>
+      </a:schemeClr>
+    </dgm:fillClrLst>
+    <dgm:linClrLst>
+      <a:schemeClr val="accent3"/>
+    </dgm:linClrLst>
+    <dgm:effectClrLst/>
+    <dgm:txLinClrLst/>
+    <dgm:txFillClrLst meth="repeat">
+      <a:schemeClr val="dk1"/>
+    </dgm:txFillClrLst>
+    <dgm:txEffectClrLst/>
+  </dgm:styleLbl>
+  <dgm:styleLbl name="fgAcc4">
+    <dgm:fillClrLst meth="repeat">
+      <a:schemeClr val="lt1">
+        <a:alpha val="90000"/>
+      </a:schemeClr>
+    </dgm:fillClrLst>
+    <dgm:linClrLst>
+      <a:schemeClr val="accent4"/>
+    </dgm:linClrLst>
+    <dgm:effectClrLst/>
+    <dgm:txLinClrLst/>
+    <dgm:txFillClrLst meth="repeat">
+      <a:schemeClr val="dk1"/>
+    </dgm:txFillClrLst>
+    <dgm:txEffectClrLst/>
+  </dgm:styleLbl>
+  <dgm:styleLbl name="bgShp">
+    <dgm:fillClrLst meth="repeat">
+      <a:schemeClr val="accent2"/>
+      <a:schemeClr val="accent3"/>
+      <a:schemeClr val="accent4"/>
+      <a:schemeClr val="accent5"/>
+      <a:schemeClr val="accent6"/>
+    </dgm:fillClrLst>
+    <dgm:linClrLst meth="repeat">
+      <a:schemeClr val="lt1">
+        <a:alpha val="0"/>
+      </a:schemeClr>
+    </dgm:linClrLst>
+    <dgm:effectClrLst/>
+    <dgm:txLinClrLst/>
+    <dgm:txFillClrLst/>
+    <dgm:txEffectClrLst/>
+  </dgm:styleLbl>
+  <dgm:styleLbl name="dkBgShp">
+    <dgm:fillClrLst meth="repeat">
+      <a:schemeClr val="accent2">
+        <a:shade val="90000"/>
+      </a:schemeClr>
+    </dgm:fillClrLst>
+    <dgm:linClrLst meth="repeat">
+      <a:schemeClr val="dk1"/>
+    </dgm:linClrLst>
+    <dgm:effectClrLst/>
+    <dgm:txLinClrLst/>
+    <dgm:txFillClrLst meth="repeat">
+      <a:schemeClr val="lt1"/>
+    </dgm:txFillClrLst>
+    <dgm:txEffectClrLst/>
+  </dgm:styleLbl>
+  <dgm:styleLbl name="trBgShp">
+    <dgm:fillClrLst meth="repeat">
+      <a:schemeClr val="accent1">
+        <a:tint val="50000"/>
+        <a:alpha val="40000"/>
+      </a:schemeClr>
+    </dgm:fillClrLst>
+    <dgm:linClrLst meth="repeat">
+      <a:schemeClr val="accent2"/>
+    </dgm:linClrLst>
+    <dgm:effectClrLst/>
+    <dgm:txLinClrLst/>
+    <dgm:txFillClrLst meth="repeat">
+      <a:schemeClr val="lt1"/>
+    </dgm:txFillClrLst>
+    <dgm:txEffectClrLst/>
+  </dgm:styleLbl>
+  <dgm:styleLbl name="fgShp">
+    <dgm:fillClrLst meth="repeat">
+      <a:schemeClr val="accent2">
+        <a:tint val="40000"/>
+      </a:schemeClr>
+    </dgm:fillClrLst>
+    <dgm:linClrLst meth="repeat">
+      <a:schemeClr val="lt1"/>
+    </dgm:linClrLst>
+    <dgm:effectClrLst/>
+    <dgm:txLinClrLst/>
+    <dgm:txFillClrLst meth="repeat">
+      <a:schemeClr val="dk1"/>
+    </dgm:txFillClrLst>
+    <dgm:txEffectClrLst/>
+  </dgm:styleLbl>
+  <dgm:styleLbl name="revTx">
+    <dgm:fillClrLst meth="repeat">
+      <a:schemeClr val="lt1">
+        <a:alpha val="0"/>
+      </a:schemeClr>
+    </dgm:fillClrLst>
+    <dgm:linClrLst meth="repeat">
+      <a:schemeClr val="dk1">
+        <a:alpha val="0"/>
+      </a:schemeClr>
+    </dgm:linClrLst>
+    <dgm:effectClrLst/>
+    <dgm:txLinClrLst/>
+    <dgm:txFillClrLst meth="repeat">
+      <a:schemeClr val="bg1"/>
     </dgm:txFillClrLst>
     <dgm:txEffectClrLst/>
   </dgm:styleLbl>
@@ -5575,6 +6640,446 @@
   <dgm:extLst>
     <a:ext uri="http://schemas.microsoft.com/office/drawing/2008/diagram">
       <dsp:dataModelExt xmlns:dsp="http://schemas.microsoft.com/office/drawing/2008/diagram" relId="rId6" minVer="http://schemas.openxmlformats.org/drawingml/2006/diagram"/>
+    </a:ext>
+  </dgm:extLst>
+</dgm:dataModel>
+</file>
+
+<file path=ppt/diagrams/data4.xml><?xml version="1.0" encoding="utf-8"?>
+<dgm:dataModel xmlns:dgm="http://schemas.openxmlformats.org/drawingml/2006/diagram" xmlns:a="http://schemas.openxmlformats.org/drawingml/2006/main">
+  <dgm:ptLst>
+    <dgm:pt modelId="{0509E7B3-079C-41FA-BD65-DE38A38DC459}" type="doc">
+      <dgm:prSet loTypeId="urn:microsoft.com/office/officeart/2018/2/layout/IconVerticalSolidList" loCatId="icon" qsTypeId="urn:microsoft.com/office/officeart/2005/8/quickstyle/simple1" qsCatId="simple" csTypeId="urn:microsoft.com/office/officeart/2018/5/colors/Iconchunking_neutralicontext_colorful1" csCatId="colorful" phldr="1"/>
+      <dgm:spPr/>
+      <dgm:t>
+        <a:bodyPr/>
+        <a:lstStyle/>
+        <a:p>
+          <a:endParaRPr lang="en-US"/>
+        </a:p>
+      </dgm:t>
+    </dgm:pt>
+    <dgm:pt modelId="{6C01B371-272E-46B1-9056-01850AA5F5F1}">
+      <dgm:prSet/>
+      <dgm:spPr/>
+      <dgm:t>
+        <a:bodyPr/>
+        <a:lstStyle/>
+        <a:p>
+          <a:r>
+            <a:rPr lang="en-GB" dirty="0"/>
+            <a:t>Feature reduction techniques, including PCA, </a:t>
+          </a:r>
+          <a:r>
+            <a:rPr lang="en-GB" dirty="0" err="1"/>
+            <a:t>AutoEncoder</a:t>
+          </a:r>
+          <a:r>
+            <a:rPr lang="en-GB" dirty="0"/>
+            <a:t>, generally lead to a decrease in model performance, particularly in terms of accuracy and F1 score.</a:t>
+          </a:r>
+          <a:endParaRPr lang="en-US" dirty="0"/>
+        </a:p>
+      </dgm:t>
+    </dgm:pt>
+    <dgm:pt modelId="{C2236C7E-2A1C-4413-AC08-D4FA2674993C}" type="parTrans" cxnId="{2B95627D-FC7A-468E-BC2B-1902223D83A5}">
+      <dgm:prSet/>
+      <dgm:spPr/>
+      <dgm:t>
+        <a:bodyPr/>
+        <a:lstStyle/>
+        <a:p>
+          <a:endParaRPr lang="en-US"/>
+        </a:p>
+      </dgm:t>
+    </dgm:pt>
+    <dgm:pt modelId="{C96F95ED-D73C-4A91-B178-FE0E13419EA5}" type="sibTrans" cxnId="{2B95627D-FC7A-468E-BC2B-1902223D83A5}">
+      <dgm:prSet/>
+      <dgm:spPr/>
+      <dgm:t>
+        <a:bodyPr/>
+        <a:lstStyle/>
+        <a:p>
+          <a:endParaRPr lang="en-US"/>
+        </a:p>
+      </dgm:t>
+    </dgm:pt>
+    <dgm:pt modelId="{33D176D9-92CB-4E8E-B745-2A02B4C7CEBE}">
+      <dgm:prSet/>
+      <dgm:spPr/>
+      <dgm:t>
+        <a:bodyPr/>
+        <a:lstStyle/>
+        <a:p>
+          <a:r>
+            <a:rPr lang="en-GB" dirty="0"/>
+            <a:t>If</a:t>
+          </a:r>
+          <a:r>
+            <a:rPr lang="zh-CN" dirty="0"/>
+            <a:t> </a:t>
+          </a:r>
+          <a:r>
+            <a:rPr lang="en-GB" dirty="0"/>
+            <a:t>a certain degree of performance degradation is acceptable, more aggressive dimensionality reduction can be applied to significantly reduce feature size and computational cost.</a:t>
+          </a:r>
+          <a:endParaRPr lang="en-US" dirty="0"/>
+        </a:p>
+      </dgm:t>
+    </dgm:pt>
+    <dgm:pt modelId="{8167A301-4BBC-49AB-9E7C-BB0B757D9B24}" type="parTrans" cxnId="{9218B108-E577-49B0-9C0F-DE1FDFE15E83}">
+      <dgm:prSet/>
+      <dgm:spPr/>
+      <dgm:t>
+        <a:bodyPr/>
+        <a:lstStyle/>
+        <a:p>
+          <a:endParaRPr lang="en-US"/>
+        </a:p>
+      </dgm:t>
+    </dgm:pt>
+    <dgm:pt modelId="{59AC3FCC-86BE-45A7-8004-B7E72EF7A6C2}" type="sibTrans" cxnId="{9218B108-E577-49B0-9C0F-DE1FDFE15E83}">
+      <dgm:prSet/>
+      <dgm:spPr/>
+      <dgm:t>
+        <a:bodyPr/>
+        <a:lstStyle/>
+        <a:p>
+          <a:endParaRPr lang="en-US"/>
+        </a:p>
+      </dgm:t>
+    </dgm:pt>
+    <dgm:pt modelId="{DD6F7A4C-D8C6-464A-9378-C0F2D9EDC8A0}">
+      <dgm:prSet/>
+      <dgm:spPr/>
+      <dgm:t>
+        <a:bodyPr/>
+        <a:lstStyle/>
+        <a:p>
+          <a:r>
+            <a:rPr lang="en-GB"/>
+            <a:t>ResNeXt introduces high CPU overhead when applied to low-dimensional flow-level data, without improving accuracy or F1 score, making it unsuitable for deployment on edge devices. In contrast, PCA and AutoEncoder show no significant resource bottlenecks and are more suitable for edge-based IDS.</a:t>
+          </a:r>
+          <a:endParaRPr lang="en-US"/>
+        </a:p>
+      </dgm:t>
+    </dgm:pt>
+    <dgm:pt modelId="{FE4C140A-A898-4ED0-B114-459E053CE701}" type="parTrans" cxnId="{233439FD-CC01-4B63-85EA-1434B42C23BA}">
+      <dgm:prSet/>
+      <dgm:spPr/>
+      <dgm:t>
+        <a:bodyPr/>
+        <a:lstStyle/>
+        <a:p>
+          <a:endParaRPr lang="en-US"/>
+        </a:p>
+      </dgm:t>
+    </dgm:pt>
+    <dgm:pt modelId="{7F630590-6EB7-4DD7-9E39-1BF1548D29F2}" type="sibTrans" cxnId="{233439FD-CC01-4B63-85EA-1434B42C23BA}">
+      <dgm:prSet/>
+      <dgm:spPr/>
+      <dgm:t>
+        <a:bodyPr/>
+        <a:lstStyle/>
+        <a:p>
+          <a:endParaRPr lang="en-US"/>
+        </a:p>
+      </dgm:t>
+    </dgm:pt>
+    <dgm:pt modelId="{B4C6CB0E-67F5-4965-8270-9D8203C5F71A}">
+      <dgm:prSet/>
+      <dgm:spPr/>
+      <dgm:t>
+        <a:bodyPr/>
+        <a:lstStyle/>
+        <a:p>
+          <a:r>
+            <a:rPr lang="en-GB"/>
+            <a:t>Feature reduction reduces performance but improves efficiency; PCA and AutoEncoder are edge-friendly, while ResNeXt is computationally expensive and ineffective for low-dimensional data.</a:t>
+          </a:r>
+          <a:endParaRPr lang="en-US"/>
+        </a:p>
+      </dgm:t>
+    </dgm:pt>
+    <dgm:pt modelId="{A33EA111-F655-4444-A541-BC090C7BC1F6}" type="parTrans" cxnId="{A7F419D8-D2A0-4D1C-9A54-F92607C3F734}">
+      <dgm:prSet/>
+      <dgm:spPr/>
+      <dgm:t>
+        <a:bodyPr/>
+        <a:lstStyle/>
+        <a:p>
+          <a:endParaRPr lang="en-US"/>
+        </a:p>
+      </dgm:t>
+    </dgm:pt>
+    <dgm:pt modelId="{460AB618-9480-4A58-B29D-EF819ACC12E9}" type="sibTrans" cxnId="{A7F419D8-D2A0-4D1C-9A54-F92607C3F734}">
+      <dgm:prSet/>
+      <dgm:spPr/>
+      <dgm:t>
+        <a:bodyPr/>
+        <a:lstStyle/>
+        <a:p>
+          <a:endParaRPr lang="en-US"/>
+        </a:p>
+      </dgm:t>
+    </dgm:pt>
+    <dgm:pt modelId="{2952F401-2612-4806-B4E8-2AA51D44616C}" type="pres">
+      <dgm:prSet presAssocID="{0509E7B3-079C-41FA-BD65-DE38A38DC459}" presName="root" presStyleCnt="0">
+        <dgm:presLayoutVars>
+          <dgm:dir/>
+          <dgm:resizeHandles val="exact"/>
+        </dgm:presLayoutVars>
+      </dgm:prSet>
+      <dgm:spPr/>
+    </dgm:pt>
+    <dgm:pt modelId="{455BDFD6-FBAE-468C-B00D-92C8952B9CD4}" type="pres">
+      <dgm:prSet presAssocID="{6C01B371-272E-46B1-9056-01850AA5F5F1}" presName="compNode" presStyleCnt="0"/>
+      <dgm:spPr/>
+    </dgm:pt>
+    <dgm:pt modelId="{72968954-DE26-4C17-96EF-E48DD42A9430}" type="pres">
+      <dgm:prSet presAssocID="{6C01B371-272E-46B1-9056-01850AA5F5F1}" presName="bgRect" presStyleLbl="bgShp" presStyleIdx="0" presStyleCnt="4"/>
+      <dgm:spPr/>
+    </dgm:pt>
+    <dgm:pt modelId="{3BE2EC3C-E37D-4B6B-8CE6-2E5C07FAFC2B}" type="pres">
+      <dgm:prSet presAssocID="{6C01B371-272E-46B1-9056-01850AA5F5F1}" presName="iconRect" presStyleLbl="node1" presStyleIdx="0" presStyleCnt="4"/>
+      <dgm:spPr>
+        <a:blipFill>
+          <a:blip xmlns:r="http://schemas.openxmlformats.org/officeDocument/2006/relationships">
+            <a:extLst>
+              <a:ext uri="{28A0092B-C50C-407E-A947-70E740481C1C}">
+                <a14:useLocalDpi xmlns:a14="http://schemas.microsoft.com/office/drawing/2010/main" val="0"/>
+              </a:ext>
+              <a:ext uri="{96DAC541-7B7A-43D3-8B79-37D633B846F1}">
+                <asvg:svgBlip xmlns:asvg="http://schemas.microsoft.com/office/drawing/2016/SVG/main" r:embed="rId1"/>
+              </a:ext>
+            </a:extLst>
+          </a:blip>
+          <a:stretch>
+            <a:fillRect/>
+          </a:stretch>
+        </a:blipFill>
+        <a:ln>
+          <a:noFill/>
+        </a:ln>
+      </dgm:spPr>
+      <dgm:extLst>
+        <a:ext uri="{E40237B7-FDA0-4F09-8148-C483321AD2D9}">
+          <dgm14:cNvPr xmlns:dgm14="http://schemas.microsoft.com/office/drawing/2010/diagram" id="0" name="" descr="Branching Diagram"/>
+        </a:ext>
+      </dgm:extLst>
+    </dgm:pt>
+    <dgm:pt modelId="{7F542A8F-D0F4-42C6-B2DD-9D8671F97ACD}" type="pres">
+      <dgm:prSet presAssocID="{6C01B371-272E-46B1-9056-01850AA5F5F1}" presName="spaceRect" presStyleCnt="0"/>
+      <dgm:spPr/>
+    </dgm:pt>
+    <dgm:pt modelId="{DD9611CE-201A-4FB8-9005-5C611C691615}" type="pres">
+      <dgm:prSet presAssocID="{6C01B371-272E-46B1-9056-01850AA5F5F1}" presName="parTx" presStyleLbl="revTx" presStyleIdx="0" presStyleCnt="4">
+        <dgm:presLayoutVars>
+          <dgm:chMax val="0"/>
+          <dgm:chPref val="0"/>
+        </dgm:presLayoutVars>
+      </dgm:prSet>
+      <dgm:spPr/>
+    </dgm:pt>
+    <dgm:pt modelId="{EE99FFA4-BF94-493F-82F8-631D7CADAB1C}" type="pres">
+      <dgm:prSet presAssocID="{C96F95ED-D73C-4A91-B178-FE0E13419EA5}" presName="sibTrans" presStyleCnt="0"/>
+      <dgm:spPr/>
+    </dgm:pt>
+    <dgm:pt modelId="{37D67F16-B9F1-41F2-A195-448293B493A8}" type="pres">
+      <dgm:prSet presAssocID="{33D176D9-92CB-4E8E-B745-2A02B4C7CEBE}" presName="compNode" presStyleCnt="0"/>
+      <dgm:spPr/>
+    </dgm:pt>
+    <dgm:pt modelId="{7D7B6B63-E17E-4C7B-960E-0E4E680C401F}" type="pres">
+      <dgm:prSet presAssocID="{33D176D9-92CB-4E8E-B745-2A02B4C7CEBE}" presName="bgRect" presStyleLbl="bgShp" presStyleIdx="1" presStyleCnt="4"/>
+      <dgm:spPr/>
+    </dgm:pt>
+    <dgm:pt modelId="{7A491E4D-D7D9-47F0-B258-C776B64A9D17}" type="pres">
+      <dgm:prSet presAssocID="{33D176D9-92CB-4E8E-B745-2A02B4C7CEBE}" presName="iconRect" presStyleLbl="node1" presStyleIdx="1" presStyleCnt="4"/>
+      <dgm:spPr>
+        <a:blipFill>
+          <a:blip xmlns:r="http://schemas.openxmlformats.org/officeDocument/2006/relationships">
+            <a:extLst>
+              <a:ext uri="{28A0092B-C50C-407E-A947-70E740481C1C}">
+                <a14:useLocalDpi xmlns:a14="http://schemas.microsoft.com/office/drawing/2010/main" val="0"/>
+              </a:ext>
+              <a:ext uri="{96DAC541-7B7A-43D3-8B79-37D633B846F1}">
+                <asvg:svgBlip xmlns:asvg="http://schemas.microsoft.com/office/drawing/2016/SVG/main" r:embed="rId2"/>
+              </a:ext>
+            </a:extLst>
+          </a:blip>
+          <a:stretch>
+            <a:fillRect/>
+          </a:stretch>
+        </a:blipFill>
+        <a:ln>
+          <a:noFill/>
+        </a:ln>
+      </dgm:spPr>
+      <dgm:extLst>
+        <a:ext uri="{E40237B7-FDA0-4F09-8148-C483321AD2D9}">
+          <dgm14:cNvPr xmlns:dgm14="http://schemas.microsoft.com/office/drawing/2010/diagram" id="0" name="" descr="Speed Bump"/>
+        </a:ext>
+      </dgm:extLst>
+    </dgm:pt>
+    <dgm:pt modelId="{A2A53907-D5B9-4E58-929B-82B0721455F6}" type="pres">
+      <dgm:prSet presAssocID="{33D176D9-92CB-4E8E-B745-2A02B4C7CEBE}" presName="spaceRect" presStyleCnt="0"/>
+      <dgm:spPr/>
+    </dgm:pt>
+    <dgm:pt modelId="{4BD72CD7-94F7-46A3-A4EB-66B07FA78D22}" type="pres">
+      <dgm:prSet presAssocID="{33D176D9-92CB-4E8E-B745-2A02B4C7CEBE}" presName="parTx" presStyleLbl="revTx" presStyleIdx="1" presStyleCnt="4">
+        <dgm:presLayoutVars>
+          <dgm:chMax val="0"/>
+          <dgm:chPref val="0"/>
+        </dgm:presLayoutVars>
+      </dgm:prSet>
+      <dgm:spPr/>
+    </dgm:pt>
+    <dgm:pt modelId="{B0D9BADF-7F73-4512-A365-8CBC650C9B7C}" type="pres">
+      <dgm:prSet presAssocID="{59AC3FCC-86BE-45A7-8004-B7E72EF7A6C2}" presName="sibTrans" presStyleCnt="0"/>
+      <dgm:spPr/>
+    </dgm:pt>
+    <dgm:pt modelId="{3C04544D-F763-43CE-847D-C250D5A13A77}" type="pres">
+      <dgm:prSet presAssocID="{DD6F7A4C-D8C6-464A-9378-C0F2D9EDC8A0}" presName="compNode" presStyleCnt="0"/>
+      <dgm:spPr/>
+    </dgm:pt>
+    <dgm:pt modelId="{0097AA3F-F4F5-45BD-92D5-6CADAA1CF95B}" type="pres">
+      <dgm:prSet presAssocID="{DD6F7A4C-D8C6-464A-9378-C0F2D9EDC8A0}" presName="bgRect" presStyleLbl="bgShp" presStyleIdx="2" presStyleCnt="4"/>
+      <dgm:spPr/>
+    </dgm:pt>
+    <dgm:pt modelId="{02E2FF33-9FF8-4CA4-BB7E-AF19AFB912A8}" type="pres">
+      <dgm:prSet presAssocID="{DD6F7A4C-D8C6-464A-9378-C0F2D9EDC8A0}" presName="iconRect" presStyleLbl="node1" presStyleIdx="2" presStyleCnt="4"/>
+      <dgm:spPr>
+        <a:blipFill>
+          <a:blip xmlns:r="http://schemas.openxmlformats.org/officeDocument/2006/relationships">
+            <a:extLst>
+              <a:ext uri="{28A0092B-C50C-407E-A947-70E740481C1C}">
+                <a14:useLocalDpi xmlns:a14="http://schemas.microsoft.com/office/drawing/2010/main" val="0"/>
+              </a:ext>
+              <a:ext uri="{96DAC541-7B7A-43D3-8B79-37D633B846F1}">
+                <asvg:svgBlip xmlns:asvg="http://schemas.microsoft.com/office/drawing/2016/SVG/main" r:embed="rId3"/>
+              </a:ext>
+            </a:extLst>
+          </a:blip>
+          <a:stretch>
+            <a:fillRect/>
+          </a:stretch>
+        </a:blipFill>
+        <a:ln>
+          <a:noFill/>
+        </a:ln>
+      </dgm:spPr>
+      <dgm:extLst>
+        <a:ext uri="{E40237B7-FDA0-4F09-8148-C483321AD2D9}">
+          <dgm14:cNvPr xmlns:dgm14="http://schemas.microsoft.com/office/drawing/2010/diagram" id="0" name="" descr="Processor"/>
+        </a:ext>
+      </dgm:extLst>
+    </dgm:pt>
+    <dgm:pt modelId="{2B91FDD1-0EAA-49E1-8F3F-B7BC044C515A}" type="pres">
+      <dgm:prSet presAssocID="{DD6F7A4C-D8C6-464A-9378-C0F2D9EDC8A0}" presName="spaceRect" presStyleCnt="0"/>
+      <dgm:spPr/>
+    </dgm:pt>
+    <dgm:pt modelId="{E5163663-6809-4479-937C-CC4F9D8F7750}" type="pres">
+      <dgm:prSet presAssocID="{DD6F7A4C-D8C6-464A-9378-C0F2D9EDC8A0}" presName="parTx" presStyleLbl="revTx" presStyleIdx="2" presStyleCnt="4">
+        <dgm:presLayoutVars>
+          <dgm:chMax val="0"/>
+          <dgm:chPref val="0"/>
+        </dgm:presLayoutVars>
+      </dgm:prSet>
+      <dgm:spPr/>
+    </dgm:pt>
+    <dgm:pt modelId="{529D4391-9351-4486-881E-17DF90736A4B}" type="pres">
+      <dgm:prSet presAssocID="{7F630590-6EB7-4DD7-9E39-1BF1548D29F2}" presName="sibTrans" presStyleCnt="0"/>
+      <dgm:spPr/>
+    </dgm:pt>
+    <dgm:pt modelId="{AA5CFE7C-6206-4318-996C-524133CB0AE3}" type="pres">
+      <dgm:prSet presAssocID="{B4C6CB0E-67F5-4965-8270-9D8203C5F71A}" presName="compNode" presStyleCnt="0"/>
+      <dgm:spPr/>
+    </dgm:pt>
+    <dgm:pt modelId="{671B6B7F-2D5E-4E26-9D69-A6A717BCB534}" type="pres">
+      <dgm:prSet presAssocID="{B4C6CB0E-67F5-4965-8270-9D8203C5F71A}" presName="bgRect" presStyleLbl="bgShp" presStyleIdx="3" presStyleCnt="4"/>
+      <dgm:spPr/>
+    </dgm:pt>
+    <dgm:pt modelId="{9E6D3103-3E6B-4FB2-BB90-807133CEE95C}" type="pres">
+      <dgm:prSet presAssocID="{B4C6CB0E-67F5-4965-8270-9D8203C5F71A}" presName="iconRect" presStyleLbl="node1" presStyleIdx="3" presStyleCnt="4"/>
+      <dgm:spPr>
+        <a:blipFill>
+          <a:blip xmlns:r="http://schemas.openxmlformats.org/officeDocument/2006/relationships">
+            <a:extLst>
+              <a:ext uri="{28A0092B-C50C-407E-A947-70E740481C1C}">
+                <a14:useLocalDpi xmlns:a14="http://schemas.microsoft.com/office/drawing/2010/main" val="0"/>
+              </a:ext>
+              <a:ext uri="{96DAC541-7B7A-43D3-8B79-37D633B846F1}">
+                <asvg:svgBlip xmlns:asvg="http://schemas.microsoft.com/office/drawing/2016/SVG/main" r:embed="rId4"/>
+              </a:ext>
+            </a:extLst>
+          </a:blip>
+          <a:stretch>
+            <a:fillRect/>
+          </a:stretch>
+        </a:blipFill>
+        <a:ln>
+          <a:noFill/>
+        </a:ln>
+      </dgm:spPr>
+      <dgm:extLst>
+        <a:ext uri="{E40237B7-FDA0-4F09-8148-C483321AD2D9}">
+          <dgm14:cNvPr xmlns:dgm14="http://schemas.microsoft.com/office/drawing/2010/diagram" id="0" name="" descr="Web Design"/>
+        </a:ext>
+      </dgm:extLst>
+    </dgm:pt>
+    <dgm:pt modelId="{ADEFC1CD-2040-41F9-BFF1-1179592AF9BD}" type="pres">
+      <dgm:prSet presAssocID="{B4C6CB0E-67F5-4965-8270-9D8203C5F71A}" presName="spaceRect" presStyleCnt="0"/>
+      <dgm:spPr/>
+    </dgm:pt>
+    <dgm:pt modelId="{64FE9260-829A-4D46-A3AE-B696D600B6E9}" type="pres">
+      <dgm:prSet presAssocID="{B4C6CB0E-67F5-4965-8270-9D8203C5F71A}" presName="parTx" presStyleLbl="revTx" presStyleIdx="3" presStyleCnt="4">
+        <dgm:presLayoutVars>
+          <dgm:chMax val="0"/>
+          <dgm:chPref val="0"/>
+        </dgm:presLayoutVars>
+      </dgm:prSet>
+      <dgm:spPr/>
+    </dgm:pt>
+  </dgm:ptLst>
+  <dgm:cxnLst>
+    <dgm:cxn modelId="{9218B108-E577-49B0-9C0F-DE1FDFE15E83}" srcId="{0509E7B3-079C-41FA-BD65-DE38A38DC459}" destId="{33D176D9-92CB-4E8E-B745-2A02B4C7CEBE}" srcOrd="1" destOrd="0" parTransId="{8167A301-4BBC-49AB-9E7C-BB0B757D9B24}" sibTransId="{59AC3FCC-86BE-45A7-8004-B7E72EF7A6C2}"/>
+    <dgm:cxn modelId="{2731C256-6ABE-4627-9F9D-BFF3ECAE1262}" type="presOf" srcId="{33D176D9-92CB-4E8E-B745-2A02B4C7CEBE}" destId="{4BD72CD7-94F7-46A3-A4EB-66B07FA78D22}" srcOrd="0" destOrd="0" presId="urn:microsoft.com/office/officeart/2018/2/layout/IconVerticalSolidList"/>
+    <dgm:cxn modelId="{D2504B78-8999-49E1-BA49-8E045A672469}" type="presOf" srcId="{6C01B371-272E-46B1-9056-01850AA5F5F1}" destId="{DD9611CE-201A-4FB8-9005-5C611C691615}" srcOrd="0" destOrd="0" presId="urn:microsoft.com/office/officeart/2018/2/layout/IconVerticalSolidList"/>
+    <dgm:cxn modelId="{FACBA37C-0DD8-44BB-83B0-7217E9BAB387}" type="presOf" srcId="{0509E7B3-079C-41FA-BD65-DE38A38DC459}" destId="{2952F401-2612-4806-B4E8-2AA51D44616C}" srcOrd="0" destOrd="0" presId="urn:microsoft.com/office/officeart/2018/2/layout/IconVerticalSolidList"/>
+    <dgm:cxn modelId="{2B95627D-FC7A-468E-BC2B-1902223D83A5}" srcId="{0509E7B3-079C-41FA-BD65-DE38A38DC459}" destId="{6C01B371-272E-46B1-9056-01850AA5F5F1}" srcOrd="0" destOrd="0" parTransId="{C2236C7E-2A1C-4413-AC08-D4FA2674993C}" sibTransId="{C96F95ED-D73C-4A91-B178-FE0E13419EA5}"/>
+    <dgm:cxn modelId="{8F637F7D-D02F-4023-85A7-741AB6A3BF43}" type="presOf" srcId="{DD6F7A4C-D8C6-464A-9378-C0F2D9EDC8A0}" destId="{E5163663-6809-4479-937C-CC4F9D8F7750}" srcOrd="0" destOrd="0" presId="urn:microsoft.com/office/officeart/2018/2/layout/IconVerticalSolidList"/>
+    <dgm:cxn modelId="{A7F419D8-D2A0-4D1C-9A54-F92607C3F734}" srcId="{0509E7B3-079C-41FA-BD65-DE38A38DC459}" destId="{B4C6CB0E-67F5-4965-8270-9D8203C5F71A}" srcOrd="3" destOrd="0" parTransId="{A33EA111-F655-4444-A541-BC090C7BC1F6}" sibTransId="{460AB618-9480-4A58-B29D-EF819ACC12E9}"/>
+    <dgm:cxn modelId="{620256EA-A6DE-487C-8433-4EB55408F0D0}" type="presOf" srcId="{B4C6CB0E-67F5-4965-8270-9D8203C5F71A}" destId="{64FE9260-829A-4D46-A3AE-B696D600B6E9}" srcOrd="0" destOrd="0" presId="urn:microsoft.com/office/officeart/2018/2/layout/IconVerticalSolidList"/>
+    <dgm:cxn modelId="{233439FD-CC01-4B63-85EA-1434B42C23BA}" srcId="{0509E7B3-079C-41FA-BD65-DE38A38DC459}" destId="{DD6F7A4C-D8C6-464A-9378-C0F2D9EDC8A0}" srcOrd="2" destOrd="0" parTransId="{FE4C140A-A898-4ED0-B114-459E053CE701}" sibTransId="{7F630590-6EB7-4DD7-9E39-1BF1548D29F2}"/>
+    <dgm:cxn modelId="{83BDD33D-27D3-4A03-A40A-942A091F6B43}" type="presParOf" srcId="{2952F401-2612-4806-B4E8-2AA51D44616C}" destId="{455BDFD6-FBAE-468C-B00D-92C8952B9CD4}" srcOrd="0" destOrd="0" presId="urn:microsoft.com/office/officeart/2018/2/layout/IconVerticalSolidList"/>
+    <dgm:cxn modelId="{CE2C99DE-9B95-43AD-A42F-8AA980706E73}" type="presParOf" srcId="{455BDFD6-FBAE-468C-B00D-92C8952B9CD4}" destId="{72968954-DE26-4C17-96EF-E48DD42A9430}" srcOrd="0" destOrd="0" presId="urn:microsoft.com/office/officeart/2018/2/layout/IconVerticalSolidList"/>
+    <dgm:cxn modelId="{41D4F43A-F1B9-49CD-94CE-CB25134C2C9E}" type="presParOf" srcId="{455BDFD6-FBAE-468C-B00D-92C8952B9CD4}" destId="{3BE2EC3C-E37D-4B6B-8CE6-2E5C07FAFC2B}" srcOrd="1" destOrd="0" presId="urn:microsoft.com/office/officeart/2018/2/layout/IconVerticalSolidList"/>
+    <dgm:cxn modelId="{650B4A62-6F82-4667-84A3-18AE0CD04149}" type="presParOf" srcId="{455BDFD6-FBAE-468C-B00D-92C8952B9CD4}" destId="{7F542A8F-D0F4-42C6-B2DD-9D8671F97ACD}" srcOrd="2" destOrd="0" presId="urn:microsoft.com/office/officeart/2018/2/layout/IconVerticalSolidList"/>
+    <dgm:cxn modelId="{45DE16FA-A56B-4DAC-B298-47EB3F9A204C}" type="presParOf" srcId="{455BDFD6-FBAE-468C-B00D-92C8952B9CD4}" destId="{DD9611CE-201A-4FB8-9005-5C611C691615}" srcOrd="3" destOrd="0" presId="urn:microsoft.com/office/officeart/2018/2/layout/IconVerticalSolidList"/>
+    <dgm:cxn modelId="{C4D8C795-45E2-414E-9DCD-B3336200759C}" type="presParOf" srcId="{2952F401-2612-4806-B4E8-2AA51D44616C}" destId="{EE99FFA4-BF94-493F-82F8-631D7CADAB1C}" srcOrd="1" destOrd="0" presId="urn:microsoft.com/office/officeart/2018/2/layout/IconVerticalSolidList"/>
+    <dgm:cxn modelId="{9506C72F-E285-4705-AC48-C354DEB90FCE}" type="presParOf" srcId="{2952F401-2612-4806-B4E8-2AA51D44616C}" destId="{37D67F16-B9F1-41F2-A195-448293B493A8}" srcOrd="2" destOrd="0" presId="urn:microsoft.com/office/officeart/2018/2/layout/IconVerticalSolidList"/>
+    <dgm:cxn modelId="{F099F039-45FE-48A9-9E91-D5503C078A20}" type="presParOf" srcId="{37D67F16-B9F1-41F2-A195-448293B493A8}" destId="{7D7B6B63-E17E-4C7B-960E-0E4E680C401F}" srcOrd="0" destOrd="0" presId="urn:microsoft.com/office/officeart/2018/2/layout/IconVerticalSolidList"/>
+    <dgm:cxn modelId="{264780D6-FF01-4558-A83D-E46AB0E8DE18}" type="presParOf" srcId="{37D67F16-B9F1-41F2-A195-448293B493A8}" destId="{7A491E4D-D7D9-47F0-B258-C776B64A9D17}" srcOrd="1" destOrd="0" presId="urn:microsoft.com/office/officeart/2018/2/layout/IconVerticalSolidList"/>
+    <dgm:cxn modelId="{93AC4458-4647-45A7-8177-53C933C059B7}" type="presParOf" srcId="{37D67F16-B9F1-41F2-A195-448293B493A8}" destId="{A2A53907-D5B9-4E58-929B-82B0721455F6}" srcOrd="2" destOrd="0" presId="urn:microsoft.com/office/officeart/2018/2/layout/IconVerticalSolidList"/>
+    <dgm:cxn modelId="{F5C2379F-EA63-48E4-8111-104C79264666}" type="presParOf" srcId="{37D67F16-B9F1-41F2-A195-448293B493A8}" destId="{4BD72CD7-94F7-46A3-A4EB-66B07FA78D22}" srcOrd="3" destOrd="0" presId="urn:microsoft.com/office/officeart/2018/2/layout/IconVerticalSolidList"/>
+    <dgm:cxn modelId="{E5D61EFA-954E-4D55-ABA8-898C850AE377}" type="presParOf" srcId="{2952F401-2612-4806-B4E8-2AA51D44616C}" destId="{B0D9BADF-7F73-4512-A365-8CBC650C9B7C}" srcOrd="3" destOrd="0" presId="urn:microsoft.com/office/officeart/2018/2/layout/IconVerticalSolidList"/>
+    <dgm:cxn modelId="{F47D9BF4-FE36-4FD8-A452-45CEF63547CC}" type="presParOf" srcId="{2952F401-2612-4806-B4E8-2AA51D44616C}" destId="{3C04544D-F763-43CE-847D-C250D5A13A77}" srcOrd="4" destOrd="0" presId="urn:microsoft.com/office/officeart/2018/2/layout/IconVerticalSolidList"/>
+    <dgm:cxn modelId="{652E78EF-0E1D-485E-8234-B17612EEEE33}" type="presParOf" srcId="{3C04544D-F763-43CE-847D-C250D5A13A77}" destId="{0097AA3F-F4F5-45BD-92D5-6CADAA1CF95B}" srcOrd="0" destOrd="0" presId="urn:microsoft.com/office/officeart/2018/2/layout/IconVerticalSolidList"/>
+    <dgm:cxn modelId="{0F457ED0-071C-4E28-87E0-0323FBFB60DB}" type="presParOf" srcId="{3C04544D-F763-43CE-847D-C250D5A13A77}" destId="{02E2FF33-9FF8-4CA4-BB7E-AF19AFB912A8}" srcOrd="1" destOrd="0" presId="urn:microsoft.com/office/officeart/2018/2/layout/IconVerticalSolidList"/>
+    <dgm:cxn modelId="{26F5FBED-8485-429F-9A59-96B7CE3F91B9}" type="presParOf" srcId="{3C04544D-F763-43CE-847D-C250D5A13A77}" destId="{2B91FDD1-0EAA-49E1-8F3F-B7BC044C515A}" srcOrd="2" destOrd="0" presId="urn:microsoft.com/office/officeart/2018/2/layout/IconVerticalSolidList"/>
+    <dgm:cxn modelId="{8724EE13-211F-4E06-B4F9-DBD5D56DC822}" type="presParOf" srcId="{3C04544D-F763-43CE-847D-C250D5A13A77}" destId="{E5163663-6809-4479-937C-CC4F9D8F7750}" srcOrd="3" destOrd="0" presId="urn:microsoft.com/office/officeart/2018/2/layout/IconVerticalSolidList"/>
+    <dgm:cxn modelId="{66B0C32C-14C4-49F8-B0FD-4B6F3078CF44}" type="presParOf" srcId="{2952F401-2612-4806-B4E8-2AA51D44616C}" destId="{529D4391-9351-4486-881E-17DF90736A4B}" srcOrd="5" destOrd="0" presId="urn:microsoft.com/office/officeart/2018/2/layout/IconVerticalSolidList"/>
+    <dgm:cxn modelId="{EF8090E7-D261-4B12-BE7C-D7C31E2C3F22}" type="presParOf" srcId="{2952F401-2612-4806-B4E8-2AA51D44616C}" destId="{AA5CFE7C-6206-4318-996C-524133CB0AE3}" srcOrd="6" destOrd="0" presId="urn:microsoft.com/office/officeart/2018/2/layout/IconVerticalSolidList"/>
+    <dgm:cxn modelId="{A1329D90-B630-4A14-8204-3899DC009AFF}" type="presParOf" srcId="{AA5CFE7C-6206-4318-996C-524133CB0AE3}" destId="{671B6B7F-2D5E-4E26-9D69-A6A717BCB534}" srcOrd="0" destOrd="0" presId="urn:microsoft.com/office/officeart/2018/2/layout/IconVerticalSolidList"/>
+    <dgm:cxn modelId="{3B8C7BF7-E5C7-4D99-9053-832ECDB37501}" type="presParOf" srcId="{AA5CFE7C-6206-4318-996C-524133CB0AE3}" destId="{9E6D3103-3E6B-4FB2-BB90-807133CEE95C}" srcOrd="1" destOrd="0" presId="urn:microsoft.com/office/officeart/2018/2/layout/IconVerticalSolidList"/>
+    <dgm:cxn modelId="{FA6D443E-20A1-4312-9851-9BF37E74C9A8}" type="presParOf" srcId="{AA5CFE7C-6206-4318-996C-524133CB0AE3}" destId="{ADEFC1CD-2040-41F9-BFF1-1179592AF9BD}" srcOrd="2" destOrd="0" presId="urn:microsoft.com/office/officeart/2018/2/layout/IconVerticalSolidList"/>
+    <dgm:cxn modelId="{59177B4C-C9A1-409A-9033-74F3B727359C}" type="presParOf" srcId="{AA5CFE7C-6206-4318-996C-524133CB0AE3}" destId="{64FE9260-829A-4D46-A3AE-B696D600B6E9}" srcOrd="3" destOrd="0" presId="urn:microsoft.com/office/officeart/2018/2/layout/IconVerticalSolidList"/>
+  </dgm:cxnLst>
+  <dgm:bg/>
+  <dgm:whole/>
+  <dgm:extLst>
+    <a:ext uri="http://schemas.microsoft.com/office/drawing/2008/diagram">
+      <dsp:dataModelExt xmlns:dsp="http://schemas.microsoft.com/office/drawing/2008/diagram" relId="rId7" minVer="http://schemas.openxmlformats.org/drawingml/2006/diagram"/>
     </a:ext>
   </dgm:extLst>
 </dgm:dataModel>
@@ -7399,6 +8904,638 @@
 </dsp:drawing>
 </file>
 
+<file path=ppt/diagrams/drawing4.xml><?xml version="1.0" encoding="utf-8"?>
+<dsp:drawing xmlns:dgm="http://schemas.openxmlformats.org/drawingml/2006/diagram" xmlns:dsp="http://schemas.microsoft.com/office/drawing/2008/diagram" xmlns:a="http://schemas.openxmlformats.org/drawingml/2006/main">
+  <dsp:spTree>
+    <dsp:nvGrpSpPr>
+      <dsp:cNvPr id="0" name=""/>
+      <dsp:cNvGrpSpPr/>
+    </dsp:nvGrpSpPr>
+    <dsp:grpSpPr/>
+    <dsp:sp modelId="{72968954-DE26-4C17-96EF-E48DD42A9430}">
+      <dsp:nvSpPr>
+        <dsp:cNvPr id="0" name=""/>
+        <dsp:cNvSpPr/>
+      </dsp:nvSpPr>
+      <dsp:spPr>
+        <a:xfrm>
+          <a:off x="0" y="3934"/>
+          <a:ext cx="7886700" cy="837226"/>
+        </a:xfrm>
+        <a:prstGeom prst="roundRect">
+          <a:avLst>
+            <a:gd name="adj" fmla="val 10000"/>
+          </a:avLst>
+        </a:prstGeom>
+        <a:solidFill>
+          <a:schemeClr val="accent2">
+            <a:hueOff val="0"/>
+            <a:satOff val="0"/>
+            <a:lumOff val="0"/>
+            <a:alphaOff val="0"/>
+          </a:schemeClr>
+        </a:solidFill>
+        <a:ln>
+          <a:noFill/>
+        </a:ln>
+        <a:effectLst/>
+      </dsp:spPr>
+      <dsp:style>
+        <a:lnRef idx="0">
+          <a:scrgbClr r="0" g="0" b="0"/>
+        </a:lnRef>
+        <a:fillRef idx="1">
+          <a:scrgbClr r="0" g="0" b="0"/>
+        </a:fillRef>
+        <a:effectRef idx="0">
+          <a:scrgbClr r="0" g="0" b="0"/>
+        </a:effectRef>
+        <a:fontRef idx="minor"/>
+      </dsp:style>
+    </dsp:sp>
+    <dsp:sp modelId="{3BE2EC3C-E37D-4B6B-8CE6-2E5C07FAFC2B}">
+      <dsp:nvSpPr>
+        <dsp:cNvPr id="0" name=""/>
+        <dsp:cNvSpPr/>
+      </dsp:nvSpPr>
+      <dsp:spPr>
+        <a:xfrm>
+          <a:off x="253261" y="192310"/>
+          <a:ext cx="460924" cy="460474"/>
+        </a:xfrm>
+        <a:prstGeom prst="rect">
+          <a:avLst/>
+        </a:prstGeom>
+        <a:blipFill>
+          <a:blip xmlns:r="http://schemas.openxmlformats.org/officeDocument/2006/relationships">
+            <a:extLst>
+              <a:ext uri="{28A0092B-C50C-407E-A947-70E740481C1C}">
+                <a14:useLocalDpi xmlns:a14="http://schemas.microsoft.com/office/drawing/2010/main" val="0"/>
+              </a:ext>
+              <a:ext uri="{96DAC541-7B7A-43D3-8B79-37D633B846F1}">
+                <asvg:svgBlip xmlns:asvg="http://schemas.microsoft.com/office/drawing/2016/SVG/main" r:embed="rId1"/>
+              </a:ext>
+            </a:extLst>
+          </a:blip>
+          <a:stretch>
+            <a:fillRect/>
+          </a:stretch>
+        </a:blipFill>
+        <a:ln w="25400" cap="flat" cmpd="sng" algn="ctr">
+          <a:noFill/>
+          <a:prstDash val="solid"/>
+        </a:ln>
+        <a:effectLst/>
+      </dsp:spPr>
+      <dsp:style>
+        <a:lnRef idx="2">
+          <a:scrgbClr r="0" g="0" b="0"/>
+        </a:lnRef>
+        <a:fillRef idx="1">
+          <a:scrgbClr r="0" g="0" b="0"/>
+        </a:fillRef>
+        <a:effectRef idx="0">
+          <a:scrgbClr r="0" g="0" b="0"/>
+        </a:effectRef>
+        <a:fontRef idx="minor">
+          <a:schemeClr val="lt1"/>
+        </a:fontRef>
+      </dsp:style>
+    </dsp:sp>
+    <dsp:sp modelId="{DD9611CE-201A-4FB8-9005-5C611C691615}">
+      <dsp:nvSpPr>
+        <dsp:cNvPr id="0" name=""/>
+        <dsp:cNvSpPr/>
+      </dsp:nvSpPr>
+      <dsp:spPr>
+        <a:xfrm>
+          <a:off x="967447" y="3934"/>
+          <a:ext cx="6875546" cy="915716"/>
+        </a:xfrm>
+        <a:prstGeom prst="rect">
+          <a:avLst/>
+        </a:prstGeom>
+        <a:noFill/>
+        <a:ln>
+          <a:noFill/>
+        </a:ln>
+        <a:effectLst/>
+      </dsp:spPr>
+      <dsp:style>
+        <a:lnRef idx="0">
+          <a:scrgbClr r="0" g="0" b="0"/>
+        </a:lnRef>
+        <a:fillRef idx="0">
+          <a:scrgbClr r="0" g="0" b="0"/>
+        </a:fillRef>
+        <a:effectRef idx="0">
+          <a:scrgbClr r="0" g="0" b="0"/>
+        </a:effectRef>
+        <a:fontRef idx="minor"/>
+      </dsp:style>
+      <dsp:txBody>
+        <a:bodyPr spcFirstLastPara="0" vert="horz" wrap="square" lIns="96913" tIns="96913" rIns="96913" bIns="96913" numCol="1" spcCol="1270" anchor="ctr" anchorCtr="0">
+          <a:noAutofit/>
+        </a:bodyPr>
+        <a:lstStyle/>
+        <a:p>
+          <a:pPr marL="0" lvl="0" indent="0" algn="l" defTabSz="622300">
+            <a:lnSpc>
+              <a:spcPct val="90000"/>
+            </a:lnSpc>
+            <a:spcBef>
+              <a:spcPct val="0"/>
+            </a:spcBef>
+            <a:spcAft>
+              <a:spcPct val="35000"/>
+            </a:spcAft>
+            <a:buNone/>
+          </a:pPr>
+          <a:r>
+            <a:rPr lang="en-GB" sz="1400" kern="1200" dirty="0"/>
+            <a:t>Feature reduction techniques, including PCA, </a:t>
+          </a:r>
+          <a:r>
+            <a:rPr lang="en-GB" sz="1400" kern="1200" dirty="0" err="1"/>
+            <a:t>AutoEncoder</a:t>
+          </a:r>
+          <a:r>
+            <a:rPr lang="en-GB" sz="1400" kern="1200" dirty="0"/>
+            <a:t>, generally lead to a decrease in model performance, particularly in terms of accuracy and F1 score.</a:t>
+          </a:r>
+          <a:endParaRPr lang="en-US" sz="1400" kern="1200" dirty="0"/>
+        </a:p>
+      </dsp:txBody>
+      <dsp:txXfrm>
+        <a:off x="967447" y="3934"/>
+        <a:ext cx="6875546" cy="915716"/>
+      </dsp:txXfrm>
+    </dsp:sp>
+    <dsp:sp modelId="{7D7B6B63-E17E-4C7B-960E-0E4E680C401F}">
+      <dsp:nvSpPr>
+        <dsp:cNvPr id="0" name=""/>
+        <dsp:cNvSpPr/>
+      </dsp:nvSpPr>
+      <dsp:spPr>
+        <a:xfrm>
+          <a:off x="0" y="1148580"/>
+          <a:ext cx="7886700" cy="837226"/>
+        </a:xfrm>
+        <a:prstGeom prst="roundRect">
+          <a:avLst>
+            <a:gd name="adj" fmla="val 10000"/>
+          </a:avLst>
+        </a:prstGeom>
+        <a:solidFill>
+          <a:schemeClr val="accent3">
+            <a:hueOff val="0"/>
+            <a:satOff val="0"/>
+            <a:lumOff val="0"/>
+            <a:alphaOff val="0"/>
+          </a:schemeClr>
+        </a:solidFill>
+        <a:ln>
+          <a:noFill/>
+        </a:ln>
+        <a:effectLst/>
+      </dsp:spPr>
+      <dsp:style>
+        <a:lnRef idx="0">
+          <a:scrgbClr r="0" g="0" b="0"/>
+        </a:lnRef>
+        <a:fillRef idx="1">
+          <a:scrgbClr r="0" g="0" b="0"/>
+        </a:fillRef>
+        <a:effectRef idx="0">
+          <a:scrgbClr r="0" g="0" b="0"/>
+        </a:effectRef>
+        <a:fontRef idx="minor"/>
+      </dsp:style>
+    </dsp:sp>
+    <dsp:sp modelId="{7A491E4D-D7D9-47F0-B258-C776B64A9D17}">
+      <dsp:nvSpPr>
+        <dsp:cNvPr id="0" name=""/>
+        <dsp:cNvSpPr/>
+      </dsp:nvSpPr>
+      <dsp:spPr>
+        <a:xfrm>
+          <a:off x="253261" y="1336956"/>
+          <a:ext cx="460924" cy="460474"/>
+        </a:xfrm>
+        <a:prstGeom prst="rect">
+          <a:avLst/>
+        </a:prstGeom>
+        <a:blipFill>
+          <a:blip xmlns:r="http://schemas.openxmlformats.org/officeDocument/2006/relationships">
+            <a:extLst>
+              <a:ext uri="{28A0092B-C50C-407E-A947-70E740481C1C}">
+                <a14:useLocalDpi xmlns:a14="http://schemas.microsoft.com/office/drawing/2010/main" val="0"/>
+              </a:ext>
+              <a:ext uri="{96DAC541-7B7A-43D3-8B79-37D633B846F1}">
+                <asvg:svgBlip xmlns:asvg="http://schemas.microsoft.com/office/drawing/2016/SVG/main" r:embed="rId2"/>
+              </a:ext>
+            </a:extLst>
+          </a:blip>
+          <a:stretch>
+            <a:fillRect/>
+          </a:stretch>
+        </a:blipFill>
+        <a:ln w="25400" cap="flat" cmpd="sng" algn="ctr">
+          <a:noFill/>
+          <a:prstDash val="solid"/>
+        </a:ln>
+        <a:effectLst/>
+      </dsp:spPr>
+      <dsp:style>
+        <a:lnRef idx="2">
+          <a:scrgbClr r="0" g="0" b="0"/>
+        </a:lnRef>
+        <a:fillRef idx="1">
+          <a:scrgbClr r="0" g="0" b="0"/>
+        </a:fillRef>
+        <a:effectRef idx="0">
+          <a:scrgbClr r="0" g="0" b="0"/>
+        </a:effectRef>
+        <a:fontRef idx="minor">
+          <a:schemeClr val="lt1"/>
+        </a:fontRef>
+      </dsp:style>
+    </dsp:sp>
+    <dsp:sp modelId="{4BD72CD7-94F7-46A3-A4EB-66B07FA78D22}">
+      <dsp:nvSpPr>
+        <dsp:cNvPr id="0" name=""/>
+        <dsp:cNvSpPr/>
+      </dsp:nvSpPr>
+      <dsp:spPr>
+        <a:xfrm>
+          <a:off x="967447" y="1148580"/>
+          <a:ext cx="6875546" cy="915716"/>
+        </a:xfrm>
+        <a:prstGeom prst="rect">
+          <a:avLst/>
+        </a:prstGeom>
+        <a:noFill/>
+        <a:ln>
+          <a:noFill/>
+        </a:ln>
+        <a:effectLst/>
+      </dsp:spPr>
+      <dsp:style>
+        <a:lnRef idx="0">
+          <a:scrgbClr r="0" g="0" b="0"/>
+        </a:lnRef>
+        <a:fillRef idx="0">
+          <a:scrgbClr r="0" g="0" b="0"/>
+        </a:fillRef>
+        <a:effectRef idx="0">
+          <a:scrgbClr r="0" g="0" b="0"/>
+        </a:effectRef>
+        <a:fontRef idx="minor"/>
+      </dsp:style>
+      <dsp:txBody>
+        <a:bodyPr spcFirstLastPara="0" vert="horz" wrap="square" lIns="96913" tIns="96913" rIns="96913" bIns="96913" numCol="1" spcCol="1270" anchor="ctr" anchorCtr="0">
+          <a:noAutofit/>
+        </a:bodyPr>
+        <a:lstStyle/>
+        <a:p>
+          <a:pPr marL="0" lvl="0" indent="0" algn="l" defTabSz="622300">
+            <a:lnSpc>
+              <a:spcPct val="90000"/>
+            </a:lnSpc>
+            <a:spcBef>
+              <a:spcPct val="0"/>
+            </a:spcBef>
+            <a:spcAft>
+              <a:spcPct val="35000"/>
+            </a:spcAft>
+            <a:buNone/>
+          </a:pPr>
+          <a:r>
+            <a:rPr lang="en-GB" sz="1400" kern="1200" dirty="0"/>
+            <a:t>If</a:t>
+          </a:r>
+          <a:r>
+            <a:rPr lang="zh-CN" sz="1400" kern="1200" dirty="0"/>
+            <a:t> </a:t>
+          </a:r>
+          <a:r>
+            <a:rPr lang="en-GB" sz="1400" kern="1200" dirty="0"/>
+            <a:t>a certain degree of performance degradation is acceptable, more aggressive dimensionality reduction can be applied to significantly reduce feature size and computational cost.</a:t>
+          </a:r>
+          <a:endParaRPr lang="en-US" sz="1400" kern="1200" dirty="0"/>
+        </a:p>
+      </dsp:txBody>
+      <dsp:txXfrm>
+        <a:off x="967447" y="1148580"/>
+        <a:ext cx="6875546" cy="915716"/>
+      </dsp:txXfrm>
+    </dsp:sp>
+    <dsp:sp modelId="{0097AA3F-F4F5-45BD-92D5-6CADAA1CF95B}">
+      <dsp:nvSpPr>
+        <dsp:cNvPr id="0" name=""/>
+        <dsp:cNvSpPr/>
+      </dsp:nvSpPr>
+      <dsp:spPr>
+        <a:xfrm>
+          <a:off x="0" y="2293226"/>
+          <a:ext cx="7886700" cy="837226"/>
+        </a:xfrm>
+        <a:prstGeom prst="roundRect">
+          <a:avLst>
+            <a:gd name="adj" fmla="val 10000"/>
+          </a:avLst>
+        </a:prstGeom>
+        <a:solidFill>
+          <a:schemeClr val="accent4">
+            <a:hueOff val="0"/>
+            <a:satOff val="0"/>
+            <a:lumOff val="0"/>
+            <a:alphaOff val="0"/>
+          </a:schemeClr>
+        </a:solidFill>
+        <a:ln>
+          <a:noFill/>
+        </a:ln>
+        <a:effectLst/>
+      </dsp:spPr>
+      <dsp:style>
+        <a:lnRef idx="0">
+          <a:scrgbClr r="0" g="0" b="0"/>
+        </a:lnRef>
+        <a:fillRef idx="1">
+          <a:scrgbClr r="0" g="0" b="0"/>
+        </a:fillRef>
+        <a:effectRef idx="0">
+          <a:scrgbClr r="0" g="0" b="0"/>
+        </a:effectRef>
+        <a:fontRef idx="minor"/>
+      </dsp:style>
+    </dsp:sp>
+    <dsp:sp modelId="{02E2FF33-9FF8-4CA4-BB7E-AF19AFB912A8}">
+      <dsp:nvSpPr>
+        <dsp:cNvPr id="0" name=""/>
+        <dsp:cNvSpPr/>
+      </dsp:nvSpPr>
+      <dsp:spPr>
+        <a:xfrm>
+          <a:off x="253261" y="2481602"/>
+          <a:ext cx="460924" cy="460474"/>
+        </a:xfrm>
+        <a:prstGeom prst="rect">
+          <a:avLst/>
+        </a:prstGeom>
+        <a:blipFill>
+          <a:blip xmlns:r="http://schemas.openxmlformats.org/officeDocument/2006/relationships">
+            <a:extLst>
+              <a:ext uri="{28A0092B-C50C-407E-A947-70E740481C1C}">
+                <a14:useLocalDpi xmlns:a14="http://schemas.microsoft.com/office/drawing/2010/main" val="0"/>
+              </a:ext>
+              <a:ext uri="{96DAC541-7B7A-43D3-8B79-37D633B846F1}">
+                <asvg:svgBlip xmlns:asvg="http://schemas.microsoft.com/office/drawing/2016/SVG/main" r:embed="rId3"/>
+              </a:ext>
+            </a:extLst>
+          </a:blip>
+          <a:stretch>
+            <a:fillRect/>
+          </a:stretch>
+        </a:blipFill>
+        <a:ln w="25400" cap="flat" cmpd="sng" algn="ctr">
+          <a:noFill/>
+          <a:prstDash val="solid"/>
+        </a:ln>
+        <a:effectLst/>
+      </dsp:spPr>
+      <dsp:style>
+        <a:lnRef idx="2">
+          <a:scrgbClr r="0" g="0" b="0"/>
+        </a:lnRef>
+        <a:fillRef idx="1">
+          <a:scrgbClr r="0" g="0" b="0"/>
+        </a:fillRef>
+        <a:effectRef idx="0">
+          <a:scrgbClr r="0" g="0" b="0"/>
+        </a:effectRef>
+        <a:fontRef idx="minor">
+          <a:schemeClr val="lt1"/>
+        </a:fontRef>
+      </dsp:style>
+    </dsp:sp>
+    <dsp:sp modelId="{E5163663-6809-4479-937C-CC4F9D8F7750}">
+      <dsp:nvSpPr>
+        <dsp:cNvPr id="0" name=""/>
+        <dsp:cNvSpPr/>
+      </dsp:nvSpPr>
+      <dsp:spPr>
+        <a:xfrm>
+          <a:off x="967447" y="2293226"/>
+          <a:ext cx="6875546" cy="915716"/>
+        </a:xfrm>
+        <a:prstGeom prst="rect">
+          <a:avLst/>
+        </a:prstGeom>
+        <a:noFill/>
+        <a:ln>
+          <a:noFill/>
+        </a:ln>
+        <a:effectLst/>
+      </dsp:spPr>
+      <dsp:style>
+        <a:lnRef idx="0">
+          <a:scrgbClr r="0" g="0" b="0"/>
+        </a:lnRef>
+        <a:fillRef idx="0">
+          <a:scrgbClr r="0" g="0" b="0"/>
+        </a:fillRef>
+        <a:effectRef idx="0">
+          <a:scrgbClr r="0" g="0" b="0"/>
+        </a:effectRef>
+        <a:fontRef idx="minor"/>
+      </dsp:style>
+      <dsp:txBody>
+        <a:bodyPr spcFirstLastPara="0" vert="horz" wrap="square" lIns="96913" tIns="96913" rIns="96913" bIns="96913" numCol="1" spcCol="1270" anchor="ctr" anchorCtr="0">
+          <a:noAutofit/>
+        </a:bodyPr>
+        <a:lstStyle/>
+        <a:p>
+          <a:pPr marL="0" lvl="0" indent="0" algn="l" defTabSz="622300">
+            <a:lnSpc>
+              <a:spcPct val="90000"/>
+            </a:lnSpc>
+            <a:spcBef>
+              <a:spcPct val="0"/>
+            </a:spcBef>
+            <a:spcAft>
+              <a:spcPct val="35000"/>
+            </a:spcAft>
+            <a:buNone/>
+          </a:pPr>
+          <a:r>
+            <a:rPr lang="en-GB" sz="1400" kern="1200"/>
+            <a:t>ResNeXt introduces high CPU overhead when applied to low-dimensional flow-level data, without improving accuracy or F1 score, making it unsuitable for deployment on edge devices. In contrast, PCA and AutoEncoder show no significant resource bottlenecks and are more suitable for edge-based IDS.</a:t>
+          </a:r>
+          <a:endParaRPr lang="en-US" sz="1400" kern="1200"/>
+        </a:p>
+      </dsp:txBody>
+      <dsp:txXfrm>
+        <a:off x="967447" y="2293226"/>
+        <a:ext cx="6875546" cy="915716"/>
+      </dsp:txXfrm>
+    </dsp:sp>
+    <dsp:sp modelId="{671B6B7F-2D5E-4E26-9D69-A6A717BCB534}">
+      <dsp:nvSpPr>
+        <dsp:cNvPr id="0" name=""/>
+        <dsp:cNvSpPr/>
+      </dsp:nvSpPr>
+      <dsp:spPr>
+        <a:xfrm>
+          <a:off x="0" y="3437872"/>
+          <a:ext cx="7886700" cy="837226"/>
+        </a:xfrm>
+        <a:prstGeom prst="roundRect">
+          <a:avLst>
+            <a:gd name="adj" fmla="val 10000"/>
+          </a:avLst>
+        </a:prstGeom>
+        <a:solidFill>
+          <a:schemeClr val="accent5">
+            <a:hueOff val="0"/>
+            <a:satOff val="0"/>
+            <a:lumOff val="0"/>
+            <a:alphaOff val="0"/>
+          </a:schemeClr>
+        </a:solidFill>
+        <a:ln>
+          <a:noFill/>
+        </a:ln>
+        <a:effectLst/>
+      </dsp:spPr>
+      <dsp:style>
+        <a:lnRef idx="0">
+          <a:scrgbClr r="0" g="0" b="0"/>
+        </a:lnRef>
+        <a:fillRef idx="1">
+          <a:scrgbClr r="0" g="0" b="0"/>
+        </a:fillRef>
+        <a:effectRef idx="0">
+          <a:scrgbClr r="0" g="0" b="0"/>
+        </a:effectRef>
+        <a:fontRef idx="minor"/>
+      </dsp:style>
+    </dsp:sp>
+    <dsp:sp modelId="{9E6D3103-3E6B-4FB2-BB90-807133CEE95C}">
+      <dsp:nvSpPr>
+        <dsp:cNvPr id="0" name=""/>
+        <dsp:cNvSpPr/>
+      </dsp:nvSpPr>
+      <dsp:spPr>
+        <a:xfrm>
+          <a:off x="253261" y="3626248"/>
+          <a:ext cx="460924" cy="460474"/>
+        </a:xfrm>
+        <a:prstGeom prst="rect">
+          <a:avLst/>
+        </a:prstGeom>
+        <a:blipFill>
+          <a:blip xmlns:r="http://schemas.openxmlformats.org/officeDocument/2006/relationships">
+            <a:extLst>
+              <a:ext uri="{28A0092B-C50C-407E-A947-70E740481C1C}">
+                <a14:useLocalDpi xmlns:a14="http://schemas.microsoft.com/office/drawing/2010/main" val="0"/>
+              </a:ext>
+              <a:ext uri="{96DAC541-7B7A-43D3-8B79-37D633B846F1}">
+                <asvg:svgBlip xmlns:asvg="http://schemas.microsoft.com/office/drawing/2016/SVG/main" r:embed="rId4"/>
+              </a:ext>
+            </a:extLst>
+          </a:blip>
+          <a:stretch>
+            <a:fillRect/>
+          </a:stretch>
+        </a:blipFill>
+        <a:ln w="25400" cap="flat" cmpd="sng" algn="ctr">
+          <a:noFill/>
+          <a:prstDash val="solid"/>
+        </a:ln>
+        <a:effectLst/>
+      </dsp:spPr>
+      <dsp:style>
+        <a:lnRef idx="2">
+          <a:scrgbClr r="0" g="0" b="0"/>
+        </a:lnRef>
+        <a:fillRef idx="1">
+          <a:scrgbClr r="0" g="0" b="0"/>
+        </a:fillRef>
+        <a:effectRef idx="0">
+          <a:scrgbClr r="0" g="0" b="0"/>
+        </a:effectRef>
+        <a:fontRef idx="minor">
+          <a:schemeClr val="lt1"/>
+        </a:fontRef>
+      </dsp:style>
+    </dsp:sp>
+    <dsp:sp modelId="{64FE9260-829A-4D46-A3AE-B696D600B6E9}">
+      <dsp:nvSpPr>
+        <dsp:cNvPr id="0" name=""/>
+        <dsp:cNvSpPr/>
+      </dsp:nvSpPr>
+      <dsp:spPr>
+        <a:xfrm>
+          <a:off x="967447" y="3437872"/>
+          <a:ext cx="6875546" cy="915716"/>
+        </a:xfrm>
+        <a:prstGeom prst="rect">
+          <a:avLst/>
+        </a:prstGeom>
+        <a:noFill/>
+        <a:ln>
+          <a:noFill/>
+        </a:ln>
+        <a:effectLst/>
+      </dsp:spPr>
+      <dsp:style>
+        <a:lnRef idx="0">
+          <a:scrgbClr r="0" g="0" b="0"/>
+        </a:lnRef>
+        <a:fillRef idx="0">
+          <a:scrgbClr r="0" g="0" b="0"/>
+        </a:fillRef>
+        <a:effectRef idx="0">
+          <a:scrgbClr r="0" g="0" b="0"/>
+        </a:effectRef>
+        <a:fontRef idx="minor"/>
+      </dsp:style>
+      <dsp:txBody>
+        <a:bodyPr spcFirstLastPara="0" vert="horz" wrap="square" lIns="96913" tIns="96913" rIns="96913" bIns="96913" numCol="1" spcCol="1270" anchor="ctr" anchorCtr="0">
+          <a:noAutofit/>
+        </a:bodyPr>
+        <a:lstStyle/>
+        <a:p>
+          <a:pPr marL="0" lvl="0" indent="0" algn="l" defTabSz="622300">
+            <a:lnSpc>
+              <a:spcPct val="90000"/>
+            </a:lnSpc>
+            <a:spcBef>
+              <a:spcPct val="0"/>
+            </a:spcBef>
+            <a:spcAft>
+              <a:spcPct val="35000"/>
+            </a:spcAft>
+            <a:buNone/>
+          </a:pPr>
+          <a:r>
+            <a:rPr lang="en-GB" sz="1400" kern="1200"/>
+            <a:t>Feature reduction reduces performance but improves efficiency; PCA and AutoEncoder are edge-friendly, while ResNeXt is computationally expensive and ineffective for low-dimensional data.</a:t>
+          </a:r>
+          <a:endParaRPr lang="en-US" sz="1400" kern="1200"/>
+        </a:p>
+      </dsp:txBody>
+      <dsp:txXfrm>
+        <a:off x="967447" y="3437872"/>
+        <a:ext cx="6875546" cy="915716"/>
+      </dsp:txXfrm>
+    </dsp:sp>
+  </dsp:spTree>
+</dsp:drawing>
+</file>
+
 <file path=ppt/diagrams/layout1.xml><?xml version="1.0" encoding="utf-8"?>
 <dgm:layoutDef xmlns:dgm="http://schemas.openxmlformats.org/drawingml/2006/diagram" xmlns:a="http://schemas.openxmlformats.org/drawingml/2006/main" uniqueId="urn:microsoft.com/office/officeart/2016/7/layout/RepeatingBendingProcessNew">
   <dgm:title val="Repeating Bending Process New"/>
@@ -8224,6 +10361,300 @@
 </dgm:layoutDef>
 </file>
 
+<file path=ppt/diagrams/layout4.xml><?xml version="1.0" encoding="utf-8"?>
+<dgm:layoutDef xmlns:dgm="http://schemas.openxmlformats.org/drawingml/2006/diagram" xmlns:a="http://schemas.openxmlformats.org/drawingml/2006/main" uniqueId="urn:microsoft.com/office/officeart/2018/2/layout/IconVerticalSolidList">
+  <dgm:title val="Icon Vertical Solid List"/>
+  <dgm:desc val="Use to show a series of visuals from top to bottom with Level 1 or Level 1 and Level 2 text grouped in a shape. Works best with icons or small pictures with lengthier descriptions."/>
+  <dgm:catLst>
+    <dgm:cat type="icon" pri="500"/>
+  </dgm:catLst>
+  <dgm:sampData useDef="1">
+    <dgm:dataModel>
+      <dgm:ptLst/>
+      <dgm:bg/>
+      <dgm:whole/>
+    </dgm:dataModel>
+  </dgm:sampData>
+  <dgm:styleData useDef="1">
+    <dgm:dataModel>
+      <dgm:ptLst/>
+      <dgm:bg/>
+      <dgm:whole/>
+    </dgm:dataModel>
+  </dgm:styleData>
+  <dgm:clrData useDef="1">
+    <dgm:dataModel>
+      <dgm:ptLst/>
+      <dgm:bg/>
+      <dgm:whole/>
+    </dgm:dataModel>
+  </dgm:clrData>
+  <dgm:layoutNode name="root">
+    <dgm:varLst>
+      <dgm:dir/>
+      <dgm:resizeHandles val="exact"/>
+    </dgm:varLst>
+    <dgm:choose name="Name0">
+      <dgm:if name="Name1" axis="self" func="var" arg="dir" op="equ" val="norm">
+        <dgm:alg type="lin">
+          <dgm:param type="linDir" val="fromT"/>
+          <dgm:param type="nodeHorzAlign" val="l"/>
+        </dgm:alg>
+      </dgm:if>
+      <dgm:else name="Name2">
+        <dgm:alg type="lin">
+          <dgm:param type="linDir" val="fromT"/>
+          <dgm:param type="nodeHorzAlign" val="r"/>
+        </dgm:alg>
+      </dgm:else>
+    </dgm:choose>
+    <dgm:shape xmlns:r="http://schemas.openxmlformats.org/officeDocument/2006/relationships" r:blip="">
+      <dgm:adjLst/>
+    </dgm:shape>
+    <dgm:presOf/>
+    <dgm:choose name="Name3">
+      <dgm:if name="Name4" axis="ch" ptType="node" func="cnt" op="lte" val="3">
+        <dgm:constrLst>
+          <dgm:constr type="h" for="ch" forName="compNode" refType="h" fact="0.3"/>
+          <dgm:constr type="w" for="ch" forName="compNode" refType="w"/>
+          <dgm:constr type="h" for="ch" forName="sibTrans" refType="h" refFor="ch" refForName="compNode" fact="0.25"/>
+          <dgm:constr type="primFontSz" for="des" forName="parTx" val="25"/>
+          <dgm:constr type="primFontSz" for="des" forName="desTx" refType="primFontSz" refFor="des" refForName="parTx" op="lte" fact="0.75"/>
+          <dgm:constr type="h" for="des" forName="compNode" op="equ"/>
+          <dgm:constr type="h" for="des" forName="bgRect" op="equ"/>
+          <dgm:constr type="h" for="des" forName="iconRect" op="equ"/>
+          <dgm:constr type="w" for="des" forName="iconRect" op="equ"/>
+          <dgm:constr type="h" for="des" forName="spaceRect" op="equ"/>
+          <dgm:constr type="h" for="des" forName="parTx" op="equ"/>
+          <dgm:constr type="h" for="des" forName="desTx" op="equ"/>
+        </dgm:constrLst>
+      </dgm:if>
+      <dgm:if name="Name5" axis="ch" ptType="node" func="cnt" op="lte" val="4">
+        <dgm:constrLst>
+          <dgm:constr type="h" for="ch" forName="compNode" refType="h" fact="0.3"/>
+          <dgm:constr type="w" for="ch" forName="compNode" refType="w"/>
+          <dgm:constr type="h" for="ch" forName="sibTrans" refType="h" refFor="ch" refForName="compNode" fact="0.25"/>
+          <dgm:constr type="primFontSz" for="des" forName="parTx" val="22"/>
+          <dgm:constr type="primFontSz" for="des" forName="desTx" refType="primFontSz" refFor="des" refForName="parTx" op="lte" fact="0.75"/>
+          <dgm:constr type="h" for="des" forName="compNode" op="equ"/>
+          <dgm:constr type="h" for="des" forName="bgRect" op="equ"/>
+          <dgm:constr type="h" for="des" forName="iconRect" op="equ"/>
+          <dgm:constr type="w" for="des" forName="iconRect" op="equ"/>
+          <dgm:constr type="h" for="des" forName="spaceRect" op="equ"/>
+          <dgm:constr type="h" for="des" forName="parTx" op="equ"/>
+          <dgm:constr type="h" for="des" forName="desTx" op="equ"/>
+        </dgm:constrLst>
+      </dgm:if>
+      <dgm:if name="Name6" axis="ch" ptType="node" func="cnt" op="lte" val="6">
+        <dgm:constrLst>
+          <dgm:constr type="h" for="ch" forName="compNode" refType="h" fact="0.3"/>
+          <dgm:constr type="w" for="ch" forName="compNode" refType="w"/>
+          <dgm:constr type="h" for="ch" forName="sibTrans" refType="h" refFor="ch" refForName="compNode" fact="0.25"/>
+          <dgm:constr type="primFontSz" for="des" forName="parTx" val="19"/>
+          <dgm:constr type="primFontSz" for="des" forName="desTx" refType="primFontSz" refFor="des" refForName="parTx" op="lte" fact="0.75"/>
+          <dgm:constr type="h" for="des" forName="compNode" op="equ"/>
+          <dgm:constr type="h" for="des" forName="bgRect" op="equ"/>
+          <dgm:constr type="h" for="des" forName="iconRect" op="equ"/>
+          <dgm:constr type="w" for="des" forName="iconRect" op="equ"/>
+          <dgm:constr type="h" for="des" forName="spaceRect" op="equ"/>
+          <dgm:constr type="h" for="des" forName="parTx" op="equ"/>
+          <dgm:constr type="h" for="des" forName="desTx" op="equ"/>
+        </dgm:constrLst>
+      </dgm:if>
+      <dgm:else name="Name7">
+        <dgm:constrLst>
+          <dgm:constr type="h" for="ch" forName="compNode" refType="h" fact="0.3"/>
+          <dgm:constr type="w" for="ch" forName="compNode" refType="w"/>
+          <dgm:constr type="h" for="ch" forName="sibTrans" refType="h" refFor="ch" refForName="compNode" fact="0.25"/>
+          <dgm:constr type="primFontSz" for="des" forName="parTx" val="16"/>
+          <dgm:constr type="primFontSz" for="des" forName="desTx" refType="primFontSz" refFor="des" refForName="parTx" op="lte" fact="0.75"/>
+          <dgm:constr type="h" for="des" forName="compNode" op="equ"/>
+          <dgm:constr type="h" for="des" forName="bgRect" op="equ"/>
+          <dgm:constr type="h" for="des" forName="iconRect" op="equ"/>
+          <dgm:constr type="w" for="des" forName="iconRect" op="equ"/>
+          <dgm:constr type="h" for="des" forName="spaceRect" op="equ"/>
+          <dgm:constr type="h" for="des" forName="parTx" op="equ"/>
+          <dgm:constr type="h" for="des" forName="desTx" op="equ"/>
+        </dgm:constrLst>
+      </dgm:else>
+    </dgm:choose>
+    <dgm:ruleLst>
+      <dgm:rule type="h" for="ch" forName="compNode" val="0" fact="NaN" max="NaN"/>
+    </dgm:ruleLst>
+    <dgm:forEach name="Name8" axis="ch" ptType="node">
+      <dgm:layoutNode name="compNode">
+        <dgm:alg type="composite"/>
+        <dgm:shape xmlns:r="http://schemas.openxmlformats.org/officeDocument/2006/relationships" r:blip="">
+          <dgm:adjLst/>
+        </dgm:shape>
+        <dgm:presOf axis="self"/>
+        <dgm:choose name="Name9">
+          <dgm:if name="Name10" axis="ch" ptType="node" func="cnt" op="gte" val="1">
+            <dgm:constrLst>
+              <dgm:constr type="w" for="ch" forName="bgRect" refType="w"/>
+              <dgm:constr type="h" for="ch" forName="bgRect" refType="h"/>
+              <dgm:constr type="l" for="ch" forName="bgRect"/>
+              <dgm:constr type="t" for="ch" forName="bgRect"/>
+              <dgm:constr type="h" for="ch" forName="iconRect" refType="h" fact="0.55"/>
+              <dgm:constr type="w" for="ch" forName="iconRect" refType="h" refFor="ch" refForName="iconRect"/>
+              <dgm:constr type="l" for="ch" forName="iconRect" refType="h" refFor="ch" refForName="iconRect" fact="0.55"/>
+              <dgm:constr type="ctrY" for="ch" forName="iconRect" refType="ctrY" refFor="ch" refForName="bgRect"/>
+              <dgm:constr type="w" for="ch" forName="spaceRect" refType="l" refFor="ch" refForName="iconRect"/>
+              <dgm:constr type="h" for="ch" forName="spaceRect" refType="h"/>
+              <dgm:constr type="l" for="ch" forName="spaceRect" refType="r" refFor="ch" refForName="iconRect"/>
+              <dgm:constr type="t" for="ch" forName="spaceRect"/>
+              <dgm:constr type="w" for="ch" forName="parTx" refType="w" fact="0.45"/>
+              <dgm:constr type="h" for="ch" forName="parTx" refType="h"/>
+              <dgm:constr type="l" for="ch" forName="parTx" refType="r" refFor="ch" refForName="spaceRect"/>
+              <dgm:constr type="t" for="ch" forName="parTx"/>
+              <dgm:constr type="h" for="ch" forName="desTx" refType="h"/>
+              <dgm:constr type="l" for="ch" forName="desTx" refType="r" refFor="ch" refForName="parTx"/>
+              <dgm:constr type="t" for="ch" forName="desTx"/>
+            </dgm:constrLst>
+          </dgm:if>
+          <dgm:else name="Name11">
+            <dgm:constrLst>
+              <dgm:constr type="w" for="ch" forName="bgRect" refType="w"/>
+              <dgm:constr type="h" for="ch" forName="bgRect" refType="h"/>
+              <dgm:constr type="l" for="ch" forName="bgRect"/>
+              <dgm:constr type="t" for="ch" forName="bgRect"/>
+              <dgm:constr type="h" for="ch" forName="iconRect" refType="h" fact="0.55"/>
+              <dgm:constr type="w" for="ch" forName="iconRect" refType="h" refFor="ch" refForName="iconRect"/>
+              <dgm:constr type="l" for="ch" forName="iconRect" refType="h" refFor="ch" refForName="iconRect" fact="0.55"/>
+              <dgm:constr type="ctrY" for="ch" forName="iconRect" refType="ctrY" refFor="ch" refForName="bgRect"/>
+              <dgm:constr type="w" for="ch" forName="spaceRect" refType="l" refFor="ch" refForName="iconRect"/>
+              <dgm:constr type="h" for="ch" forName="spaceRect" refType="h"/>
+              <dgm:constr type="l" for="ch" forName="spaceRect" refType="r" refFor="ch" refForName="iconRect"/>
+              <dgm:constr type="t" for="ch" forName="spaceRect"/>
+              <dgm:constr type="h" for="ch" forName="parTx" refType="h"/>
+              <dgm:constr type="l" for="ch" forName="parTx" refType="r" refFor="ch" refForName="spaceRect"/>
+              <dgm:constr type="t" for="ch" forName="parTx"/>
+            </dgm:constrLst>
+          </dgm:else>
+        </dgm:choose>
+        <dgm:ruleLst>
+          <dgm:rule type="h" val="INF" fact="NaN" max="NaN"/>
+        </dgm:ruleLst>
+        <dgm:layoutNode name="bgRect" styleLbl="bgShp">
+          <dgm:alg type="sp"/>
+          <dgm:shape xmlns:r="http://schemas.openxmlformats.org/officeDocument/2006/relationships" type="roundRect" r:blip="">
+            <dgm:adjLst>
+              <dgm:adj idx="1" val="0.1"/>
+            </dgm:adjLst>
+          </dgm:shape>
+          <dgm:presOf/>
+          <dgm:constrLst/>
+          <dgm:ruleLst/>
+        </dgm:layoutNode>
+        <dgm:layoutNode name="iconRect" styleLbl="node1">
+          <dgm:alg type="sp"/>
+          <dgm:shape xmlns:r="http://schemas.openxmlformats.org/officeDocument/2006/relationships" type="rect" r:blip="" blipPhldr="1">
+            <dgm:adjLst/>
+          </dgm:shape>
+          <dgm:presOf/>
+          <dgm:constrLst/>
+          <dgm:ruleLst/>
+        </dgm:layoutNode>
+        <dgm:layoutNode name="spaceRect">
+          <dgm:alg type="sp"/>
+          <dgm:shape xmlns:r="http://schemas.openxmlformats.org/officeDocument/2006/relationships" r:blip="">
+            <dgm:adjLst/>
+          </dgm:shape>
+          <dgm:presOf/>
+          <dgm:constrLst/>
+          <dgm:ruleLst/>
+        </dgm:layoutNode>
+        <dgm:layoutNode name="parTx" styleLbl="revTx">
+          <dgm:varLst>
+            <dgm:chMax val="0"/>
+            <dgm:chPref val="0"/>
+          </dgm:varLst>
+          <dgm:alg type="tx">
+            <dgm:param type="txAnchorVert" val="mid"/>
+            <dgm:param type="parTxLTRAlign" val="l"/>
+            <dgm:param type="shpTxLTRAlignCh" val="l"/>
+            <dgm:param type="parTxRTLAlign" val="r"/>
+            <dgm:param type="shpTxRTLAlignCh" val="r"/>
+          </dgm:alg>
+          <dgm:shape xmlns:r="http://schemas.openxmlformats.org/officeDocument/2006/relationships" type="rect" r:blip="">
+            <dgm:adjLst/>
+          </dgm:shape>
+          <dgm:presOf axis="self" ptType="node"/>
+          <dgm:constrLst>
+            <dgm:constr type="lMarg" refType="h" fact="0.3"/>
+            <dgm:constr type="rMarg" refType="h" fact="0.3"/>
+            <dgm:constr type="tMarg" refType="h" fact="0.3"/>
+            <dgm:constr type="bMarg" refType="h" fact="0.3"/>
+          </dgm:constrLst>
+          <dgm:ruleLst>
+            <dgm:rule type="primFontSz" val="14" fact="NaN" max="NaN"/>
+            <dgm:rule type="h" val="INF" fact="NaN" max="NaN"/>
+          </dgm:ruleLst>
+        </dgm:layoutNode>
+        <dgm:choose name="Name12">
+          <dgm:if name="Name13" axis="ch" ptType="node" func="cnt" op="gte" val="1">
+            <dgm:layoutNode name="desTx" styleLbl="revTx">
+              <dgm:varLst/>
+              <dgm:alg type="tx">
+                <dgm:param type="txAnchorVertCh" val="mid"/>
+                <dgm:param type="parTxLTRAlign" val="l"/>
+                <dgm:param type="shpTxLTRAlignCh" val="l"/>
+                <dgm:param type="parTxRTLAlign" val="r"/>
+                <dgm:param type="shpTxRTLAlignCh" val="r"/>
+                <dgm:param type="stBulletLvl" val="0"/>
+              </dgm:alg>
+              <dgm:shape xmlns:r="http://schemas.openxmlformats.org/officeDocument/2006/relationships" type="rect" r:blip="">
+                <dgm:adjLst/>
+              </dgm:shape>
+              <dgm:presOf axis="des" ptType="node"/>
+              <dgm:constrLst>
+                <dgm:constr type="primFontSz" val="18"/>
+                <dgm:constr type="secFontSz" refType="primFontSz"/>
+                <dgm:constr type="lMarg" refType="h" fact="0.3"/>
+                <dgm:constr type="rMarg" refType="h" fact="0.3"/>
+                <dgm:constr type="tMarg" refType="h" fact="0.3"/>
+                <dgm:constr type="bMarg" refType="h" fact="0.3"/>
+              </dgm:constrLst>
+              <dgm:ruleLst>
+                <dgm:rule type="primFontSz" val="11" fact="NaN" max="NaN"/>
+              </dgm:ruleLst>
+            </dgm:layoutNode>
+          </dgm:if>
+          <dgm:else name="Name14"/>
+        </dgm:choose>
+      </dgm:layoutNode>
+      <dgm:forEach name="Name15" axis="followSib" ptType="sibTrans" cnt="1">
+        <dgm:layoutNode name="sibTrans">
+          <dgm:alg type="sp"/>
+          <dgm:shape xmlns:r="http://schemas.openxmlformats.org/officeDocument/2006/relationships" r:blip="">
+            <dgm:adjLst/>
+          </dgm:shape>
+          <dgm:presOf axis="self"/>
+          <dgm:constrLst/>
+          <dgm:ruleLst/>
+        </dgm:layoutNode>
+      </dgm:forEach>
+    </dgm:forEach>
+  </dgm:layoutNode>
+  <dgm:extLst>
+    <a:ext uri="{68A01E43-0DF5-4B5B-8FA6-DAF915123BFB}">
+      <dgm1612:lstStyle xmlns:dgm1612="http://schemas.microsoft.com/office/drawing/2016/12/diagram">
+        <a:lvl1pPr>
+          <a:lnSpc>
+            <a:spcPct val="100000"/>
+          </a:lnSpc>
+        </a:lvl1pPr>
+        <a:lvl2pPr>
+          <a:lnSpc>
+            <a:spcPct val="100000"/>
+          </a:lnSpc>
+        </a:lvl2pPr>
+      </dgm1612:lstStyle>
+    </a:ext>
+  </dgm:extLst>
+</dgm:layoutDef>
+</file>
+
 <file path=ppt/diagrams/quickStyle1.xml><?xml version="1.0" encoding="utf-8"?>
 <dgm:styleDef xmlns:dgm="http://schemas.openxmlformats.org/drawingml/2006/diagram" xmlns:a="http://schemas.openxmlformats.org/drawingml/2006/main" uniqueId="urn:microsoft.com/office/officeart/2005/8/quickstyle/simple1">
   <dgm:title val=""/>
@@ -11298,6 +13729,1040 @@
         <a:scrgbClr r="0" g="0" b="0"/>
       </a:fillRef>
       <a:effectRef idx="2">
+        <a:scrgbClr r="0" g="0" b="0"/>
+      </a:effectRef>
+      <a:fontRef idx="minor"/>
+    </dgm:style>
+  </dgm:styleLbl>
+  <dgm:styleLbl name="revTx">
+    <dgm:scene3d>
+      <a:camera prst="orthographicFront"/>
+      <a:lightRig rig="threePt" dir="t"/>
+    </dgm:scene3d>
+    <dgm:sp3d/>
+    <dgm:txPr/>
+    <dgm:style>
+      <a:lnRef idx="0">
+        <a:scrgbClr r="0" g="0" b="0"/>
+      </a:lnRef>
+      <a:fillRef idx="0">
+        <a:scrgbClr r="0" g="0" b="0"/>
+      </a:fillRef>
+      <a:effectRef idx="0">
+        <a:scrgbClr r="0" g="0" b="0"/>
+      </a:effectRef>
+      <a:fontRef idx="minor"/>
+    </dgm:style>
+  </dgm:styleLbl>
+</dgm:styleDef>
+</file>
+
+<file path=ppt/diagrams/quickStyle4.xml><?xml version="1.0" encoding="utf-8"?>
+<dgm:styleDef xmlns:dgm="http://schemas.openxmlformats.org/drawingml/2006/diagram" xmlns:a="http://schemas.openxmlformats.org/drawingml/2006/main" uniqueId="urn:microsoft.com/office/officeart/2005/8/quickstyle/simple1">
+  <dgm:title val=""/>
+  <dgm:desc val=""/>
+  <dgm:catLst>
+    <dgm:cat type="simple" pri="10100"/>
+  </dgm:catLst>
+  <dgm:scene3d>
+    <a:camera prst="orthographicFront"/>
+    <a:lightRig rig="threePt" dir="t"/>
+  </dgm:scene3d>
+  <dgm:styleLbl name="node0">
+    <dgm:scene3d>
+      <a:camera prst="orthographicFront"/>
+      <a:lightRig rig="threePt" dir="t"/>
+    </dgm:scene3d>
+    <dgm:sp3d/>
+    <dgm:txPr/>
+    <dgm:style>
+      <a:lnRef idx="2">
+        <a:scrgbClr r="0" g="0" b="0"/>
+      </a:lnRef>
+      <a:fillRef idx="1">
+        <a:scrgbClr r="0" g="0" b="0"/>
+      </a:fillRef>
+      <a:effectRef idx="0">
+        <a:scrgbClr r="0" g="0" b="0"/>
+      </a:effectRef>
+      <a:fontRef idx="minor">
+        <a:schemeClr val="lt1"/>
+      </a:fontRef>
+    </dgm:style>
+  </dgm:styleLbl>
+  <dgm:styleLbl name="lnNode1">
+    <dgm:scene3d>
+      <a:camera prst="orthographicFront"/>
+      <a:lightRig rig="threePt" dir="t"/>
+    </dgm:scene3d>
+    <dgm:sp3d/>
+    <dgm:txPr/>
+    <dgm:style>
+      <a:lnRef idx="2">
+        <a:scrgbClr r="0" g="0" b="0"/>
+      </a:lnRef>
+      <a:fillRef idx="1">
+        <a:scrgbClr r="0" g="0" b="0"/>
+      </a:fillRef>
+      <a:effectRef idx="0">
+        <a:scrgbClr r="0" g="0" b="0"/>
+      </a:effectRef>
+      <a:fontRef idx="minor">
+        <a:schemeClr val="lt1"/>
+      </a:fontRef>
+    </dgm:style>
+  </dgm:styleLbl>
+  <dgm:styleLbl name="vennNode1">
+    <dgm:scene3d>
+      <a:camera prst="orthographicFront"/>
+      <a:lightRig rig="threePt" dir="t"/>
+    </dgm:scene3d>
+    <dgm:sp3d/>
+    <dgm:txPr/>
+    <dgm:style>
+      <a:lnRef idx="2">
+        <a:scrgbClr r="0" g="0" b="0"/>
+      </a:lnRef>
+      <a:fillRef idx="1">
+        <a:scrgbClr r="0" g="0" b="0"/>
+      </a:fillRef>
+      <a:effectRef idx="0">
+        <a:scrgbClr r="0" g="0" b="0"/>
+      </a:effectRef>
+      <a:fontRef idx="minor">
+        <a:schemeClr val="tx1"/>
+      </a:fontRef>
+    </dgm:style>
+  </dgm:styleLbl>
+  <dgm:styleLbl name="alignNode1">
+    <dgm:scene3d>
+      <a:camera prst="orthographicFront"/>
+      <a:lightRig rig="threePt" dir="t"/>
+    </dgm:scene3d>
+    <dgm:sp3d/>
+    <dgm:txPr/>
+    <dgm:style>
+      <a:lnRef idx="2">
+        <a:scrgbClr r="0" g="0" b="0"/>
+      </a:lnRef>
+      <a:fillRef idx="1">
+        <a:scrgbClr r="0" g="0" b="0"/>
+      </a:fillRef>
+      <a:effectRef idx="0">
+        <a:scrgbClr r="0" g="0" b="0"/>
+      </a:effectRef>
+      <a:fontRef idx="minor">
+        <a:schemeClr val="lt1"/>
+      </a:fontRef>
+    </dgm:style>
+  </dgm:styleLbl>
+  <dgm:styleLbl name="node1">
+    <dgm:scene3d>
+      <a:camera prst="orthographicFront"/>
+      <a:lightRig rig="threePt" dir="t"/>
+    </dgm:scene3d>
+    <dgm:sp3d/>
+    <dgm:txPr/>
+    <dgm:style>
+      <a:lnRef idx="2">
+        <a:scrgbClr r="0" g="0" b="0"/>
+      </a:lnRef>
+      <a:fillRef idx="1">
+        <a:scrgbClr r="0" g="0" b="0"/>
+      </a:fillRef>
+      <a:effectRef idx="0">
+        <a:scrgbClr r="0" g="0" b="0"/>
+      </a:effectRef>
+      <a:fontRef idx="minor">
+        <a:schemeClr val="lt1"/>
+      </a:fontRef>
+    </dgm:style>
+  </dgm:styleLbl>
+  <dgm:styleLbl name="node2">
+    <dgm:scene3d>
+      <a:camera prst="orthographicFront"/>
+      <a:lightRig rig="threePt" dir="t"/>
+    </dgm:scene3d>
+    <dgm:sp3d/>
+    <dgm:txPr/>
+    <dgm:style>
+      <a:lnRef idx="2">
+        <a:scrgbClr r="0" g="0" b="0"/>
+      </a:lnRef>
+      <a:fillRef idx="1">
+        <a:scrgbClr r="0" g="0" b="0"/>
+      </a:fillRef>
+      <a:effectRef idx="0">
+        <a:scrgbClr r="0" g="0" b="0"/>
+      </a:effectRef>
+      <a:fontRef idx="minor">
+        <a:schemeClr val="lt1"/>
+      </a:fontRef>
+    </dgm:style>
+  </dgm:styleLbl>
+  <dgm:styleLbl name="node3">
+    <dgm:scene3d>
+      <a:camera prst="orthographicFront"/>
+      <a:lightRig rig="threePt" dir="t"/>
+    </dgm:scene3d>
+    <dgm:sp3d/>
+    <dgm:txPr/>
+    <dgm:style>
+      <a:lnRef idx="2">
+        <a:scrgbClr r="0" g="0" b="0"/>
+      </a:lnRef>
+      <a:fillRef idx="1">
+        <a:scrgbClr r="0" g="0" b="0"/>
+      </a:fillRef>
+      <a:effectRef idx="0">
+        <a:scrgbClr r="0" g="0" b="0"/>
+      </a:effectRef>
+      <a:fontRef idx="minor">
+        <a:schemeClr val="lt1"/>
+      </a:fontRef>
+    </dgm:style>
+  </dgm:styleLbl>
+  <dgm:styleLbl name="node4">
+    <dgm:scene3d>
+      <a:camera prst="orthographicFront"/>
+      <a:lightRig rig="threePt" dir="t"/>
+    </dgm:scene3d>
+    <dgm:sp3d/>
+    <dgm:txPr/>
+    <dgm:style>
+      <a:lnRef idx="2">
+        <a:scrgbClr r="0" g="0" b="0"/>
+      </a:lnRef>
+      <a:fillRef idx="1">
+        <a:scrgbClr r="0" g="0" b="0"/>
+      </a:fillRef>
+      <a:effectRef idx="0">
+        <a:scrgbClr r="0" g="0" b="0"/>
+      </a:effectRef>
+      <a:fontRef idx="minor">
+        <a:schemeClr val="lt1"/>
+      </a:fontRef>
+    </dgm:style>
+  </dgm:styleLbl>
+  <dgm:styleLbl name="fgImgPlace1">
+    <dgm:scene3d>
+      <a:camera prst="orthographicFront"/>
+      <a:lightRig rig="threePt" dir="t"/>
+    </dgm:scene3d>
+    <dgm:sp3d/>
+    <dgm:txPr/>
+    <dgm:style>
+      <a:lnRef idx="2">
+        <a:scrgbClr r="0" g="0" b="0"/>
+      </a:lnRef>
+      <a:fillRef idx="1">
+        <a:scrgbClr r="0" g="0" b="0"/>
+      </a:fillRef>
+      <a:effectRef idx="0">
+        <a:scrgbClr r="0" g="0" b="0"/>
+      </a:effectRef>
+      <a:fontRef idx="minor"/>
+    </dgm:style>
+  </dgm:styleLbl>
+  <dgm:styleLbl name="alignImgPlace1">
+    <dgm:scene3d>
+      <a:camera prst="orthographicFront"/>
+      <a:lightRig rig="threePt" dir="t"/>
+    </dgm:scene3d>
+    <dgm:sp3d/>
+    <dgm:txPr/>
+    <dgm:style>
+      <a:lnRef idx="2">
+        <a:scrgbClr r="0" g="0" b="0"/>
+      </a:lnRef>
+      <a:fillRef idx="1">
+        <a:scrgbClr r="0" g="0" b="0"/>
+      </a:fillRef>
+      <a:effectRef idx="0">
+        <a:scrgbClr r="0" g="0" b="0"/>
+      </a:effectRef>
+      <a:fontRef idx="minor"/>
+    </dgm:style>
+  </dgm:styleLbl>
+  <dgm:styleLbl name="bgImgPlace1">
+    <dgm:scene3d>
+      <a:camera prst="orthographicFront"/>
+      <a:lightRig rig="threePt" dir="t"/>
+    </dgm:scene3d>
+    <dgm:sp3d/>
+    <dgm:txPr/>
+    <dgm:style>
+      <a:lnRef idx="2">
+        <a:scrgbClr r="0" g="0" b="0"/>
+      </a:lnRef>
+      <a:fillRef idx="1">
+        <a:scrgbClr r="0" g="0" b="0"/>
+      </a:fillRef>
+      <a:effectRef idx="0">
+        <a:scrgbClr r="0" g="0" b="0"/>
+      </a:effectRef>
+      <a:fontRef idx="minor"/>
+    </dgm:style>
+  </dgm:styleLbl>
+  <dgm:styleLbl name="sibTrans2D1">
+    <dgm:scene3d>
+      <a:camera prst="orthographicFront"/>
+      <a:lightRig rig="threePt" dir="t"/>
+    </dgm:scene3d>
+    <dgm:sp3d/>
+    <dgm:txPr/>
+    <dgm:style>
+      <a:lnRef idx="0">
+        <a:scrgbClr r="0" g="0" b="0"/>
+      </a:lnRef>
+      <a:fillRef idx="1">
+        <a:scrgbClr r="0" g="0" b="0"/>
+      </a:fillRef>
+      <a:effectRef idx="0">
+        <a:scrgbClr r="0" g="0" b="0"/>
+      </a:effectRef>
+      <a:fontRef idx="minor">
+        <a:schemeClr val="lt1"/>
+      </a:fontRef>
+    </dgm:style>
+  </dgm:styleLbl>
+  <dgm:styleLbl name="fgSibTrans2D1">
+    <dgm:scene3d>
+      <a:camera prst="orthographicFront"/>
+      <a:lightRig rig="threePt" dir="t"/>
+    </dgm:scene3d>
+    <dgm:sp3d/>
+    <dgm:txPr/>
+    <dgm:style>
+      <a:lnRef idx="0">
+        <a:scrgbClr r="0" g="0" b="0"/>
+      </a:lnRef>
+      <a:fillRef idx="1">
+        <a:scrgbClr r="0" g="0" b="0"/>
+      </a:fillRef>
+      <a:effectRef idx="0">
+        <a:scrgbClr r="0" g="0" b="0"/>
+      </a:effectRef>
+      <a:fontRef idx="minor">
+        <a:schemeClr val="lt1"/>
+      </a:fontRef>
+    </dgm:style>
+  </dgm:styleLbl>
+  <dgm:styleLbl name="bgSibTrans2D1">
+    <dgm:scene3d>
+      <a:camera prst="orthographicFront"/>
+      <a:lightRig rig="threePt" dir="t"/>
+    </dgm:scene3d>
+    <dgm:sp3d/>
+    <dgm:txPr/>
+    <dgm:style>
+      <a:lnRef idx="0">
+        <a:scrgbClr r="0" g="0" b="0"/>
+      </a:lnRef>
+      <a:fillRef idx="1">
+        <a:scrgbClr r="0" g="0" b="0"/>
+      </a:fillRef>
+      <a:effectRef idx="0">
+        <a:scrgbClr r="0" g="0" b="0"/>
+      </a:effectRef>
+      <a:fontRef idx="minor">
+        <a:schemeClr val="lt1"/>
+      </a:fontRef>
+    </dgm:style>
+  </dgm:styleLbl>
+  <dgm:styleLbl name="sibTrans1D1">
+    <dgm:scene3d>
+      <a:camera prst="orthographicFront"/>
+      <a:lightRig rig="threePt" dir="t"/>
+    </dgm:scene3d>
+    <dgm:sp3d/>
+    <dgm:txPr/>
+    <dgm:style>
+      <a:lnRef idx="1">
+        <a:scrgbClr r="0" g="0" b="0"/>
+      </a:lnRef>
+      <a:fillRef idx="0">
+        <a:scrgbClr r="0" g="0" b="0"/>
+      </a:fillRef>
+      <a:effectRef idx="0">
+        <a:scrgbClr r="0" g="0" b="0"/>
+      </a:effectRef>
+      <a:fontRef idx="minor"/>
+    </dgm:style>
+  </dgm:styleLbl>
+  <dgm:styleLbl name="callout">
+    <dgm:scene3d>
+      <a:camera prst="orthographicFront"/>
+      <a:lightRig rig="threePt" dir="t"/>
+    </dgm:scene3d>
+    <dgm:sp3d/>
+    <dgm:txPr/>
+    <dgm:style>
+      <a:lnRef idx="2">
+        <a:scrgbClr r="0" g="0" b="0"/>
+      </a:lnRef>
+      <a:fillRef idx="1">
+        <a:scrgbClr r="0" g="0" b="0"/>
+      </a:fillRef>
+      <a:effectRef idx="0">
+        <a:scrgbClr r="0" g="0" b="0"/>
+      </a:effectRef>
+      <a:fontRef idx="minor"/>
+    </dgm:style>
+  </dgm:styleLbl>
+  <dgm:styleLbl name="asst0">
+    <dgm:scene3d>
+      <a:camera prst="orthographicFront"/>
+      <a:lightRig rig="threePt" dir="t"/>
+    </dgm:scene3d>
+    <dgm:sp3d/>
+    <dgm:txPr/>
+    <dgm:style>
+      <a:lnRef idx="2">
+        <a:scrgbClr r="0" g="0" b="0"/>
+      </a:lnRef>
+      <a:fillRef idx="1">
+        <a:scrgbClr r="0" g="0" b="0"/>
+      </a:fillRef>
+      <a:effectRef idx="0">
+        <a:scrgbClr r="0" g="0" b="0"/>
+      </a:effectRef>
+      <a:fontRef idx="minor">
+        <a:schemeClr val="lt1"/>
+      </a:fontRef>
+    </dgm:style>
+  </dgm:styleLbl>
+  <dgm:styleLbl name="asst1">
+    <dgm:scene3d>
+      <a:camera prst="orthographicFront"/>
+      <a:lightRig rig="threePt" dir="t"/>
+    </dgm:scene3d>
+    <dgm:sp3d/>
+    <dgm:txPr/>
+    <dgm:style>
+      <a:lnRef idx="2">
+        <a:scrgbClr r="0" g="0" b="0"/>
+      </a:lnRef>
+      <a:fillRef idx="1">
+        <a:scrgbClr r="0" g="0" b="0"/>
+      </a:fillRef>
+      <a:effectRef idx="0">
+        <a:scrgbClr r="0" g="0" b="0"/>
+      </a:effectRef>
+      <a:fontRef idx="minor">
+        <a:schemeClr val="lt1"/>
+      </a:fontRef>
+    </dgm:style>
+  </dgm:styleLbl>
+  <dgm:styleLbl name="asst2">
+    <dgm:scene3d>
+      <a:camera prst="orthographicFront"/>
+      <a:lightRig rig="threePt" dir="t"/>
+    </dgm:scene3d>
+    <dgm:sp3d/>
+    <dgm:txPr/>
+    <dgm:style>
+      <a:lnRef idx="2">
+        <a:scrgbClr r="0" g="0" b="0"/>
+      </a:lnRef>
+      <a:fillRef idx="1">
+        <a:scrgbClr r="0" g="0" b="0"/>
+      </a:fillRef>
+      <a:effectRef idx="0">
+        <a:scrgbClr r="0" g="0" b="0"/>
+      </a:effectRef>
+      <a:fontRef idx="minor">
+        <a:schemeClr val="lt1"/>
+      </a:fontRef>
+    </dgm:style>
+  </dgm:styleLbl>
+  <dgm:styleLbl name="asst3">
+    <dgm:scene3d>
+      <a:camera prst="orthographicFront"/>
+      <a:lightRig rig="threePt" dir="t"/>
+    </dgm:scene3d>
+    <dgm:sp3d/>
+    <dgm:txPr/>
+    <dgm:style>
+      <a:lnRef idx="2">
+        <a:scrgbClr r="0" g="0" b="0"/>
+      </a:lnRef>
+      <a:fillRef idx="1">
+        <a:scrgbClr r="0" g="0" b="0"/>
+      </a:fillRef>
+      <a:effectRef idx="0">
+        <a:scrgbClr r="0" g="0" b="0"/>
+      </a:effectRef>
+      <a:fontRef idx="minor">
+        <a:schemeClr val="lt1"/>
+      </a:fontRef>
+    </dgm:style>
+  </dgm:styleLbl>
+  <dgm:styleLbl name="asst4">
+    <dgm:scene3d>
+      <a:camera prst="orthographicFront"/>
+      <a:lightRig rig="threePt" dir="t"/>
+    </dgm:scene3d>
+    <dgm:sp3d/>
+    <dgm:txPr/>
+    <dgm:style>
+      <a:lnRef idx="2">
+        <a:scrgbClr r="0" g="0" b="0"/>
+      </a:lnRef>
+      <a:fillRef idx="1">
+        <a:scrgbClr r="0" g="0" b="0"/>
+      </a:fillRef>
+      <a:effectRef idx="0">
+        <a:scrgbClr r="0" g="0" b="0"/>
+      </a:effectRef>
+      <a:fontRef idx="minor">
+        <a:schemeClr val="lt1"/>
+      </a:fontRef>
+    </dgm:style>
+  </dgm:styleLbl>
+  <dgm:styleLbl name="parChTrans2D1">
+    <dgm:scene3d>
+      <a:camera prst="orthographicFront"/>
+      <a:lightRig rig="threePt" dir="t"/>
+    </dgm:scene3d>
+    <dgm:sp3d/>
+    <dgm:txPr/>
+    <dgm:style>
+      <a:lnRef idx="2">
+        <a:scrgbClr r="0" g="0" b="0"/>
+      </a:lnRef>
+      <a:fillRef idx="1">
+        <a:scrgbClr r="0" g="0" b="0"/>
+      </a:fillRef>
+      <a:effectRef idx="0">
+        <a:scrgbClr r="0" g="0" b="0"/>
+      </a:effectRef>
+      <a:fontRef idx="minor">
+        <a:schemeClr val="lt1"/>
+      </a:fontRef>
+    </dgm:style>
+  </dgm:styleLbl>
+  <dgm:styleLbl name="parChTrans2D2">
+    <dgm:scene3d>
+      <a:camera prst="orthographicFront"/>
+      <a:lightRig rig="threePt" dir="t"/>
+    </dgm:scene3d>
+    <dgm:sp3d/>
+    <dgm:txPr/>
+    <dgm:style>
+      <a:lnRef idx="2">
+        <a:scrgbClr r="0" g="0" b="0"/>
+      </a:lnRef>
+      <a:fillRef idx="1">
+        <a:scrgbClr r="0" g="0" b="0"/>
+      </a:fillRef>
+      <a:effectRef idx="0">
+        <a:scrgbClr r="0" g="0" b="0"/>
+      </a:effectRef>
+      <a:fontRef idx="minor">
+        <a:schemeClr val="lt1"/>
+      </a:fontRef>
+    </dgm:style>
+  </dgm:styleLbl>
+  <dgm:styleLbl name="parChTrans2D3">
+    <dgm:scene3d>
+      <a:camera prst="orthographicFront"/>
+      <a:lightRig rig="threePt" dir="t"/>
+    </dgm:scene3d>
+    <dgm:sp3d/>
+    <dgm:txPr/>
+    <dgm:style>
+      <a:lnRef idx="2">
+        <a:scrgbClr r="0" g="0" b="0"/>
+      </a:lnRef>
+      <a:fillRef idx="1">
+        <a:scrgbClr r="0" g="0" b="0"/>
+      </a:fillRef>
+      <a:effectRef idx="0">
+        <a:scrgbClr r="0" g="0" b="0"/>
+      </a:effectRef>
+      <a:fontRef idx="minor">
+        <a:schemeClr val="lt1"/>
+      </a:fontRef>
+    </dgm:style>
+  </dgm:styleLbl>
+  <dgm:styleLbl name="parChTrans2D4">
+    <dgm:scene3d>
+      <a:camera prst="orthographicFront"/>
+      <a:lightRig rig="threePt" dir="t"/>
+    </dgm:scene3d>
+    <dgm:sp3d/>
+    <dgm:txPr/>
+    <dgm:style>
+      <a:lnRef idx="2">
+        <a:scrgbClr r="0" g="0" b="0"/>
+      </a:lnRef>
+      <a:fillRef idx="1">
+        <a:scrgbClr r="0" g="0" b="0"/>
+      </a:fillRef>
+      <a:effectRef idx="0">
+        <a:scrgbClr r="0" g="0" b="0"/>
+      </a:effectRef>
+      <a:fontRef idx="minor">
+        <a:schemeClr val="lt1"/>
+      </a:fontRef>
+    </dgm:style>
+  </dgm:styleLbl>
+  <dgm:styleLbl name="parChTrans1D1">
+    <dgm:scene3d>
+      <a:camera prst="orthographicFront"/>
+      <a:lightRig rig="threePt" dir="t"/>
+    </dgm:scene3d>
+    <dgm:sp3d/>
+    <dgm:txPr/>
+    <dgm:style>
+      <a:lnRef idx="2">
+        <a:scrgbClr r="0" g="0" b="0"/>
+      </a:lnRef>
+      <a:fillRef idx="0">
+        <a:scrgbClr r="0" g="0" b="0"/>
+      </a:fillRef>
+      <a:effectRef idx="0">
+        <a:scrgbClr r="0" g="0" b="0"/>
+      </a:effectRef>
+      <a:fontRef idx="minor"/>
+    </dgm:style>
+  </dgm:styleLbl>
+  <dgm:styleLbl name="parChTrans1D2">
+    <dgm:scene3d>
+      <a:camera prst="orthographicFront"/>
+      <a:lightRig rig="threePt" dir="t"/>
+    </dgm:scene3d>
+    <dgm:sp3d/>
+    <dgm:txPr/>
+    <dgm:style>
+      <a:lnRef idx="2">
+        <a:scrgbClr r="0" g="0" b="0"/>
+      </a:lnRef>
+      <a:fillRef idx="0">
+        <a:scrgbClr r="0" g="0" b="0"/>
+      </a:fillRef>
+      <a:effectRef idx="0">
+        <a:scrgbClr r="0" g="0" b="0"/>
+      </a:effectRef>
+      <a:fontRef idx="minor"/>
+    </dgm:style>
+  </dgm:styleLbl>
+  <dgm:styleLbl name="parChTrans1D3">
+    <dgm:scene3d>
+      <a:camera prst="orthographicFront"/>
+      <a:lightRig rig="threePt" dir="t"/>
+    </dgm:scene3d>
+    <dgm:sp3d/>
+    <dgm:txPr/>
+    <dgm:style>
+      <a:lnRef idx="2">
+        <a:scrgbClr r="0" g="0" b="0"/>
+      </a:lnRef>
+      <a:fillRef idx="0">
+        <a:scrgbClr r="0" g="0" b="0"/>
+      </a:fillRef>
+      <a:effectRef idx="0">
+        <a:scrgbClr r="0" g="0" b="0"/>
+      </a:effectRef>
+      <a:fontRef idx="minor"/>
+    </dgm:style>
+  </dgm:styleLbl>
+  <dgm:styleLbl name="parChTrans1D4">
+    <dgm:scene3d>
+      <a:camera prst="orthographicFront"/>
+      <a:lightRig rig="threePt" dir="t"/>
+    </dgm:scene3d>
+    <dgm:sp3d/>
+    <dgm:txPr/>
+    <dgm:style>
+      <a:lnRef idx="2">
+        <a:scrgbClr r="0" g="0" b="0"/>
+      </a:lnRef>
+      <a:fillRef idx="0">
+        <a:scrgbClr r="0" g="0" b="0"/>
+      </a:fillRef>
+      <a:effectRef idx="0">
+        <a:scrgbClr r="0" g="0" b="0"/>
+      </a:effectRef>
+      <a:fontRef idx="minor"/>
+    </dgm:style>
+  </dgm:styleLbl>
+  <dgm:styleLbl name="fgAcc1">
+    <dgm:scene3d>
+      <a:camera prst="orthographicFront"/>
+      <a:lightRig rig="threePt" dir="t"/>
+    </dgm:scene3d>
+    <dgm:sp3d/>
+    <dgm:txPr/>
+    <dgm:style>
+      <a:lnRef idx="2">
+        <a:scrgbClr r="0" g="0" b="0"/>
+      </a:lnRef>
+      <a:fillRef idx="1">
+        <a:scrgbClr r="0" g="0" b="0"/>
+      </a:fillRef>
+      <a:effectRef idx="0">
+        <a:scrgbClr r="0" g="0" b="0"/>
+      </a:effectRef>
+      <a:fontRef idx="minor"/>
+    </dgm:style>
+  </dgm:styleLbl>
+  <dgm:styleLbl name="conFgAcc1">
+    <dgm:scene3d>
+      <a:camera prst="orthographicFront"/>
+      <a:lightRig rig="threePt" dir="t"/>
+    </dgm:scene3d>
+    <dgm:sp3d/>
+    <dgm:txPr/>
+    <dgm:style>
+      <a:lnRef idx="2">
+        <a:scrgbClr r="0" g="0" b="0"/>
+      </a:lnRef>
+      <a:fillRef idx="1">
+        <a:scrgbClr r="0" g="0" b="0"/>
+      </a:fillRef>
+      <a:effectRef idx="0">
+        <a:scrgbClr r="0" g="0" b="0"/>
+      </a:effectRef>
+      <a:fontRef idx="minor"/>
+    </dgm:style>
+  </dgm:styleLbl>
+  <dgm:styleLbl name="alignAcc1">
+    <dgm:scene3d>
+      <a:camera prst="orthographicFront"/>
+      <a:lightRig rig="threePt" dir="t"/>
+    </dgm:scene3d>
+    <dgm:sp3d/>
+    <dgm:txPr/>
+    <dgm:style>
+      <a:lnRef idx="2">
+        <a:scrgbClr r="0" g="0" b="0"/>
+      </a:lnRef>
+      <a:fillRef idx="1">
+        <a:scrgbClr r="0" g="0" b="0"/>
+      </a:fillRef>
+      <a:effectRef idx="0">
+        <a:scrgbClr r="0" g="0" b="0"/>
+      </a:effectRef>
+      <a:fontRef idx="minor"/>
+    </dgm:style>
+  </dgm:styleLbl>
+  <dgm:styleLbl name="trAlignAcc1">
+    <dgm:scene3d>
+      <a:camera prst="orthographicFront"/>
+      <a:lightRig rig="threePt" dir="t"/>
+    </dgm:scene3d>
+    <dgm:sp3d/>
+    <dgm:txPr/>
+    <dgm:style>
+      <a:lnRef idx="1">
+        <a:scrgbClr r="0" g="0" b="0"/>
+      </a:lnRef>
+      <a:fillRef idx="1">
+        <a:scrgbClr r="0" g="0" b="0"/>
+      </a:fillRef>
+      <a:effectRef idx="0">
+        <a:scrgbClr r="0" g="0" b="0"/>
+      </a:effectRef>
+      <a:fontRef idx="minor"/>
+    </dgm:style>
+  </dgm:styleLbl>
+  <dgm:styleLbl name="bgAcc1">
+    <dgm:scene3d>
+      <a:camera prst="orthographicFront"/>
+      <a:lightRig rig="threePt" dir="t"/>
+    </dgm:scene3d>
+    <dgm:sp3d/>
+    <dgm:txPr/>
+    <dgm:style>
+      <a:lnRef idx="2">
+        <a:scrgbClr r="0" g="0" b="0"/>
+      </a:lnRef>
+      <a:fillRef idx="1">
+        <a:scrgbClr r="0" g="0" b="0"/>
+      </a:fillRef>
+      <a:effectRef idx="0">
+        <a:scrgbClr r="0" g="0" b="0"/>
+      </a:effectRef>
+      <a:fontRef idx="minor"/>
+    </dgm:style>
+  </dgm:styleLbl>
+  <dgm:styleLbl name="solidFgAcc1">
+    <dgm:scene3d>
+      <a:camera prst="orthographicFront"/>
+      <a:lightRig rig="threePt" dir="t"/>
+    </dgm:scene3d>
+    <dgm:sp3d/>
+    <dgm:txPr/>
+    <dgm:style>
+      <a:lnRef idx="2">
+        <a:scrgbClr r="0" g="0" b="0"/>
+      </a:lnRef>
+      <a:fillRef idx="1">
+        <a:scrgbClr r="0" g="0" b="0"/>
+      </a:fillRef>
+      <a:effectRef idx="0">
+        <a:scrgbClr r="0" g="0" b="0"/>
+      </a:effectRef>
+      <a:fontRef idx="minor"/>
+    </dgm:style>
+  </dgm:styleLbl>
+  <dgm:styleLbl name="solidAlignAcc1">
+    <dgm:scene3d>
+      <a:camera prst="orthographicFront"/>
+      <a:lightRig rig="threePt" dir="t"/>
+    </dgm:scene3d>
+    <dgm:sp3d/>
+    <dgm:txPr/>
+    <dgm:style>
+      <a:lnRef idx="2">
+        <a:scrgbClr r="0" g="0" b="0"/>
+      </a:lnRef>
+      <a:fillRef idx="1">
+        <a:scrgbClr r="0" g="0" b="0"/>
+      </a:fillRef>
+      <a:effectRef idx="0">
+        <a:scrgbClr r="0" g="0" b="0"/>
+      </a:effectRef>
+      <a:fontRef idx="minor"/>
+    </dgm:style>
+  </dgm:styleLbl>
+  <dgm:styleLbl name="solidBgAcc1">
+    <dgm:scene3d>
+      <a:camera prst="orthographicFront"/>
+      <a:lightRig rig="threePt" dir="t"/>
+    </dgm:scene3d>
+    <dgm:sp3d/>
+    <dgm:txPr/>
+    <dgm:style>
+      <a:lnRef idx="2">
+        <a:scrgbClr r="0" g="0" b="0"/>
+      </a:lnRef>
+      <a:fillRef idx="1">
+        <a:scrgbClr r="0" g="0" b="0"/>
+      </a:fillRef>
+      <a:effectRef idx="0">
+        <a:scrgbClr r="0" g="0" b="0"/>
+      </a:effectRef>
+      <a:fontRef idx="minor"/>
+    </dgm:style>
+  </dgm:styleLbl>
+  <dgm:styleLbl name="fgAccFollowNode1">
+    <dgm:scene3d>
+      <a:camera prst="orthographicFront"/>
+      <a:lightRig rig="threePt" dir="t"/>
+    </dgm:scene3d>
+    <dgm:sp3d/>
+    <dgm:txPr/>
+    <dgm:style>
+      <a:lnRef idx="2">
+        <a:scrgbClr r="0" g="0" b="0"/>
+      </a:lnRef>
+      <a:fillRef idx="1">
+        <a:scrgbClr r="0" g="0" b="0"/>
+      </a:fillRef>
+      <a:effectRef idx="0">
+        <a:scrgbClr r="0" g="0" b="0"/>
+      </a:effectRef>
+      <a:fontRef idx="minor"/>
+    </dgm:style>
+  </dgm:styleLbl>
+  <dgm:styleLbl name="alignAccFollowNode1">
+    <dgm:scene3d>
+      <a:camera prst="orthographicFront"/>
+      <a:lightRig rig="threePt" dir="t"/>
+    </dgm:scene3d>
+    <dgm:sp3d/>
+    <dgm:txPr/>
+    <dgm:style>
+      <a:lnRef idx="2">
+        <a:scrgbClr r="0" g="0" b="0"/>
+      </a:lnRef>
+      <a:fillRef idx="1">
+        <a:scrgbClr r="0" g="0" b="0"/>
+      </a:fillRef>
+      <a:effectRef idx="0">
+        <a:scrgbClr r="0" g="0" b="0"/>
+      </a:effectRef>
+      <a:fontRef idx="minor"/>
+    </dgm:style>
+  </dgm:styleLbl>
+  <dgm:styleLbl name="bgAccFollowNode1">
+    <dgm:scene3d>
+      <a:camera prst="orthographicFront"/>
+      <a:lightRig rig="threePt" dir="t"/>
+    </dgm:scene3d>
+    <dgm:sp3d/>
+    <dgm:txPr/>
+    <dgm:style>
+      <a:lnRef idx="2">
+        <a:scrgbClr r="0" g="0" b="0"/>
+      </a:lnRef>
+      <a:fillRef idx="1">
+        <a:scrgbClr r="0" g="0" b="0"/>
+      </a:fillRef>
+      <a:effectRef idx="0">
+        <a:scrgbClr r="0" g="0" b="0"/>
+      </a:effectRef>
+      <a:fontRef idx="minor"/>
+    </dgm:style>
+  </dgm:styleLbl>
+  <dgm:styleLbl name="fgAcc0">
+    <dgm:scene3d>
+      <a:camera prst="orthographicFront"/>
+      <a:lightRig rig="threePt" dir="t"/>
+    </dgm:scene3d>
+    <dgm:sp3d/>
+    <dgm:txPr/>
+    <dgm:style>
+      <a:lnRef idx="2">
+        <a:scrgbClr r="0" g="0" b="0"/>
+      </a:lnRef>
+      <a:fillRef idx="1">
+        <a:scrgbClr r="0" g="0" b="0"/>
+      </a:fillRef>
+      <a:effectRef idx="0">
+        <a:scrgbClr r="0" g="0" b="0"/>
+      </a:effectRef>
+      <a:fontRef idx="minor"/>
+    </dgm:style>
+  </dgm:styleLbl>
+  <dgm:styleLbl name="fgAcc2">
+    <dgm:scene3d>
+      <a:camera prst="orthographicFront"/>
+      <a:lightRig rig="threePt" dir="t"/>
+    </dgm:scene3d>
+    <dgm:sp3d/>
+    <dgm:txPr/>
+    <dgm:style>
+      <a:lnRef idx="2">
+        <a:scrgbClr r="0" g="0" b="0"/>
+      </a:lnRef>
+      <a:fillRef idx="1">
+        <a:scrgbClr r="0" g="0" b="0"/>
+      </a:fillRef>
+      <a:effectRef idx="0">
+        <a:scrgbClr r="0" g="0" b="0"/>
+      </a:effectRef>
+      <a:fontRef idx="minor"/>
+    </dgm:style>
+  </dgm:styleLbl>
+  <dgm:styleLbl name="fgAcc3">
+    <dgm:scene3d>
+      <a:camera prst="orthographicFront"/>
+      <a:lightRig rig="threePt" dir="t"/>
+    </dgm:scene3d>
+    <dgm:sp3d/>
+    <dgm:txPr/>
+    <dgm:style>
+      <a:lnRef idx="2">
+        <a:scrgbClr r="0" g="0" b="0"/>
+      </a:lnRef>
+      <a:fillRef idx="1">
+        <a:scrgbClr r="0" g="0" b="0"/>
+      </a:fillRef>
+      <a:effectRef idx="0">
+        <a:scrgbClr r="0" g="0" b="0"/>
+      </a:effectRef>
+      <a:fontRef idx="minor"/>
+    </dgm:style>
+  </dgm:styleLbl>
+  <dgm:styleLbl name="fgAcc4">
+    <dgm:scene3d>
+      <a:camera prst="orthographicFront"/>
+      <a:lightRig rig="threePt" dir="t"/>
+    </dgm:scene3d>
+    <dgm:sp3d/>
+    <dgm:txPr/>
+    <dgm:style>
+      <a:lnRef idx="2">
+        <a:scrgbClr r="0" g="0" b="0"/>
+      </a:lnRef>
+      <a:fillRef idx="1">
+        <a:scrgbClr r="0" g="0" b="0"/>
+      </a:fillRef>
+      <a:effectRef idx="0">
+        <a:scrgbClr r="0" g="0" b="0"/>
+      </a:effectRef>
+      <a:fontRef idx="minor"/>
+    </dgm:style>
+  </dgm:styleLbl>
+  <dgm:styleLbl name="bgShp">
+    <dgm:scene3d>
+      <a:camera prst="orthographicFront"/>
+      <a:lightRig rig="threePt" dir="t"/>
+    </dgm:scene3d>
+    <dgm:sp3d/>
+    <dgm:txPr/>
+    <dgm:style>
+      <a:lnRef idx="0">
+        <a:scrgbClr r="0" g="0" b="0"/>
+      </a:lnRef>
+      <a:fillRef idx="1">
+        <a:scrgbClr r="0" g="0" b="0"/>
+      </a:fillRef>
+      <a:effectRef idx="0">
+        <a:scrgbClr r="0" g="0" b="0"/>
+      </a:effectRef>
+      <a:fontRef idx="minor"/>
+    </dgm:style>
+  </dgm:styleLbl>
+  <dgm:styleLbl name="dkBgShp">
+    <dgm:scene3d>
+      <a:camera prst="orthographicFront"/>
+      <a:lightRig rig="threePt" dir="t"/>
+    </dgm:scene3d>
+    <dgm:sp3d/>
+    <dgm:txPr/>
+    <dgm:style>
+      <a:lnRef idx="0">
+        <a:scrgbClr r="0" g="0" b="0"/>
+      </a:lnRef>
+      <a:fillRef idx="1">
+        <a:scrgbClr r="0" g="0" b="0"/>
+      </a:fillRef>
+      <a:effectRef idx="0">
+        <a:scrgbClr r="0" g="0" b="0"/>
+      </a:effectRef>
+      <a:fontRef idx="minor"/>
+    </dgm:style>
+  </dgm:styleLbl>
+  <dgm:styleLbl name="trBgShp">
+    <dgm:scene3d>
+      <a:camera prst="orthographicFront"/>
+      <a:lightRig rig="threePt" dir="t"/>
+    </dgm:scene3d>
+    <dgm:sp3d/>
+    <dgm:txPr/>
+    <dgm:style>
+      <a:lnRef idx="0">
+        <a:scrgbClr r="0" g="0" b="0"/>
+      </a:lnRef>
+      <a:fillRef idx="1">
+        <a:scrgbClr r="0" g="0" b="0"/>
+      </a:fillRef>
+      <a:effectRef idx="0">
+        <a:scrgbClr r="0" g="0" b="0"/>
+      </a:effectRef>
+      <a:fontRef idx="minor"/>
+    </dgm:style>
+  </dgm:styleLbl>
+  <dgm:styleLbl name="fgShp">
+    <dgm:scene3d>
+      <a:camera prst="orthographicFront"/>
+      <a:lightRig rig="threePt" dir="t"/>
+    </dgm:scene3d>
+    <dgm:sp3d/>
+    <dgm:txPr/>
+    <dgm:style>
+      <a:lnRef idx="2">
+        <a:scrgbClr r="0" g="0" b="0"/>
+      </a:lnRef>
+      <a:fillRef idx="1">
+        <a:scrgbClr r="0" g="0" b="0"/>
+      </a:fillRef>
+      <a:effectRef idx="0">
         <a:scrgbClr r="0" g="0" b="0"/>
       </a:effectRef>
       <a:fontRef idx="minor"/>
@@ -12358,6 +15823,90 @@
     <p:extLst>
       <p:ext uri="{BB962C8B-B14F-4D97-AF65-F5344CB8AC3E}">
         <p14:creationId xmlns:p14="http://schemas.microsoft.com/office/powerpoint/2010/main" val="1022987678"/>
+      </p:ext>
+    </p:extLst>
+  </p:cSld>
+  <p:clrMapOvr>
+    <a:masterClrMapping/>
+  </p:clrMapOvr>
+</p:notes>
+</file>
+
+<file path=ppt/notesSlides/notesSlide5.xml><?xml version="1.0" encoding="utf-8"?>
+<p:notes xmlns:a="http://schemas.openxmlformats.org/drawingml/2006/main" xmlns:r="http://schemas.openxmlformats.org/officeDocument/2006/relationships" xmlns:p="http://schemas.openxmlformats.org/presentationml/2006/main">
+  <p:cSld>
+    <p:spTree>
+      <p:nvGrpSpPr>
+        <p:cNvPr id="1" name=""/>
+        <p:cNvGrpSpPr/>
+        <p:nvPr/>
+      </p:nvGrpSpPr>
+      <p:grpSpPr>
+        <a:xfrm>
+          <a:off x="0" y="0"/>
+          <a:ext cx="0" cy="0"/>
+          <a:chOff x="0" y="0"/>
+          <a:chExt cx="0" cy="0"/>
+        </a:xfrm>
+      </p:grpSpPr>
+      <p:sp>
+        <p:nvSpPr>
+          <p:cNvPr id="2" name="Slide Image Placeholder 1"/>
+          <p:cNvSpPr>
+            <a:spLocks noGrp="1" noRot="1" noChangeAspect="1"/>
+          </p:cNvSpPr>
+          <p:nvPr>
+            <p:ph type="sldImg"/>
+          </p:nvPr>
+        </p:nvSpPr>
+        <p:spPr/>
+      </p:sp>
+      <p:sp>
+        <p:nvSpPr>
+          <p:cNvPr id="3" name="Notes Placeholder 2"/>
+          <p:cNvSpPr>
+            <a:spLocks noGrp="1"/>
+          </p:cNvSpPr>
+          <p:nvPr>
+            <p:ph type="body" idx="1"/>
+          </p:nvPr>
+        </p:nvSpPr>
+        <p:spPr/>
+        <p:txBody>
+          <a:bodyPr/>
+          <a:lstStyle/>
+          <a:p>
+            <a:endParaRPr lang="en-US" dirty="0"/>
+          </a:p>
+        </p:txBody>
+      </p:sp>
+      <p:sp>
+        <p:nvSpPr>
+          <p:cNvPr id="4" name="Slide Number Placeholder 3"/>
+          <p:cNvSpPr>
+            <a:spLocks noGrp="1"/>
+          </p:cNvSpPr>
+          <p:nvPr>
+            <p:ph type="sldNum" sz="quarter" idx="5"/>
+          </p:nvPr>
+        </p:nvSpPr>
+        <p:spPr/>
+        <p:txBody>
+          <a:bodyPr/>
+          <a:lstStyle/>
+          <a:p>
+            <a:fld id="{EDEF46E4-EE54-564F-BFBC-E1DA32DE0BEF}" type="slidenum">
+              <a:rPr lang="en-US" smtClean="0"/>
+              <a:t>12</a:t>
+            </a:fld>
+            <a:endParaRPr lang="en-US"/>
+          </a:p>
+        </p:txBody>
+      </p:sp>
+    </p:spTree>
+    <p:extLst>
+      <p:ext uri="{BB962C8B-B14F-4D97-AF65-F5344CB8AC3E}">
+        <p14:creationId xmlns:p14="http://schemas.microsoft.com/office/powerpoint/2010/main" val="2684792558"/>
       </p:ext>
     </p:extLst>
   </p:cSld>
@@ -15970,6 +19519,382 @@
 <file path=ppt/slides/slide10.xml><?xml version="1.0" encoding="utf-8"?>
 <p:sld xmlns:a="http://schemas.openxmlformats.org/drawingml/2006/main" xmlns:r="http://schemas.openxmlformats.org/officeDocument/2006/relationships" xmlns:p="http://schemas.openxmlformats.org/presentationml/2006/main">
   <p:cSld>
+    <p:bg>
+      <p:bgPr>
+        <a:solidFill>
+          <a:schemeClr val="bg1"/>
+        </a:solidFill>
+        <a:effectLst/>
+      </p:bgPr>
+    </p:bg>
+    <p:spTree>
+      <p:nvGrpSpPr>
+        <p:cNvPr id="1" name="">
+          <a:extLst>
+            <a:ext uri="{FF2B5EF4-FFF2-40B4-BE49-F238E27FC236}">
+              <a16:creationId xmlns:a16="http://schemas.microsoft.com/office/drawing/2014/main" id="{A725C967-FB18-C74B-FE86-5A42C3A0E1D7}"/>
+            </a:ext>
+          </a:extLst>
+        </p:cNvPr>
+        <p:cNvGrpSpPr/>
+        <p:nvPr/>
+      </p:nvGrpSpPr>
+      <p:grpSpPr>
+        <a:xfrm>
+          <a:off x="0" y="0"/>
+          <a:ext cx="0" cy="0"/>
+          <a:chOff x="0" y="0"/>
+          <a:chExt cx="0" cy="0"/>
+        </a:xfrm>
+      </p:grpSpPr>
+      <p:sp>
+        <p:nvSpPr>
+          <p:cNvPr id="6" name="Rectangle 5">
+            <a:extLst>
+              <a:ext uri="{FF2B5EF4-FFF2-40B4-BE49-F238E27FC236}">
+                <a16:creationId xmlns:a16="http://schemas.microsoft.com/office/drawing/2014/main" id="{A4AC5506-6312-4701-8D3C-40187889A947}"/>
+              </a:ext>
+              <a:ext uri="{C183D7F6-B498-43B3-948B-1728B52AA6E4}">
+                <adec:decorative xmlns:adec="http://schemas.microsoft.com/office/drawing/2017/decorative" val="1"/>
+              </a:ext>
+            </a:extLst>
+          </p:cNvPr>
+          <p:cNvSpPr>
+            <a:spLocks noGrp="1" noRot="1" noChangeAspect="1" noMove="1" noResize="1" noEditPoints="1" noAdjustHandles="1" noChangeArrowheads="1" noChangeShapeType="1" noTextEdit="1"/>
+          </p:cNvSpPr>
+          <p:nvPr>
+            <p:extLst>
+              <p:ext uri="{386F3935-93C4-4BCD-93E2-E3B085C9AB24}">
+                <p16:designElem xmlns:p16="http://schemas.microsoft.com/office/powerpoint/2015/main" val="1"/>
+              </p:ext>
+            </p:extLst>
+          </p:nvPr>
+        </p:nvSpPr>
+        <p:spPr>
+          <a:xfrm>
+            <a:off x="0" y="651752"/>
+            <a:ext cx="9144000" cy="736551"/>
+          </a:xfrm>
+          <a:prstGeom prst="rect">
+            <a:avLst/>
+          </a:prstGeom>
+          <a:solidFill>
+            <a:schemeClr val="tx1"/>
+          </a:solidFill>
+          <a:ln>
+            <a:noFill/>
+          </a:ln>
+        </p:spPr>
+        <p:style>
+          <a:lnRef idx="2">
+            <a:schemeClr val="accent1">
+              <a:shade val="50000"/>
+            </a:schemeClr>
+          </a:lnRef>
+          <a:fillRef idx="1">
+            <a:schemeClr val="accent1"/>
+          </a:fillRef>
+          <a:effectRef idx="0">
+            <a:schemeClr val="accent1"/>
+          </a:effectRef>
+          <a:fontRef idx="minor">
+            <a:schemeClr val="lt1"/>
+          </a:fontRef>
+        </p:style>
+        <p:txBody>
+          <a:bodyPr rtlCol="0" anchor="ctr"/>
+          <a:lstStyle/>
+          <a:p>
+            <a:pPr algn="ctr"/>
+            <a:endParaRPr lang="en-US"/>
+          </a:p>
+        </p:txBody>
+      </p:sp>
+      <p:sp>
+        <p:nvSpPr>
+          <p:cNvPr id="2" name="Title 1">
+            <a:extLst>
+              <a:ext uri="{FF2B5EF4-FFF2-40B4-BE49-F238E27FC236}">
+                <a16:creationId xmlns:a16="http://schemas.microsoft.com/office/drawing/2014/main" id="{FE1BC7AD-C24C-85D6-CEF2-EA35DCBA076A}"/>
+              </a:ext>
+            </a:extLst>
+          </p:cNvPr>
+          <p:cNvSpPr>
+            <a:spLocks noGrp="1"/>
+          </p:cNvSpPr>
+          <p:nvPr>
+            <p:ph type="title"/>
+          </p:nvPr>
+        </p:nvSpPr>
+        <p:spPr>
+          <a:xfrm>
+            <a:off x="417399" y="643467"/>
+            <a:ext cx="8408193" cy="744836"/>
+          </a:xfrm>
+        </p:spPr>
+        <p:txBody>
+          <a:bodyPr vert="horz" lIns="91440" tIns="45720" rIns="91440" bIns="45720" rtlCol="0" anchor="ctr">
+            <a:normAutofit/>
+          </a:bodyPr>
+          <a:lstStyle/>
+          <a:p>
+            <a:pPr defTabSz="914400">
+              <a:lnSpc>
+                <a:spcPct val="90000"/>
+              </a:lnSpc>
+            </a:pPr>
+            <a:r>
+              <a:rPr lang="en-US" sz="2800" kern="1200" dirty="0">
+                <a:solidFill>
+                  <a:schemeClr val="bg1"/>
+                </a:solidFill>
+                <a:latin typeface="+mj-lt"/>
+                <a:ea typeface="+mj-ea"/>
+                <a:cs typeface="+mj-cs"/>
+              </a:rPr>
+              <a:t>Results: Detection Performance</a:t>
+            </a:r>
+          </a:p>
+        </p:txBody>
+      </p:sp>
+      <p:pic>
+        <p:nvPicPr>
+          <p:cNvPr id="3" name="Picture 2">
+            <a:extLst>
+              <a:ext uri="{FF2B5EF4-FFF2-40B4-BE49-F238E27FC236}">
+                <a16:creationId xmlns:a16="http://schemas.microsoft.com/office/drawing/2014/main" id="{25BE9F14-AAAC-F3B5-9722-4E0629D91F9E}"/>
+              </a:ext>
+            </a:extLst>
+          </p:cNvPr>
+          <p:cNvPicPr>
+            <a:picLocks noChangeAspect="1"/>
+          </p:cNvPicPr>
+          <p:nvPr/>
+        </p:nvPicPr>
+        <p:blipFill>
+          <a:blip r:embed="rId2"/>
+          <a:stretch>
+            <a:fillRect/>
+          </a:stretch>
+        </p:blipFill>
+        <p:spPr>
+          <a:xfrm>
+            <a:off x="1095607" y="1509711"/>
+            <a:ext cx="6952785" cy="4844154"/>
+          </a:xfrm>
+          <a:prstGeom prst="rect">
+            <a:avLst/>
+          </a:prstGeom>
+        </p:spPr>
+      </p:pic>
+    </p:spTree>
+    <p:extLst>
+      <p:ext uri="{BB962C8B-B14F-4D97-AF65-F5344CB8AC3E}">
+        <p14:creationId xmlns:p14="http://schemas.microsoft.com/office/powerpoint/2010/main" val="350239924"/>
+      </p:ext>
+    </p:extLst>
+  </p:cSld>
+  <p:clrMapOvr>
+    <a:masterClrMapping/>
+  </p:clrMapOvr>
+</p:sld>
+</file>
+
+<file path=ppt/slides/slide11.xml><?xml version="1.0" encoding="utf-8"?>
+<p:sld xmlns:a="http://schemas.openxmlformats.org/drawingml/2006/main" xmlns:r="http://schemas.openxmlformats.org/officeDocument/2006/relationships" xmlns:p="http://schemas.openxmlformats.org/presentationml/2006/main">
+  <p:cSld>
+    <p:bg>
+      <p:bgPr>
+        <a:solidFill>
+          <a:schemeClr val="bg1"/>
+        </a:solidFill>
+        <a:effectLst/>
+      </p:bgPr>
+    </p:bg>
+    <p:spTree>
+      <p:nvGrpSpPr>
+        <p:cNvPr id="1" name="">
+          <a:extLst>
+            <a:ext uri="{FF2B5EF4-FFF2-40B4-BE49-F238E27FC236}">
+              <a16:creationId xmlns:a16="http://schemas.microsoft.com/office/drawing/2014/main" id="{7BB5486A-2C7D-4CB3-E309-21FF9897FBB1}"/>
+            </a:ext>
+          </a:extLst>
+        </p:cNvPr>
+        <p:cNvGrpSpPr/>
+        <p:nvPr/>
+      </p:nvGrpSpPr>
+      <p:grpSpPr>
+        <a:xfrm>
+          <a:off x="0" y="0"/>
+          <a:ext cx="0" cy="0"/>
+          <a:chOff x="0" y="0"/>
+          <a:chExt cx="0" cy="0"/>
+        </a:xfrm>
+      </p:grpSpPr>
+      <p:sp>
+        <p:nvSpPr>
+          <p:cNvPr id="8" name="Rectangle 7">
+            <a:extLst>
+              <a:ext uri="{FF2B5EF4-FFF2-40B4-BE49-F238E27FC236}">
+                <a16:creationId xmlns:a16="http://schemas.microsoft.com/office/drawing/2014/main" id="{A4AC5506-6312-4701-8D3C-40187889A947}"/>
+              </a:ext>
+              <a:ext uri="{C183D7F6-B498-43B3-948B-1728B52AA6E4}">
+                <adec:decorative xmlns:adec="http://schemas.microsoft.com/office/drawing/2017/decorative" val="1"/>
+              </a:ext>
+            </a:extLst>
+          </p:cNvPr>
+          <p:cNvSpPr>
+            <a:spLocks noGrp="1" noRot="1" noChangeAspect="1" noMove="1" noResize="1" noEditPoints="1" noAdjustHandles="1" noChangeArrowheads="1" noChangeShapeType="1" noTextEdit="1"/>
+          </p:cNvSpPr>
+          <p:nvPr>
+            <p:extLst>
+              <p:ext uri="{386F3935-93C4-4BCD-93E2-E3B085C9AB24}">
+                <p16:designElem xmlns:p16="http://schemas.microsoft.com/office/powerpoint/2015/main" val="1"/>
+              </p:ext>
+            </p:extLst>
+          </p:nvPr>
+        </p:nvSpPr>
+        <p:spPr>
+          <a:xfrm>
+            <a:off x="0" y="651752"/>
+            <a:ext cx="9144000" cy="736551"/>
+          </a:xfrm>
+          <a:prstGeom prst="rect">
+            <a:avLst/>
+          </a:prstGeom>
+          <a:solidFill>
+            <a:schemeClr val="tx1"/>
+          </a:solidFill>
+          <a:ln>
+            <a:noFill/>
+          </a:ln>
+        </p:spPr>
+        <p:style>
+          <a:lnRef idx="2">
+            <a:schemeClr val="accent1">
+              <a:shade val="50000"/>
+            </a:schemeClr>
+          </a:lnRef>
+          <a:fillRef idx="1">
+            <a:schemeClr val="accent1"/>
+          </a:fillRef>
+          <a:effectRef idx="0">
+            <a:schemeClr val="accent1"/>
+          </a:effectRef>
+          <a:fontRef idx="minor">
+            <a:schemeClr val="lt1"/>
+          </a:fontRef>
+        </p:style>
+        <p:txBody>
+          <a:bodyPr rtlCol="0" anchor="ctr"/>
+          <a:lstStyle/>
+          <a:p>
+            <a:pPr algn="ctr"/>
+            <a:endParaRPr lang="en-US"/>
+          </a:p>
+        </p:txBody>
+      </p:sp>
+      <p:sp>
+        <p:nvSpPr>
+          <p:cNvPr id="2" name="Title 1">
+            <a:extLst>
+              <a:ext uri="{FF2B5EF4-FFF2-40B4-BE49-F238E27FC236}">
+                <a16:creationId xmlns:a16="http://schemas.microsoft.com/office/drawing/2014/main" id="{E887A502-E9A3-22A2-1607-CC766198F6B0}"/>
+              </a:ext>
+            </a:extLst>
+          </p:cNvPr>
+          <p:cNvSpPr>
+            <a:spLocks noGrp="1"/>
+          </p:cNvSpPr>
+          <p:nvPr>
+            <p:ph type="title"/>
+          </p:nvPr>
+        </p:nvSpPr>
+        <p:spPr>
+          <a:xfrm>
+            <a:off x="417399" y="643467"/>
+            <a:ext cx="8408193" cy="744836"/>
+          </a:xfrm>
+        </p:spPr>
+        <p:txBody>
+          <a:bodyPr vert="horz" lIns="91440" tIns="45720" rIns="91440" bIns="45720" rtlCol="0" anchor="ctr">
+            <a:normAutofit/>
+          </a:bodyPr>
+          <a:lstStyle/>
+          <a:p>
+            <a:pPr defTabSz="914400">
+              <a:lnSpc>
+                <a:spcPct val="90000"/>
+              </a:lnSpc>
+            </a:pPr>
+            <a:r>
+              <a:rPr lang="en-US" sz="2800" kern="1200" dirty="0">
+                <a:solidFill>
+                  <a:schemeClr val="bg1"/>
+                </a:solidFill>
+                <a:latin typeface="+mj-lt"/>
+                <a:ea typeface="+mj-ea"/>
+                <a:cs typeface="+mj-cs"/>
+              </a:rPr>
+              <a:t>Results: Detection Performance</a:t>
+            </a:r>
+          </a:p>
+        </p:txBody>
+      </p:sp>
+      <p:pic>
+        <p:nvPicPr>
+          <p:cNvPr id="4" name="Picture 3">
+            <a:extLst>
+              <a:ext uri="{FF2B5EF4-FFF2-40B4-BE49-F238E27FC236}">
+                <a16:creationId xmlns:a16="http://schemas.microsoft.com/office/drawing/2014/main" id="{32C908D8-FD4A-23AD-FF3A-C520FE2AF206}"/>
+              </a:ext>
+            </a:extLst>
+          </p:cNvPr>
+          <p:cNvPicPr>
+            <a:picLocks noChangeAspect="1"/>
+          </p:cNvPicPr>
+          <p:nvPr/>
+        </p:nvPicPr>
+        <p:blipFill>
+          <a:blip r:embed="rId2"/>
+          <a:stretch>
+            <a:fillRect/>
+          </a:stretch>
+        </p:blipFill>
+        <p:spPr>
+          <a:xfrm>
+            <a:off x="1279602" y="1515378"/>
+            <a:ext cx="6584795" cy="4587767"/>
+          </a:xfrm>
+          <a:prstGeom prst="rect">
+            <a:avLst/>
+          </a:prstGeom>
+        </p:spPr>
+      </p:pic>
+    </p:spTree>
+    <p:extLst>
+      <p:ext uri="{BB962C8B-B14F-4D97-AF65-F5344CB8AC3E}">
+        <p14:creationId xmlns:p14="http://schemas.microsoft.com/office/powerpoint/2010/main" val="2818536614"/>
+      </p:ext>
+    </p:extLst>
+  </p:cSld>
+  <p:clrMapOvr>
+    <a:masterClrMapping/>
+  </p:clrMapOvr>
+</p:sld>
+</file>
+
+<file path=ppt/slides/slide12.xml><?xml version="1.0" encoding="utf-8"?>
+<p:sld xmlns:a="http://schemas.openxmlformats.org/drawingml/2006/main" xmlns:r="http://schemas.openxmlformats.org/officeDocument/2006/relationships" xmlns:p="http://schemas.openxmlformats.org/presentationml/2006/main">
+  <p:cSld>
+    <p:bg>
+      <p:bgPr>
+        <a:solidFill>
+          <a:schemeClr val="bg1"/>
+        </a:solidFill>
+        <a:effectLst/>
+      </p:bgPr>
+    </p:bg>
     <p:spTree>
       <p:nvGrpSpPr>
         <p:cNvPr id="1" name=""/>
@@ -15984,6 +19909,66 @@
           <a:chExt cx="0" cy="0"/>
         </a:xfrm>
       </p:grpSpPr>
+      <p:sp useBgFill="1">
+        <p:nvSpPr>
+          <p:cNvPr id="9" name="Rectangle 8">
+            <a:extLst>
+              <a:ext uri="{FF2B5EF4-FFF2-40B4-BE49-F238E27FC236}">
+                <a16:creationId xmlns:a16="http://schemas.microsoft.com/office/drawing/2014/main" id="{53B021B3-DE93-4AB7-8A18-CF5F1CED88B8}"/>
+              </a:ext>
+              <a:ext uri="{C183D7F6-B498-43B3-948B-1728B52AA6E4}">
+                <adec:decorative xmlns:adec="http://schemas.microsoft.com/office/drawing/2017/decorative" val="1"/>
+              </a:ext>
+            </a:extLst>
+          </p:cNvPr>
+          <p:cNvSpPr>
+            <a:spLocks noGrp="1" noRot="1" noChangeAspect="1" noMove="1" noResize="1" noEditPoints="1" noAdjustHandles="1" noChangeArrowheads="1" noChangeShapeType="1" noTextEdit="1"/>
+          </p:cNvSpPr>
+          <p:nvPr>
+            <p:extLst>
+              <p:ext uri="{386F3935-93C4-4BCD-93E2-E3B085C9AB24}">
+                <p16:designElem xmlns:p16="http://schemas.microsoft.com/office/powerpoint/2015/main" val="1"/>
+              </p:ext>
+            </p:extLst>
+          </p:nvPr>
+        </p:nvSpPr>
+        <p:spPr>
+          <a:xfrm>
+            <a:off x="0" y="0"/>
+            <a:ext cx="9144000" cy="6858000"/>
+          </a:xfrm>
+          <a:prstGeom prst="rect">
+            <a:avLst/>
+          </a:prstGeom>
+          <a:ln>
+            <a:noFill/>
+          </a:ln>
+        </p:spPr>
+        <p:style>
+          <a:lnRef idx="2">
+            <a:schemeClr val="accent1">
+              <a:shade val="50000"/>
+            </a:schemeClr>
+          </a:lnRef>
+          <a:fillRef idx="1">
+            <a:schemeClr val="accent1"/>
+          </a:fillRef>
+          <a:effectRef idx="0">
+            <a:schemeClr val="accent1"/>
+          </a:effectRef>
+          <a:fontRef idx="minor">
+            <a:schemeClr val="lt1"/>
+          </a:fontRef>
+        </p:style>
+        <p:txBody>
+          <a:bodyPr rtlCol="0" anchor="ctr"/>
+          <a:lstStyle/>
+          <a:p>
+            <a:pPr algn="ctr"/>
+            <a:endParaRPr lang="en-US"/>
+          </a:p>
+        </p:txBody>
+      </p:sp>
       <p:sp>
         <p:nvSpPr>
           <p:cNvPr id="2" name="Title 1"/>
@@ -15994,9 +19979,16 @@
             <p:ph type="title"/>
           </p:nvPr>
         </p:nvSpPr>
-        <p:spPr/>
+        <p:spPr>
+          <a:xfrm>
+            <a:off x="630936" y="256032"/>
+            <a:ext cx="7879842" cy="1014984"/>
+          </a:xfrm>
+        </p:spPr>
         <p:txBody>
-          <a:bodyPr/>
+          <a:bodyPr anchor="b">
+            <a:normAutofit/>
+          </a:bodyPr>
           <a:lstStyle/>
           <a:p>
             <a:r>
@@ -16007,104 +19999,172 @@
       </p:sp>
       <p:sp>
         <p:nvSpPr>
-          <p:cNvPr id="3" name="Content Placeholder 2"/>
+          <p:cNvPr id="11" name="Rectangle 10">
+            <a:extLst>
+              <a:ext uri="{FF2B5EF4-FFF2-40B4-BE49-F238E27FC236}">
+                <a16:creationId xmlns:a16="http://schemas.microsoft.com/office/drawing/2014/main" id="{52D502E5-F6B4-4D58-B4AE-FC466FF15EE8}"/>
+              </a:ext>
+              <a:ext uri="{C183D7F6-B498-43B3-948B-1728B52AA6E4}">
+                <adec:decorative xmlns:adec="http://schemas.microsoft.com/office/drawing/2017/decorative" val="1"/>
+              </a:ext>
+            </a:extLst>
+          </p:cNvPr>
           <p:cNvSpPr>
-            <a:spLocks noGrp="1"/>
+            <a:spLocks noGrp="1" noRot="1" noChangeAspect="1" noMove="1" noResize="1" noEditPoints="1" noAdjustHandles="1" noChangeArrowheads="1" noChangeShapeType="1" noTextEdit="1"/>
           </p:cNvSpPr>
           <p:nvPr>
-            <p:ph idx="1"/>
+            <p:extLst>
+              <p:ext uri="{386F3935-93C4-4BCD-93E2-E3B085C9AB24}">
+                <p16:designElem xmlns:p16="http://schemas.microsoft.com/office/powerpoint/2015/main" val="1"/>
+              </p:ext>
+            </p:extLst>
           </p:nvPr>
         </p:nvSpPr>
-        <p:spPr/>
+        <p:spPr>
+          <a:xfrm>
+            <a:off x="649464" y="1634502"/>
+            <a:ext cx="7838694" cy="18288"/>
+          </a:xfrm>
+          <a:prstGeom prst="rect">
+            <a:avLst/>
+          </a:prstGeom>
+          <a:solidFill>
+            <a:srgbClr val="D5D5D5"/>
+          </a:solidFill>
+          <a:ln w="3175">
+            <a:noFill/>
+          </a:ln>
+          <a:effectLst/>
+        </p:spPr>
+        <p:style>
+          <a:lnRef idx="2">
+            <a:schemeClr val="accent1">
+              <a:shade val="50000"/>
+            </a:schemeClr>
+          </a:lnRef>
+          <a:fillRef idx="1">
+            <a:schemeClr val="accent1"/>
+          </a:fillRef>
+          <a:effectRef idx="0">
+            <a:schemeClr val="accent1"/>
+          </a:effectRef>
+          <a:fontRef idx="minor">
+            <a:schemeClr val="lt1"/>
+          </a:fontRef>
+        </p:style>
         <p:txBody>
-          <a:bodyPr>
-            <a:normAutofit fontScale="70000" lnSpcReduction="20000"/>
-          </a:bodyPr>
+          <a:bodyPr rtlCol="0" anchor="ctr"/>
           <a:lstStyle/>
           <a:p>
-            <a:r>
-              <a:rPr lang="en-GB"/>
-              <a:t>Feature reduction techniques, including PCA, </a:t>
-            </a:r>
-            <a:r>
-              <a:rPr lang="en-GB" err="1"/>
-              <a:t>AutoEncoder</a:t>
-            </a:r>
-            <a:r>
-              <a:rPr lang="en-GB"/>
-              <a:t>, and </a:t>
-            </a:r>
-            <a:r>
-              <a:rPr lang="en-GB" err="1"/>
-              <a:t>ResNeXt</a:t>
-            </a:r>
-            <a:r>
-              <a:rPr lang="en-GB"/>
-              <a:t>, generally lead to a decrease in model performance, particularly in terms of accuracy and F1 score.</a:t>
-            </a:r>
-          </a:p>
-          <a:p>
-            <a:r>
-              <a:rPr lang="en-GB"/>
-              <a:t>If</a:t>
-            </a:r>
-            <a:r>
-              <a:rPr lang="zh-CN" altLang="en-US"/>
-              <a:t> </a:t>
-            </a:r>
-            <a:r>
-              <a:rPr lang="en-GB"/>
-              <a:t>a certain degree of performance degradation is acceptable, more aggressive dimensionality reduction can be applied to significantly reduce feature size and computational cost.</a:t>
-            </a:r>
-          </a:p>
-          <a:p>
-            <a:r>
-              <a:rPr lang="en-GB" err="1"/>
-              <a:t>ResNeXt</a:t>
-            </a:r>
-            <a:r>
-              <a:rPr lang="en-GB"/>
-              <a:t> introduces high CPU overhead when applied to low-dimensional flow-level data, without improving accuracy or F1 score, making it unsuitable for deployment on edge devices. In contrast, PCA and </a:t>
-            </a:r>
-            <a:r>
-              <a:rPr lang="en-GB" err="1"/>
-              <a:t>AutoEncoder</a:t>
-            </a:r>
-            <a:r>
-              <a:rPr lang="en-GB"/>
-              <a:t> show no significant resource bottlenecks and are more suitable for edge-based IDS.</a:t>
-            </a:r>
-          </a:p>
-          <a:p>
-            <a:r>
-              <a:rPr lang="en-GB"/>
-              <a:t>Feature reduction reduces performance but improves efficiency; PCA and </a:t>
-            </a:r>
-            <a:r>
-              <a:rPr lang="en-GB" err="1"/>
-              <a:t>AutoEncoder</a:t>
-            </a:r>
-            <a:r>
-              <a:rPr lang="en-GB"/>
-              <a:t> are edge-friendly, while </a:t>
-            </a:r>
-            <a:r>
-              <a:rPr lang="en-GB" err="1"/>
-              <a:t>ResNeXt</a:t>
-            </a:r>
-            <a:r>
-              <a:rPr lang="en-GB"/>
-              <a:t> is computationally expensive and ineffective for low-dimensional data.</a:t>
-            </a:r>
-          </a:p>
-          <a:p>
-            <a:endParaRPr lang="en-GB"/>
-          </a:p>
-          <a:p>
-            <a:endParaRPr lang="en-GB"/>
+            <a:pPr algn="ctr"/>
+            <a:endParaRPr lang="en-US">
+              <a:solidFill>
+                <a:prstClr val="white"/>
+              </a:solidFill>
+              <a:latin typeface="Calibri" panose="020F0502020204030204"/>
+            </a:endParaRPr>
           </a:p>
         </p:txBody>
       </p:sp>
+      <p:sp>
+        <p:nvSpPr>
+          <p:cNvPr id="13" name="Rectangle 12">
+            <a:extLst>
+              <a:ext uri="{FF2B5EF4-FFF2-40B4-BE49-F238E27FC236}">
+                <a16:creationId xmlns:a16="http://schemas.microsoft.com/office/drawing/2014/main" id="{9DECDBF4-02B6-4BB4-B65B-B8107AD6A9E8}"/>
+              </a:ext>
+              <a:ext uri="{C183D7F6-B498-43B3-948B-1728B52AA6E4}">
+                <adec:decorative xmlns:adec="http://schemas.microsoft.com/office/drawing/2017/decorative" val="1"/>
+              </a:ext>
+            </a:extLst>
+          </p:cNvPr>
+          <p:cNvSpPr>
+            <a:spLocks noGrp="1" noRot="1" noChangeAspect="1" noMove="1" noResize="1" noEditPoints="1" noAdjustHandles="1" noChangeArrowheads="1" noChangeShapeType="1" noTextEdit="1"/>
+          </p:cNvSpPr>
+          <p:nvPr>
+            <p:extLst>
+              <p:ext uri="{386F3935-93C4-4BCD-93E2-E3B085C9AB24}">
+                <p16:designElem xmlns:p16="http://schemas.microsoft.com/office/powerpoint/2015/main" val="1"/>
+              </p:ext>
+            </p:extLst>
+          </p:nvPr>
+        </p:nvSpPr>
+        <p:spPr>
+          <a:xfrm flipV="1">
+            <a:off x="630936" y="1538176"/>
+            <a:ext cx="1405092" cy="109814"/>
+          </a:xfrm>
+          <a:prstGeom prst="rect">
+            <a:avLst/>
+          </a:prstGeom>
+          <a:solidFill>
+            <a:schemeClr val="accent2"/>
+          </a:solidFill>
+          <a:ln>
+            <a:noFill/>
+          </a:ln>
+        </p:spPr>
+        <p:style>
+          <a:lnRef idx="2">
+            <a:schemeClr val="accent1">
+              <a:shade val="50000"/>
+            </a:schemeClr>
+          </a:lnRef>
+          <a:fillRef idx="1">
+            <a:schemeClr val="accent1"/>
+          </a:fillRef>
+          <a:effectRef idx="0">
+            <a:schemeClr val="accent1"/>
+          </a:effectRef>
+          <a:fontRef idx="minor">
+            <a:schemeClr val="lt1"/>
+          </a:fontRef>
+        </p:style>
+        <p:txBody>
+          <a:bodyPr rtlCol="0" anchor="ctr"/>
+          <a:lstStyle/>
+          <a:p>
+            <a:pPr algn="ctr"/>
+            <a:endParaRPr lang="en-US">
+              <a:solidFill>
+                <a:prstClr val="white"/>
+              </a:solidFill>
+              <a:latin typeface="Calibri" panose="020F0502020204030204"/>
+            </a:endParaRPr>
+          </a:p>
+        </p:txBody>
+      </p:sp>
+      <p:graphicFrame>
+        <p:nvGraphicFramePr>
+          <p:cNvPr id="5" name="Content Placeholder 2">
+            <a:extLst>
+              <a:ext uri="{FF2B5EF4-FFF2-40B4-BE49-F238E27FC236}">
+                <a16:creationId xmlns:a16="http://schemas.microsoft.com/office/drawing/2014/main" id="{8229F03F-070E-65BB-A314-B6D801640DE9}"/>
+              </a:ext>
+            </a:extLst>
+          </p:cNvPr>
+          <p:cNvGraphicFramePr>
+            <a:graphicFrameLocks noGrp="1"/>
+          </p:cNvGraphicFramePr>
+          <p:nvPr>
+            <p:ph idx="1"/>
+            <p:extLst>
+              <p:ext uri="{D42A27DB-BD31-4B8C-83A1-F6EECF244321}">
+                <p14:modId xmlns:p14="http://schemas.microsoft.com/office/powerpoint/2010/main" val="3464032770"/>
+              </p:ext>
+            </p:extLst>
+          </p:nvPr>
+        </p:nvGraphicFramePr>
+        <p:xfrm>
+          <a:off x="628650" y="1926266"/>
+          <a:ext cx="7886700" cy="4357524"/>
+        </p:xfrm>
+        <a:graphic>
+          <a:graphicData uri="http://schemas.openxmlformats.org/drawingml/2006/diagram">
+            <dgm:relIds xmlns:dgm="http://schemas.openxmlformats.org/drawingml/2006/diagram" xmlns:r="http://schemas.openxmlformats.org/officeDocument/2006/relationships" r:dm="rId3" r:lo="rId4" r:qs="rId5" r:cs="rId6"/>
+          </a:graphicData>
+        </a:graphic>
+      </p:graphicFrame>
     </p:spTree>
   </p:cSld>
   <p:clrMapOvr>
@@ -16113,7 +20173,7 @@
 </p:sld>
 </file>
 
-<file path=ppt/slides/slide11.xml><?xml version="1.0" encoding="utf-8"?>
+<file path=ppt/slides/slide13.xml><?xml version="1.0" encoding="utf-8"?>
 <p:sld xmlns:a="http://schemas.openxmlformats.org/drawingml/2006/main" xmlns:r="http://schemas.openxmlformats.org/officeDocument/2006/relationships" xmlns:p="http://schemas.openxmlformats.org/presentationml/2006/main">
   <p:cSld>
     <p:spTree>
@@ -32610,7 +36670,7 @@
         <p:spPr>
           <a:xfrm>
             <a:off x="457200" y="4430486"/>
-            <a:ext cx="5137266" cy="2585323"/>
+            <a:ext cx="5137266" cy="2031325"/>
           </a:xfrm>
           <a:prstGeom prst="rect">
             <a:avLst/>
@@ -32692,8 +36752,14 @@
             </a:pPr>
             <a:r>
               <a:rPr lang="en-GB" dirty="0"/>
-              <a:t>Autoencoder / </a:t>
+              <a:t>Autoencoder</a:t>
             </a:r>
+          </a:p>
+          <a:p>
+            <a:pPr marL="742950" lvl="1" indent="-285750">
+              <a:buFont typeface="Arial" panose="020B0604020202020204" pitchFamily="34" charset="0"/>
+              <a:buChar char="•"/>
+            </a:pPr>
             <a:r>
               <a:rPr lang="en-GB" dirty="0" err="1"/>
               <a:t>ResNeXt</a:t>
@@ -32706,19 +36772,14 @@
               <a:rPr lang="en-GB" dirty="0"/>
               <a:t> (deep representation)</a:t>
             </a:r>
+            <a:endParaRPr lang="en-US" dirty="0"/>
           </a:p>
           <a:p>
             <a:pPr marL="742950" lvl="1" indent="-285750">
               <a:buFont typeface="Arial" panose="020B0604020202020204" pitchFamily="34" charset="0"/>
               <a:buChar char="•"/>
             </a:pPr>
-            <a:r>
-              <a:rPr lang="en-GB" dirty="0"/>
-              <a:t>Goal: reduce features while preserving information</a:t>
-            </a:r>
-          </a:p>
-          <a:p>
-            <a:endParaRPr lang="en-US" dirty="0"/>
+            <a:endParaRPr lang="en-GB" dirty="0"/>
           </a:p>
         </p:txBody>
       </p:sp>
@@ -33190,6 +37251,14 @@
 <file path=ppt/slides/slide9.xml><?xml version="1.0" encoding="utf-8"?>
 <p:sld xmlns:a="http://schemas.openxmlformats.org/drawingml/2006/main" xmlns:r="http://schemas.openxmlformats.org/officeDocument/2006/relationships" xmlns:p="http://schemas.openxmlformats.org/presentationml/2006/main">
   <p:cSld>
+    <p:bg>
+      <p:bgPr>
+        <a:solidFill>
+          <a:schemeClr val="bg1"/>
+        </a:solidFill>
+        <a:effectLst/>
+      </p:bgPr>
+    </p:bg>
     <p:spTree>
       <p:nvGrpSpPr>
         <p:cNvPr id="1" name=""/>
@@ -33206,6 +37275,69 @@
       </p:grpSpPr>
       <p:sp>
         <p:nvSpPr>
+          <p:cNvPr id="9" name="Rectangle 8">
+            <a:extLst>
+              <a:ext uri="{FF2B5EF4-FFF2-40B4-BE49-F238E27FC236}">
+                <a16:creationId xmlns:a16="http://schemas.microsoft.com/office/drawing/2014/main" id="{A4AC5506-6312-4701-8D3C-40187889A947}"/>
+              </a:ext>
+              <a:ext uri="{C183D7F6-B498-43B3-948B-1728B52AA6E4}">
+                <adec:decorative xmlns:adec="http://schemas.microsoft.com/office/drawing/2017/decorative" val="1"/>
+              </a:ext>
+            </a:extLst>
+          </p:cNvPr>
+          <p:cNvSpPr>
+            <a:spLocks noGrp="1" noRot="1" noChangeAspect="1" noMove="1" noResize="1" noEditPoints="1" noAdjustHandles="1" noChangeArrowheads="1" noChangeShapeType="1" noTextEdit="1"/>
+          </p:cNvSpPr>
+          <p:nvPr>
+            <p:extLst>
+              <p:ext uri="{386F3935-93C4-4BCD-93E2-E3B085C9AB24}">
+                <p16:designElem xmlns:p16="http://schemas.microsoft.com/office/powerpoint/2015/main" val="1"/>
+              </p:ext>
+            </p:extLst>
+          </p:nvPr>
+        </p:nvSpPr>
+        <p:spPr>
+          <a:xfrm>
+            <a:off x="0" y="651752"/>
+            <a:ext cx="9144000" cy="736551"/>
+          </a:xfrm>
+          <a:prstGeom prst="rect">
+            <a:avLst/>
+          </a:prstGeom>
+          <a:solidFill>
+            <a:schemeClr val="tx1"/>
+          </a:solidFill>
+          <a:ln>
+            <a:noFill/>
+          </a:ln>
+        </p:spPr>
+        <p:style>
+          <a:lnRef idx="2">
+            <a:schemeClr val="accent1">
+              <a:shade val="50000"/>
+            </a:schemeClr>
+          </a:lnRef>
+          <a:fillRef idx="1">
+            <a:schemeClr val="accent1"/>
+          </a:fillRef>
+          <a:effectRef idx="0">
+            <a:schemeClr val="accent1"/>
+          </a:effectRef>
+          <a:fontRef idx="minor">
+            <a:schemeClr val="lt1"/>
+          </a:fontRef>
+        </p:style>
+        <p:txBody>
+          <a:bodyPr rtlCol="0" anchor="ctr"/>
+          <a:lstStyle/>
+          <a:p>
+            <a:pPr algn="ctr"/>
+            <a:endParaRPr lang="en-US"/>
+          </a:p>
+        </p:txBody>
+      </p:sp>
+      <p:sp>
+        <p:nvSpPr>
           <p:cNvPr id="2" name="Title 1"/>
           <p:cNvSpPr>
             <a:spLocks noGrp="1"/>
@@ -33214,51 +37346,67 @@
             <p:ph type="title"/>
           </p:nvPr>
         </p:nvSpPr>
-        <p:spPr/>
+        <p:spPr>
+          <a:xfrm>
+            <a:off x="417399" y="643467"/>
+            <a:ext cx="8408193" cy="744836"/>
+          </a:xfrm>
+        </p:spPr>
         <p:txBody>
-          <a:bodyPr/>
+          <a:bodyPr vert="horz" lIns="91440" tIns="45720" rIns="91440" bIns="45720" rtlCol="0" anchor="ctr">
+            <a:normAutofit/>
+          </a:bodyPr>
           <a:lstStyle/>
           <a:p>
+            <a:pPr defTabSz="914400">
+              <a:lnSpc>
+                <a:spcPct val="90000"/>
+              </a:lnSpc>
+            </a:pPr>
             <a:r>
+              <a:rPr lang="en-US" sz="2800" kern="1200" dirty="0">
+                <a:solidFill>
+                  <a:schemeClr val="bg1"/>
+                </a:solidFill>
+                <a:latin typeface="+mj-lt"/>
+                <a:ea typeface="+mj-ea"/>
+                <a:cs typeface="+mj-cs"/>
+              </a:rPr>
               <a:t>Results: Detection Performance</a:t>
             </a:r>
           </a:p>
         </p:txBody>
       </p:sp>
-      <p:sp>
-        <p:nvSpPr>
-          <p:cNvPr id="3" name="Content Placeholder 2"/>
-          <p:cNvSpPr>
-            <a:spLocks noGrp="1"/>
-          </p:cNvSpPr>
-          <p:nvPr>
-            <p:ph idx="1"/>
-          </p:nvPr>
-        </p:nvSpPr>
-        <p:spPr/>
-        <p:txBody>
-          <a:bodyPr/>
-          <a:lstStyle/>
-          <a:p>
-            <a:r>
-              <a:rPr lang="en-GB"/>
-              <a:t>Compare FS, PCA, Autoencoder</a:t>
-            </a:r>
-          </a:p>
-          <a:p>
-            <a:r>
-              <a:rPr lang="en-GB"/>
-              <a:t>Accuracy / Precision / Recall results</a:t>
-            </a:r>
-          </a:p>
-          <a:p>
-            <a:r>
-              <a:rPr lang="en-GB"/>
-              <a:t>Performance differences observed</a:t>
-            </a:r>
-          </a:p>
-        </p:txBody>
-      </p:sp>
+      <p:pic>
+        <p:nvPicPr>
+          <p:cNvPr id="4" name="Picture 3">
+            <a:extLst>
+              <a:ext uri="{FF2B5EF4-FFF2-40B4-BE49-F238E27FC236}">
+                <a16:creationId xmlns:a16="http://schemas.microsoft.com/office/drawing/2014/main" id="{DAA2CFB1-11FC-6602-E404-BCF9B9E77477}"/>
+              </a:ext>
+            </a:extLst>
+          </p:cNvPr>
+          <p:cNvPicPr>
+            <a:picLocks noChangeAspect="1"/>
+          </p:cNvPicPr>
+          <p:nvPr/>
+        </p:nvPicPr>
+        <p:blipFill>
+          <a:blip r:embed="rId2"/>
+          <a:stretch>
+            <a:fillRect/>
+          </a:stretch>
+        </p:blipFill>
+        <p:spPr>
+          <a:xfrm>
+            <a:off x="1044507" y="1555867"/>
+            <a:ext cx="7153975" cy="4989898"/>
+          </a:xfrm>
+          <a:prstGeom prst="rect">
+            <a:avLst/>
+          </a:prstGeom>
+        </p:spPr>
+      </p:pic>
     </p:spTree>
   </p:cSld>
   <p:clrMapOvr>

</xml_diff>